<commit_message>
Add settings and presenter mode
- Settings panel (gear in the toolbar): pen colours from the 10 UZH colours (up to 10,
  in the order picked), highlighter colours from the six UZH accents, laser in UZH berry
  or dark green; saved per device, stored values snapped to the nearest UZH colour
- Presenter mode: projector window kept in sync over BroadcastChannel (PDF, page, ink,
  live strokes, laser, zoom); greyed out where it cannot work, switched off with an
  explanation if the projector window does not respond
- Presenter chip with connection status, timer and next-slide preview
- Guide deck: settings and projector buttons, laser colours, presenter-mode steps

Co-Authored-By: Claude Opus 5.5 <noreply@anthropic.com>
Claude-Session: https://claude.ai/code/session_01V4q6MUNQzbvGfyJNvW5Le1
</commit_message>
<xml_diff>
--- a/source/guide-deck.pptx
+++ b/source/guide-deck.pptx
@@ -22,6 +22,7 @@
     <p:sldId id="393" r:id="rId22"/>
     <p:sldId id="394" r:id="rId23"/>
     <p:sldId id="395" r:id="rId24"/>
+    <p:sldId id="396" r:id="rId25"/>
   </p:sldIdLst>
   <p:sldSz cx="12192000" cy="6858000"/>
   <p:notesSz cx="6858000" cy="9144000"/>
@@ -9694,58 +9695,77 @@
           <a:lstStyle/>
           <a:p>
             <a:r>
-              <a:t>Save keeps your notes</a:t>
-            </a:r>
-          </a:p>
-        </p:txBody>
-      </p:sp>
-      <p:sp>
-        <p:nvSpPr>
-          <p:cNvPr id="3" name="Rectangle 2"/>
-          <p:cNvSpPr/>
-          <p:nvPr/>
-        </p:nvSpPr>
-        <p:spPr>
-          <a:xfrm>
-            <a:off x="271461" y="870744"/>
-            <a:ext cx="11650663" cy="5150545"/>
-          </a:xfrm>
-          <a:prstGeom prst="rect">
-            <a:avLst/>
-          </a:prstGeom>
-          <a:solidFill>
-            <a:srgbClr val="0028A5"/>
-          </a:solidFill>
-          <a:ln>
-            <a:noFill/>
-          </a:ln>
-          <a:effectLst/>
-        </p:spPr>
-        <p:style>
-          <a:lnRef idx="1">
-            <a:schemeClr val="accent1"/>
-          </a:lnRef>
-          <a:fillRef idx="3">
-            <a:schemeClr val="accent1"/>
-          </a:fillRef>
-          <a:effectRef idx="2">
-            <a:schemeClr val="accent1"/>
-          </a:effectRef>
-          <a:fontRef idx="minor">
-            <a:schemeClr val="lt1"/>
-          </a:fontRef>
-        </p:style>
-        <p:txBody>
-          <a:bodyPr rtlCol="0" anchor="ctr"/>
-          <a:lstStyle/>
-          <a:p>
-            <a:pPr algn="ctr"/>
+              <a:t>Two screens: presenter mode</a:t>
+            </a:r>
+          </a:p>
+        </p:txBody>
+      </p:sp>
+      <p:sp>
+        <p:nvSpPr>
+          <p:cNvPr id="3" name="Text Placeholder 2"/>
+          <p:cNvSpPr>
+            <a:spLocks noGrp="1"/>
+          </p:cNvSpPr>
+          <p:nvPr>
+            <p:ph type="body" idx="20"/>
+          </p:nvPr>
+        </p:nvSpPr>
+        <p:spPr/>
+        <p:txBody>
+          <a:bodyPr/>
+          <a:lstStyle/>
+          <a:p>
+            <a:r>
+              <a:t>1. Turn on presenter mode in Settings (Safari, iPad with M1 chip or later)</a:t>
+            </a:r>
+          </a:p>
+        </p:txBody>
+      </p:sp>
+      <p:sp>
+        <p:nvSpPr>
+          <p:cNvPr id="4" name="Text Placeholder 3"/>
+          <p:cNvSpPr>
+            <a:spLocks noGrp="1"/>
+          </p:cNvSpPr>
+          <p:nvPr>
+            <p:ph type="body" idx="21"/>
+          </p:nvPr>
+        </p:nvSpPr>
+        <p:spPr/>
+        <p:txBody>
+          <a:bodyPr/>
+          <a:lstStyle/>
+          <a:p>
+            <a:r>
+              <a:t>2. Drag the new projector tab out into its own window, onto the display</a:t>
+            </a:r>
+          </a:p>
+        </p:txBody>
+      </p:sp>
+      <p:sp>
+        <p:nvSpPr>
+          <p:cNvPr id="5" name="Text Placeholder 4"/>
+          <p:cNvSpPr>
+            <a:spLocks noGrp="1"/>
+          </p:cNvSpPr>
+          <p:nvPr>
+            <p:ph type="body" idx="22"/>
+          </p:nvPr>
+        </p:nvSpPr>
+        <p:spPr/>
+        <p:txBody>
+          <a:bodyPr/>
+          <a:lstStyle/>
+          <a:p>
+            <a:r>
+              <a:t>3. Tap the projector window to fill the screen</a:t>
+            </a:r>
           </a:p>
         </p:txBody>
       </p:sp>
       <p:pic>
         <p:nvPicPr>
-          <p:cNvPr id="4" name="Picture 3" descr="save-w.png"/>
+          <p:cNvPr id="6" name="Picture 5" descr="settings-w.png"/>
           <p:cNvPicPr>
             <a:picLocks noChangeAspect="1"/>
           </p:cNvPicPr>
@@ -9759,78 +9779,62 @@
         </p:blipFill>
         <p:spPr>
           <a:xfrm>
-            <a:off x="1371461" y="2106875"/>
-            <a:ext cx="2678283" cy="2678283"/>
+            <a:off x="1413179" y="1770744"/>
+            <a:ext cx="1500000" cy="1500000"/>
           </a:xfrm>
           <a:prstGeom prst="rect">
             <a:avLst/>
           </a:prstGeom>
         </p:spPr>
       </p:pic>
-      <p:sp>
-        <p:nvSpPr>
-          <p:cNvPr id="5" name="TextBox 4"/>
-          <p:cNvSpPr txBox="1"/>
+      <p:pic>
+        <p:nvPicPr>
+          <p:cNvPr id="7" name="Picture 6" descr="screen-w.png"/>
+          <p:cNvPicPr>
+            <a:picLocks noChangeAspect="1"/>
+          </p:cNvPicPr>
           <p:nvPr/>
-        </p:nvSpPr>
-        <p:spPr>
-          <a:xfrm>
-            <a:off x="4949744" y="870744"/>
-            <a:ext cx="6172380" cy="5150545"/>
+        </p:nvPicPr>
+        <p:blipFill>
+          <a:blip r:embed="rId3"/>
+          <a:stretch>
+            <a:fillRect/>
+          </a:stretch>
+        </p:blipFill>
+        <p:spPr>
+          <a:xfrm>
+            <a:off x="5351252" y="1770744"/>
+            <a:ext cx="1500000" cy="1500000"/>
           </a:xfrm>
           <a:prstGeom prst="rect">
             <a:avLst/>
           </a:prstGeom>
-          <a:noFill/>
-        </p:spPr>
-        <p:txBody>
-          <a:bodyPr wrap="square" anchor="ctr" lIns="0" rIns="0" tIns="0" bIns="0">
-            <a:spAutoFit/>
-          </a:bodyPr>
-          <a:lstStyle/>
-          <a:p>
-            <a:pPr algn="l"/>
-            <a:r>
-              <a:rPr sz="2800" b="1">
-                <a:solidFill>
-                  <a:srgbClr val="FFFFFF"/>
-                </a:solidFill>
-              </a:rPr>
-              <a:t>Save writes your ink into a new PDF</a:t>
-            </a:r>
-          </a:p>
-          <a:p>
-            <a:pPr algn="l">
-              <a:spcBef>
-                <a:spcPts val="600"/>
-              </a:spcBef>
-            </a:pPr>
-            <a:r>
-              <a:rPr sz="2000" b="0">
-                <a:solidFill>
-                  <a:srgbClr val="FFFFFF"/>
-                </a:solidFill>
-              </a:rPr>
-              <a:t>On iPad, choose Save to Files and pick a folder.</a:t>
-            </a:r>
-          </a:p>
-          <a:p>
-            <a:pPr algn="l">
-              <a:spcBef>
-                <a:spcPts val="600"/>
-              </a:spcBef>
-            </a:pPr>
-            <a:r>
-              <a:rPr sz="2000" b="0">
-                <a:solidFill>
-                  <a:srgbClr val="FFFFFF"/>
-                </a:solidFill>
-              </a:rPr>
-              <a:t>Try it: circle something on this slide, then tap Save.</a:t>
-            </a:r>
-          </a:p>
-        </p:txBody>
-      </p:sp>
+        </p:spPr>
+      </p:pic>
+      <p:pic>
+        <p:nvPicPr>
+          <p:cNvPr id="8" name="Picture 7" descr="fs-w.png"/>
+          <p:cNvPicPr>
+            <a:picLocks noChangeAspect="1"/>
+          </p:cNvPicPr>
+          <p:nvPr/>
+        </p:nvPicPr>
+        <p:blipFill>
+          <a:blip r:embed="rId4"/>
+          <a:stretch>
+            <a:fillRect/>
+          </a:stretch>
+        </p:blipFill>
+        <p:spPr>
+          <a:xfrm>
+            <a:off x="9289325" y="1770744"/>
+            <a:ext cx="1500000" cy="1500000"/>
+          </a:xfrm>
+          <a:prstGeom prst="rect">
+            <a:avLst/>
+          </a:prstGeom>
+        </p:spPr>
+      </p:pic>
     </p:spTree>
   </p:cSld>
   <p:clrMapOvr>
@@ -9865,6 +9869,177 @@
           <a:lstStyle/>
           <a:p>
             <a:r>
+              <a:t>Save keeps your notes</a:t>
+            </a:r>
+          </a:p>
+        </p:txBody>
+      </p:sp>
+      <p:sp>
+        <p:nvSpPr>
+          <p:cNvPr id="3" name="Rectangle 2"/>
+          <p:cNvSpPr/>
+          <p:nvPr/>
+        </p:nvSpPr>
+        <p:spPr>
+          <a:xfrm>
+            <a:off x="271461" y="870744"/>
+            <a:ext cx="11650663" cy="5150545"/>
+          </a:xfrm>
+          <a:prstGeom prst="rect">
+            <a:avLst/>
+          </a:prstGeom>
+          <a:solidFill>
+            <a:srgbClr val="0028A5"/>
+          </a:solidFill>
+          <a:ln>
+            <a:noFill/>
+          </a:ln>
+          <a:effectLst/>
+        </p:spPr>
+        <p:style>
+          <a:lnRef idx="1">
+            <a:schemeClr val="accent1"/>
+          </a:lnRef>
+          <a:fillRef idx="3">
+            <a:schemeClr val="accent1"/>
+          </a:fillRef>
+          <a:effectRef idx="2">
+            <a:schemeClr val="accent1"/>
+          </a:effectRef>
+          <a:fontRef idx="minor">
+            <a:schemeClr val="lt1"/>
+          </a:fontRef>
+        </p:style>
+        <p:txBody>
+          <a:bodyPr rtlCol="0" anchor="ctr"/>
+          <a:lstStyle/>
+          <a:p>
+            <a:pPr algn="ctr"/>
+          </a:p>
+        </p:txBody>
+      </p:sp>
+      <p:pic>
+        <p:nvPicPr>
+          <p:cNvPr id="4" name="Picture 3" descr="save-w.png"/>
+          <p:cNvPicPr>
+            <a:picLocks noChangeAspect="1"/>
+          </p:cNvPicPr>
+          <p:nvPr/>
+        </p:nvPicPr>
+        <p:blipFill>
+          <a:blip r:embed="rId2"/>
+          <a:stretch>
+            <a:fillRect/>
+          </a:stretch>
+        </p:blipFill>
+        <p:spPr>
+          <a:xfrm>
+            <a:off x="1371461" y="2106875"/>
+            <a:ext cx="2678283" cy="2678283"/>
+          </a:xfrm>
+          <a:prstGeom prst="rect">
+            <a:avLst/>
+          </a:prstGeom>
+        </p:spPr>
+      </p:pic>
+      <p:sp>
+        <p:nvSpPr>
+          <p:cNvPr id="5" name="TextBox 4"/>
+          <p:cNvSpPr txBox="1"/>
+          <p:nvPr/>
+        </p:nvSpPr>
+        <p:spPr>
+          <a:xfrm>
+            <a:off x="4949744" y="870744"/>
+            <a:ext cx="6172380" cy="5150545"/>
+          </a:xfrm>
+          <a:prstGeom prst="rect">
+            <a:avLst/>
+          </a:prstGeom>
+          <a:noFill/>
+        </p:spPr>
+        <p:txBody>
+          <a:bodyPr wrap="square" anchor="ctr" lIns="0" rIns="0" tIns="0" bIns="0">
+            <a:spAutoFit/>
+          </a:bodyPr>
+          <a:lstStyle/>
+          <a:p>
+            <a:pPr algn="l"/>
+            <a:r>
+              <a:rPr sz="2800" b="1">
+                <a:solidFill>
+                  <a:srgbClr val="FFFFFF"/>
+                </a:solidFill>
+              </a:rPr>
+              <a:t>Save writes your ink into a new PDF</a:t>
+            </a:r>
+          </a:p>
+          <a:p>
+            <a:pPr algn="l">
+              <a:spcBef>
+                <a:spcPts val="600"/>
+              </a:spcBef>
+            </a:pPr>
+            <a:r>
+              <a:rPr sz="2000" b="0">
+                <a:solidFill>
+                  <a:srgbClr val="FFFFFF"/>
+                </a:solidFill>
+              </a:rPr>
+              <a:t>On iPad, choose Save to Files and pick a folder.</a:t>
+            </a:r>
+          </a:p>
+          <a:p>
+            <a:pPr algn="l">
+              <a:spcBef>
+                <a:spcPts val="600"/>
+              </a:spcBef>
+            </a:pPr>
+            <a:r>
+              <a:rPr sz="2000" b="0">
+                <a:solidFill>
+                  <a:srgbClr val="FFFFFF"/>
+                </a:solidFill>
+              </a:rPr>
+              <a:t>Try it: circle something on this slide, then tap Save.</a:t>
+            </a:r>
+          </a:p>
+        </p:txBody>
+      </p:sp>
+    </p:spTree>
+  </p:cSld>
+  <p:clrMapOvr>
+    <a:masterClrMapping/>
+  </p:clrMapOvr>
+</p:sld>
+</file>
+
+<file path=ppt/slides/slide12.xml><?xml version="1.0" encoding="utf-8"?>
+<p:sld xmlns:a="http://schemas.openxmlformats.org/drawingml/2006/main" xmlns:p="http://schemas.openxmlformats.org/presentationml/2006/main" xmlns:r="http://schemas.openxmlformats.org/officeDocument/2006/relationships">
+  <p:cSld>
+    <p:spTree>
+      <p:nvGrpSpPr>
+        <p:cNvPr id="1" name=""/>
+        <p:cNvGrpSpPr/>
+        <p:nvPr/>
+      </p:nvGrpSpPr>
+      <p:grpSpPr/>
+      <p:sp>
+        <p:nvSpPr>
+          <p:cNvPr id="2" name="Title 1"/>
+          <p:cNvSpPr>
+            <a:spLocks noGrp="1"/>
+          </p:cNvSpPr>
+          <p:nvPr>
+            <p:ph type="title"/>
+          </p:nvPr>
+        </p:nvSpPr>
+        <p:spPr/>
+        <p:txBody>
+          <a:bodyPr/>
+          <a:lstStyle/>
+          <a:p>
+            <a:r>
               <a:t>Open your own PDF from the toolbar to begin</a:t>
             </a:r>
           </a:p>
@@ -11701,7 +11876,7 @@
                   <a:srgbClr val="555B6B"/>
                 </a:solidFill>
               </a:rPr>
-              <a:t>Pressure-sensitive ink in UZH colours.</a:t>
+              <a:t>Pressure-sensitive ink, up to 10 UZH colours.</a:t>
             </a:r>
           </a:p>
         </p:txBody>
@@ -12084,7 +12259,7 @@
                   <a:srgbClr val="555B6B"/>
                 </a:solidFill>
               </a:rPr>
-              <a:t>Transparent marks over text and figures.</a:t>
+              <a:t>Transparent marks in the six UZH accent colours.</a:t>
             </a:r>
           </a:p>
         </p:txBody>
@@ -12421,14 +12596,102 @@
                   <a:srgbClr val="555B6B"/>
                 </a:solidFill>
               </a:rPr>
-              <a:t>A red trail that fades away: points without marking.</a:t>
-            </a:r>
-          </a:p>
-        </p:txBody>
-      </p:sp>
-      <p:sp>
-        <p:nvSpPr>
-          <p:cNvPr id="22" name="Rectangle 21"/>
+              <a:t>A fading trail that points without marking.</a:t>
+            </a:r>
+          </a:p>
+        </p:txBody>
+      </p:sp>
+      <p:sp>
+        <p:nvSpPr>
+          <p:cNvPr id="22" name="Oval 21"/>
+          <p:cNvSpPr/>
+          <p:nvPr/>
+        </p:nvSpPr>
+        <p:spPr>
+          <a:xfrm>
+            <a:off x="6771461" y="3849834"/>
+            <a:ext cx="480000" cy="480000"/>
+          </a:xfrm>
+          <a:prstGeom prst="ellipse">
+            <a:avLst/>
+          </a:prstGeom>
+          <a:solidFill>
+            <a:srgbClr val="BF0D3E"/>
+          </a:solidFill>
+          <a:ln>
+            <a:noFill/>
+          </a:ln>
+          <a:effectLst/>
+        </p:spPr>
+        <p:style>
+          <a:lnRef idx="1">
+            <a:schemeClr val="accent1"/>
+          </a:lnRef>
+          <a:fillRef idx="3">
+            <a:schemeClr val="accent1"/>
+          </a:fillRef>
+          <a:effectRef idx="2">
+            <a:schemeClr val="accent1"/>
+          </a:effectRef>
+          <a:fontRef idx="minor">
+            <a:schemeClr val="lt1"/>
+          </a:fontRef>
+        </p:style>
+        <p:txBody>
+          <a:bodyPr rtlCol="0" anchor="ctr"/>
+          <a:lstStyle/>
+          <a:p>
+            <a:pPr algn="ctr"/>
+          </a:p>
+        </p:txBody>
+      </p:sp>
+      <p:sp>
+        <p:nvSpPr>
+          <p:cNvPr id="23" name="Oval 22"/>
+          <p:cNvSpPr/>
+          <p:nvPr/>
+        </p:nvSpPr>
+        <p:spPr>
+          <a:xfrm>
+            <a:off x="7421461" y="3849834"/>
+            <a:ext cx="480000" cy="480000"/>
+          </a:xfrm>
+          <a:prstGeom prst="ellipse">
+            <a:avLst/>
+          </a:prstGeom>
+          <a:solidFill>
+            <a:srgbClr val="4E6B12"/>
+          </a:solidFill>
+          <a:ln>
+            <a:noFill/>
+          </a:ln>
+          <a:effectLst/>
+        </p:spPr>
+        <p:style>
+          <a:lnRef idx="1">
+            <a:schemeClr val="accent1"/>
+          </a:lnRef>
+          <a:fillRef idx="3">
+            <a:schemeClr val="accent1"/>
+          </a:fillRef>
+          <a:effectRef idx="2">
+            <a:schemeClr val="accent1"/>
+          </a:effectRef>
+          <a:fontRef idx="minor">
+            <a:schemeClr val="lt1"/>
+          </a:fontRef>
+        </p:style>
+        <p:txBody>
+          <a:bodyPr rtlCol="0" anchor="ctr"/>
+          <a:lstStyle/>
+          <a:p>
+            <a:pPr algn="ctr"/>
+          </a:p>
+        </p:txBody>
+      </p:sp>
+      <p:sp>
+        <p:nvSpPr>
+          <p:cNvPr id="24" name="Rectangle 23"/>
           <p:cNvSpPr/>
           <p:nvPr/>
         </p:nvSpPr>
@@ -12472,7 +12735,7 @@
       </p:sp>
       <p:pic>
         <p:nvPicPr>
-          <p:cNvPr id="23" name="Picture 22" descr="eraser.png"/>
+          <p:cNvPr id="25" name="Picture 24" descr="eraser.png"/>
           <p:cNvPicPr>
             <a:picLocks noChangeAspect="1"/>
           </p:cNvPicPr>
@@ -12496,7 +12759,7 @@
       </p:pic>
       <p:sp>
         <p:nvSpPr>
-          <p:cNvPr id="24" name="TextBox 23"/>
+          <p:cNvPr id="26" name="TextBox 25"/>
           <p:cNvSpPr txBox="1"/>
           <p:nvPr/>
         </p:nvSpPr>
@@ -12598,8 +12861,8 @@
         </p:blipFill>
         <p:spPr>
           <a:xfrm>
-            <a:off x="271461" y="1194562"/>
-            <a:ext cx="640000" cy="640000"/>
+            <a:off x="271461" y="1085798"/>
+            <a:ext cx="600000" cy="600000"/>
           </a:xfrm>
           <a:prstGeom prst="rect">
             <a:avLst/>
@@ -12614,8 +12877,8 @@
         </p:nvSpPr>
         <p:spPr>
           <a:xfrm>
-            <a:off x="1921461" y="1174562"/>
-            <a:ext cx="3975331" cy="640000"/>
+            <a:off x="1841461" y="1065798"/>
+            <a:ext cx="4055331" cy="600000"/>
           </a:xfrm>
           <a:prstGeom prst="rect">
             <a:avLst/>
@@ -12671,8 +12934,8 @@
         </p:blipFill>
         <p:spPr>
           <a:xfrm>
-            <a:off x="271461" y="2482198"/>
-            <a:ext cx="640000" cy="640000"/>
+            <a:off x="271461" y="2115907"/>
+            <a:ext cx="600000" cy="600000"/>
           </a:xfrm>
           <a:prstGeom prst="rect">
             <a:avLst/>
@@ -12695,8 +12958,8 @@
         </p:blipFill>
         <p:spPr>
           <a:xfrm>
-            <a:off x="1001461" y="2482198"/>
-            <a:ext cx="640000" cy="640000"/>
+            <a:off x="961461" y="2115907"/>
+            <a:ext cx="600000" cy="600000"/>
           </a:xfrm>
           <a:prstGeom prst="rect">
             <a:avLst/>
@@ -12711,8 +12974,8 @@
         </p:nvSpPr>
         <p:spPr>
           <a:xfrm>
-            <a:off x="1921461" y="2462198"/>
-            <a:ext cx="3975331" cy="640000"/>
+            <a:off x="1841461" y="2095907"/>
+            <a:ext cx="4055331" cy="600000"/>
           </a:xfrm>
           <a:prstGeom prst="rect">
             <a:avLst/>
@@ -12768,8 +13031,8 @@
         </p:blipFill>
         <p:spPr>
           <a:xfrm>
-            <a:off x="271461" y="3769834"/>
-            <a:ext cx="640000" cy="640000"/>
+            <a:off x="271461" y="3146016"/>
+            <a:ext cx="600000" cy="600000"/>
           </a:xfrm>
           <a:prstGeom prst="rect">
             <a:avLst/>
@@ -12784,8 +13047,8 @@
         </p:nvSpPr>
         <p:spPr>
           <a:xfrm>
-            <a:off x="1921461" y="3749834"/>
-            <a:ext cx="3975331" cy="640000"/>
+            <a:off x="1841461" y="3126016"/>
+            <a:ext cx="4055331" cy="600000"/>
           </a:xfrm>
           <a:prstGeom prst="rect">
             <a:avLst/>
@@ -12841,8 +13104,8 @@
         </p:blipFill>
         <p:spPr>
           <a:xfrm>
-            <a:off x="271461" y="5057470"/>
-            <a:ext cx="640000" cy="640000"/>
+            <a:off x="271461" y="4176125"/>
+            <a:ext cx="600000" cy="600000"/>
           </a:xfrm>
           <a:prstGeom prst="rect">
             <a:avLst/>
@@ -12857,8 +13120,8 @@
         </p:nvSpPr>
         <p:spPr>
           <a:xfrm>
-            <a:off x="1921461" y="5037470"/>
-            <a:ext cx="3975331" cy="640000"/>
+            <a:off x="1841461" y="4156125"/>
+            <a:ext cx="4055331" cy="600000"/>
           </a:xfrm>
           <a:prstGeom prst="rect">
             <a:avLst/>
@@ -12914,8 +13177,8 @@
         </p:blipFill>
         <p:spPr>
           <a:xfrm>
-            <a:off x="6096792" y="1194562"/>
-            <a:ext cx="640000" cy="640000"/>
+            <a:off x="271461" y="5206234"/>
+            <a:ext cx="600000" cy="600000"/>
           </a:xfrm>
           <a:prstGeom prst="rect">
             <a:avLst/>
@@ -12930,8 +13193,8 @@
         </p:nvSpPr>
         <p:spPr>
           <a:xfrm>
-            <a:off x="7746792" y="1174562"/>
-            <a:ext cx="3975331" cy="640000"/>
+            <a:off x="1841461" y="5186234"/>
+            <a:ext cx="4055331" cy="600000"/>
           </a:xfrm>
           <a:prstGeom prst="rect">
             <a:avLst/>
@@ -12987,8 +13250,8 @@
         </p:blipFill>
         <p:spPr>
           <a:xfrm>
-            <a:off x="6096792" y="2482198"/>
-            <a:ext cx="640000" cy="640000"/>
+            <a:off x="6096792" y="1085798"/>
+            <a:ext cx="600000" cy="600000"/>
           </a:xfrm>
           <a:prstGeom prst="rect">
             <a:avLst/>
@@ -13003,8 +13266,8 @@
         </p:nvSpPr>
         <p:spPr>
           <a:xfrm>
-            <a:off x="7746792" y="2462198"/>
-            <a:ext cx="3975331" cy="640000"/>
+            <a:off x="7666792" y="1065798"/>
+            <a:ext cx="4055331" cy="600000"/>
           </a:xfrm>
           <a:prstGeom prst="rect">
             <a:avLst/>
@@ -13060,8 +13323,8 @@
         </p:blipFill>
         <p:spPr>
           <a:xfrm>
-            <a:off x="6096792" y="3769834"/>
-            <a:ext cx="640000" cy="640000"/>
+            <a:off x="6096792" y="2115907"/>
+            <a:ext cx="600000" cy="600000"/>
           </a:xfrm>
           <a:prstGeom prst="rect">
             <a:avLst/>
@@ -13076,8 +13339,8 @@
         </p:nvSpPr>
         <p:spPr>
           <a:xfrm>
-            <a:off x="7746792" y="3749834"/>
-            <a:ext cx="3975331" cy="640000"/>
+            <a:off x="7666792" y="2095907"/>
+            <a:ext cx="4055331" cy="600000"/>
           </a:xfrm>
           <a:prstGeom prst="rect">
             <a:avLst/>
@@ -13119,7 +13382,7 @@
       </p:sp>
       <p:pic>
         <p:nvPicPr>
-          <p:cNvPr id="18" name="Picture 17" descr="hide.png"/>
+          <p:cNvPr id="18" name="Picture 17" descr="screen.png"/>
           <p:cNvPicPr>
             <a:picLocks noChangeAspect="1"/>
           </p:cNvPicPr>
@@ -13133,8 +13396,8 @@
         </p:blipFill>
         <p:spPr>
           <a:xfrm>
-            <a:off x="6096792" y="5057470"/>
-            <a:ext cx="640000" cy="640000"/>
+            <a:off x="6096792" y="3146016"/>
+            <a:ext cx="600000" cy="600000"/>
           </a:xfrm>
           <a:prstGeom prst="rect">
             <a:avLst/>
@@ -13149,8 +13412,154 @@
         </p:nvSpPr>
         <p:spPr>
           <a:xfrm>
-            <a:off x="7746792" y="5037470"/>
-            <a:ext cx="3975331" cy="640000"/>
+            <a:off x="7666792" y="3126016"/>
+            <a:ext cx="4055331" cy="600000"/>
+          </a:xfrm>
+          <a:prstGeom prst="rect">
+            <a:avLst/>
+          </a:prstGeom>
+          <a:noFill/>
+        </p:spPr>
+        <p:txBody>
+          <a:bodyPr wrap="square" anchor="ctr" lIns="0" rIns="0" tIns="0" bIns="0">
+            <a:spAutoFit/>
+          </a:bodyPr>
+          <a:lstStyle/>
+          <a:p>
+            <a:pPr algn="l"/>
+            <a:r>
+              <a:rPr sz="2200" b="1">
+                <a:solidFill>
+                  <a:srgbClr val="111111"/>
+                </a:solidFill>
+              </a:rPr>
+              <a:t>Projector window</a:t>
+            </a:r>
+          </a:p>
+          <a:p>
+            <a:pPr algn="l">
+              <a:spcBef>
+                <a:spcPts val="600"/>
+              </a:spcBef>
+            </a:pPr>
+            <a:r>
+              <a:rPr sz="1700" b="0">
+                <a:solidFill>
+                  <a:srgbClr val="555B6B"/>
+                </a:solidFill>
+              </a:rPr>
+              <a:t>Reopens it when presenter mode is on.</a:t>
+            </a:r>
+          </a:p>
+        </p:txBody>
+      </p:sp>
+      <p:pic>
+        <p:nvPicPr>
+          <p:cNvPr id="20" name="Picture 19" descr="settings.png"/>
+          <p:cNvPicPr>
+            <a:picLocks noChangeAspect="1"/>
+          </p:cNvPicPr>
+          <p:nvPr/>
+        </p:nvPicPr>
+        <p:blipFill>
+          <a:blip r:embed="rId11"/>
+          <a:stretch>
+            <a:fillRect/>
+          </a:stretch>
+        </p:blipFill>
+        <p:spPr>
+          <a:xfrm>
+            <a:off x="6096792" y="4176125"/>
+            <a:ext cx="600000" cy="600000"/>
+          </a:xfrm>
+          <a:prstGeom prst="rect">
+            <a:avLst/>
+          </a:prstGeom>
+        </p:spPr>
+      </p:pic>
+      <p:sp>
+        <p:nvSpPr>
+          <p:cNvPr id="21" name="TextBox 20"/>
+          <p:cNvSpPr txBox="1"/>
+          <p:nvPr/>
+        </p:nvSpPr>
+        <p:spPr>
+          <a:xfrm>
+            <a:off x="7666792" y="4156125"/>
+            <a:ext cx="4055331" cy="600000"/>
+          </a:xfrm>
+          <a:prstGeom prst="rect">
+            <a:avLst/>
+          </a:prstGeom>
+          <a:noFill/>
+        </p:spPr>
+        <p:txBody>
+          <a:bodyPr wrap="square" anchor="ctr" lIns="0" rIns="0" tIns="0" bIns="0">
+            <a:spAutoFit/>
+          </a:bodyPr>
+          <a:lstStyle/>
+          <a:p>
+            <a:pPr algn="l"/>
+            <a:r>
+              <a:rPr sz="2200" b="1">
+                <a:solidFill>
+                  <a:srgbClr val="111111"/>
+                </a:solidFill>
+              </a:rPr>
+              <a:t>Settings</a:t>
+            </a:r>
+          </a:p>
+          <a:p>
+            <a:pPr algn="l">
+              <a:spcBef>
+                <a:spcPts val="600"/>
+              </a:spcBef>
+            </a:pPr>
+            <a:r>
+              <a:rPr sz="1700" b="0">
+                <a:solidFill>
+                  <a:srgbClr val="555B6B"/>
+                </a:solidFill>
+              </a:rPr>
+              <a:t>Colours and presenter mode.</a:t>
+            </a:r>
+          </a:p>
+        </p:txBody>
+      </p:sp>
+      <p:pic>
+        <p:nvPicPr>
+          <p:cNvPr id="22" name="Picture 21" descr="hide.png"/>
+          <p:cNvPicPr>
+            <a:picLocks noChangeAspect="1"/>
+          </p:cNvPicPr>
+          <p:nvPr/>
+        </p:nvPicPr>
+        <p:blipFill>
+          <a:blip r:embed="rId12"/>
+          <a:stretch>
+            <a:fillRect/>
+          </a:stretch>
+        </p:blipFill>
+        <p:spPr>
+          <a:xfrm>
+            <a:off x="6096792" y="5206234"/>
+            <a:ext cx="600000" cy="600000"/>
+          </a:xfrm>
+          <a:prstGeom prst="rect">
+            <a:avLst/>
+          </a:prstGeom>
+        </p:spPr>
+      </p:pic>
+      <p:sp>
+        <p:nvSpPr>
+          <p:cNvPr id="23" name="TextBox 22"/>
+          <p:cNvSpPr txBox="1"/>
+          <p:nvPr/>
+        </p:nvSpPr>
+        <p:spPr>
+          <a:xfrm>
+            <a:off x="7666792" y="5186234"/>
+            <a:ext cx="4055331" cy="600000"/>
           </a:xfrm>
           <a:prstGeom prst="rect">
             <a:avLst/>
@@ -13224,7 +13633,7 @@
           <a:lstStyle/>
           <a:p>
             <a:r>
-              <a:t>Mirror the iPad to the projector, then tap the top centre to hide the toolbar</a:t>
+              <a:t>With one screen, mirror the iPad and tap the top centre to hide the toolbar</a:t>
             </a:r>
           </a:p>
         </p:txBody>

</xml_diff>

<commit_message>
Separate views toggle, lecturer view and strip glide
- Toolbar toggle between same view (mirroring) and separate views
- Projector window on iPad via touch and hold, Open in New Window (the
  automatically opened tab was invisible in full screen); pop-up window on computers
- Separate views disabled in the Home Screen app, which cannot open a second window
- Lecturer view: projector status, elapsed time (tap to restart), 24-hour clock,
  slide number and a permanent slide strip; choosing a slide moves the projector
- Slide strip drag scrolling with adjustable speed and glide (Settings)
- Switching back to same view now closes the projector window
- Guide deck updated for the toggle and the new steps

Co-Authored-By: Claude Opus 5.5 <noreply@anthropic.com>
Claude-Session: https://claude.ai/code/session_01V4q6MUNQzbvGfyJNvW5Le1
</commit_message>
<xml_diff>
--- a/source/guide-deck.pptx
+++ b/source/guide-deck.pptx
@@ -9695,7 +9695,7 @@
           <a:lstStyle/>
           <a:p>
             <a:r>
-              <a:t>Two screens: presenter mode</a:t>
+              <a:t>Separate views: projector and lecturer</a:t>
             </a:r>
           </a:p>
         </p:txBody>
@@ -9716,7 +9716,7 @@
           <a:lstStyle/>
           <a:p>
             <a:r>
-              <a:t>1. Turn on presenter mode in Settings (Safari, iPad with M1 chip or later)</a:t>
+              <a:t>1. Tap the two-screens button in the toolbar (in Safari; iPad with M1 chip or later)</a:t>
             </a:r>
           </a:p>
         </p:txBody>
@@ -9737,7 +9737,7 @@
           <a:lstStyle/>
           <a:p>
             <a:r>
-              <a:t>2. Drag the new projector tab out into its own window, onto the display</a:t>
+              <a:t>2. Touch and hold Projector window, choose Open in New Window, drag it to the display</a:t>
             </a:r>
           </a:p>
         </p:txBody>
@@ -9758,14 +9758,14 @@
           <a:lstStyle/>
           <a:p>
             <a:r>
-              <a:t>3. Tap the projector window to fill the screen</a:t>
+              <a:t>3. Tap the projector window to fill the screen. This iPad shows the clock and slide strip</a:t>
             </a:r>
           </a:p>
         </p:txBody>
       </p:sp>
       <p:pic>
         <p:nvPicPr>
-          <p:cNvPr id="6" name="Picture 5" descr="settings-w.png"/>
+          <p:cNvPr id="6" name="Picture 5" descr="split-w.png"/>
           <p:cNvPicPr>
             <a:picLocks noChangeAspect="1"/>
           </p:cNvPicPr>
@@ -13382,7 +13382,7 @@
       </p:sp>
       <p:pic>
         <p:nvPicPr>
-          <p:cNvPr id="18" name="Picture 17" descr="screen.png"/>
+          <p:cNvPr id="18" name="Picture 17" descr="split.png"/>
           <p:cNvPicPr>
             <a:picLocks noChangeAspect="1"/>
           </p:cNvPicPr>
@@ -13433,7 +13433,7 @@
                   <a:srgbClr val="111111"/>
                 </a:solidFill>
               </a:rPr>
-              <a:t>Projector window</a:t>
+              <a:t>Same or separate views</a:t>
             </a:r>
           </a:p>
           <a:p>
@@ -13448,7 +13448,7 @@
                   <a:srgbClr val="555B6B"/>
                 </a:solidFill>
               </a:rPr>
-              <a:t>Reopens it when presenter mode is on.</a:t>
+              <a:t>Mirror one screen, or projector plus lecturer view.</a:t>
             </a:r>
           </a:p>
         </p:txBody>
@@ -13521,7 +13521,7 @@
                   <a:srgbClr val="555B6B"/>
                 </a:solidFill>
               </a:rPr>
-              <a:t>Colours and presenter mode.</a:t>
+              <a:t>Colours, slide strip speed and glide.</a:t>
             </a:r>
           </a:p>
         </p:txBody>
@@ -13633,7 +13633,7 @@
           <a:lstStyle/>
           <a:p>
             <a:r>
-              <a:t>With one screen, mirror the iPad and tap the top centre to hide the toolbar</a:t>
+              <a:t>Same view: mirror the iPad, then tap the top centre to hide the toolbar</a:t>
             </a:r>
           </a:p>
         </p:txBody>

</xml_diff>

<commit_message>
Mouse and finger input alongside the Pencil
- Navigate tool (default without a Pencil): clicks and taps turn pages, toggle the
  toolbar and open the overview; drawing tools draw with the mouse or a finger
- Pencil mode switches on at the first Pencil contact and is remembered: only the
  Pencil draws, fingers navigate; switch in Settings
- Two fingers pinch-zoom even while drawing with a finger (the stroke is dropped)
- Laser follows the mouse without pressing; wheel pans when zoomed, Ctrl/Cmd + wheel
  and trackpad pinch zoom at the pointer; tool shortcuts V, P, H, L, E and Esc
- Guide deck: "Three ways to use it" slide and Navigate in the tools slide; README
  section on input and keyboard shortcuts

Co-Authored-By: Claude Opus 5.5 <noreply@anthropic.com>
Claude-Session: https://claude.ai/code/session_01V4q6MUNQzbvGfyJNvW5Le1
</commit_message>
<xml_diff>
--- a/source/guide-deck.pptx
+++ b/source/guide-deck.pptx
@@ -23,6 +23,7 @@
     <p:sldId id="394" r:id="rId23"/>
     <p:sldId id="395" r:id="rId24"/>
     <p:sldId id="396" r:id="rId25"/>
+    <p:sldId id="397" r:id="rId26"/>
   </p:sldIdLst>
   <p:sldSz cx="12192000" cy="6858000"/>
   <p:notesSz cx="6858000" cy="9144000"/>
@@ -9695,146 +9696,11 @@
           <a:lstStyle/>
           <a:p>
             <a:r>
-              <a:t>Separate views: projector and lecturer</a:t>
-            </a:r>
-          </a:p>
-        </p:txBody>
-      </p:sp>
-      <p:sp>
-        <p:nvSpPr>
-          <p:cNvPr id="3" name="Text Placeholder 2"/>
-          <p:cNvSpPr>
-            <a:spLocks noGrp="1"/>
-          </p:cNvSpPr>
-          <p:nvPr>
-            <p:ph type="body" idx="20"/>
-          </p:nvPr>
-        </p:nvSpPr>
-        <p:spPr/>
-        <p:txBody>
-          <a:bodyPr/>
-          <a:lstStyle/>
-          <a:p>
-            <a:r>
-              <a:t>1. Tap the two-screens button in the toolbar (in Safari; iPad with M1 chip or later)</a:t>
-            </a:r>
-          </a:p>
-        </p:txBody>
-      </p:sp>
-      <p:sp>
-        <p:nvSpPr>
-          <p:cNvPr id="4" name="Text Placeholder 3"/>
-          <p:cNvSpPr>
-            <a:spLocks noGrp="1"/>
-          </p:cNvSpPr>
-          <p:nvPr>
-            <p:ph type="body" idx="21"/>
-          </p:nvPr>
-        </p:nvSpPr>
-        <p:spPr/>
-        <p:txBody>
-          <a:bodyPr/>
-          <a:lstStyle/>
-          <a:p>
-            <a:r>
-              <a:t>2. Touch and hold Projector window, choose Open in New Window, drag it to the display</a:t>
-            </a:r>
-          </a:p>
-        </p:txBody>
-      </p:sp>
-      <p:sp>
-        <p:nvSpPr>
-          <p:cNvPr id="5" name="Text Placeholder 4"/>
-          <p:cNvSpPr>
-            <a:spLocks noGrp="1"/>
-          </p:cNvSpPr>
-          <p:nvPr>
-            <p:ph type="body" idx="22"/>
-          </p:nvPr>
-        </p:nvSpPr>
-        <p:spPr/>
-        <p:txBody>
-          <a:bodyPr/>
-          <a:lstStyle/>
-          <a:p>
-            <a:r>
-              <a:t>3. Tap the projector window to fill the screen. This iPad shows the clock and slide strip</a:t>
-            </a:r>
-          </a:p>
-        </p:txBody>
-      </p:sp>
-      <p:pic>
-        <p:nvPicPr>
-          <p:cNvPr id="6" name="Picture 5" descr="split-w.png"/>
-          <p:cNvPicPr>
-            <a:picLocks noChangeAspect="1"/>
-          </p:cNvPicPr>
-          <p:nvPr/>
-        </p:nvPicPr>
-        <p:blipFill>
-          <a:blip r:embed="rId2"/>
-          <a:stretch>
-            <a:fillRect/>
-          </a:stretch>
-        </p:blipFill>
-        <p:spPr>
-          <a:xfrm>
-            <a:off x="1413179" y="1770744"/>
-            <a:ext cx="1500000" cy="1500000"/>
-          </a:xfrm>
-          <a:prstGeom prst="rect">
-            <a:avLst/>
-          </a:prstGeom>
-        </p:spPr>
-      </p:pic>
-      <p:pic>
-        <p:nvPicPr>
-          <p:cNvPr id="7" name="Picture 6" descr="screen-w.png"/>
-          <p:cNvPicPr>
-            <a:picLocks noChangeAspect="1"/>
-          </p:cNvPicPr>
-          <p:nvPr/>
-        </p:nvPicPr>
-        <p:blipFill>
-          <a:blip r:embed="rId3"/>
-          <a:stretch>
-            <a:fillRect/>
-          </a:stretch>
-        </p:blipFill>
-        <p:spPr>
-          <a:xfrm>
-            <a:off x="5351252" y="1770744"/>
-            <a:ext cx="1500000" cy="1500000"/>
-          </a:xfrm>
-          <a:prstGeom prst="rect">
-            <a:avLst/>
-          </a:prstGeom>
-        </p:spPr>
-      </p:pic>
-      <p:pic>
-        <p:nvPicPr>
-          <p:cNvPr id="8" name="Picture 7" descr="fs-w.png"/>
-          <p:cNvPicPr>
-            <a:picLocks noChangeAspect="1"/>
-          </p:cNvPicPr>
-          <p:nvPr/>
-        </p:nvPicPr>
-        <p:blipFill>
-          <a:blip r:embed="rId4"/>
-          <a:stretch>
-            <a:fillRect/>
-          </a:stretch>
-        </p:blipFill>
-        <p:spPr>
-          <a:xfrm>
-            <a:off x="9289325" y="1770744"/>
-            <a:ext cx="1500000" cy="1500000"/>
-          </a:xfrm>
-          <a:prstGeom prst="rect">
-            <a:avLst/>
-          </a:prstGeom>
-        </p:spPr>
-      </p:pic>
+              <a:t>Same view: mirror the iPad, then tap the top centre to hide the toolbar</a:t>
+            </a:r>
+          </a:p>
+        </p:txBody>
+      </p:sp>
     </p:spTree>
   </p:cSld>
   <p:clrMapOvr>
@@ -9869,58 +9735,77 @@
           <a:lstStyle/>
           <a:p>
             <a:r>
-              <a:t>Save keeps your notes</a:t>
-            </a:r>
-          </a:p>
-        </p:txBody>
-      </p:sp>
-      <p:sp>
-        <p:nvSpPr>
-          <p:cNvPr id="3" name="Rectangle 2"/>
-          <p:cNvSpPr/>
-          <p:nvPr/>
-        </p:nvSpPr>
-        <p:spPr>
-          <a:xfrm>
-            <a:off x="271461" y="870744"/>
-            <a:ext cx="11650663" cy="5150545"/>
-          </a:xfrm>
-          <a:prstGeom prst="rect">
-            <a:avLst/>
-          </a:prstGeom>
-          <a:solidFill>
-            <a:srgbClr val="0028A5"/>
-          </a:solidFill>
-          <a:ln>
-            <a:noFill/>
-          </a:ln>
-          <a:effectLst/>
-        </p:spPr>
-        <p:style>
-          <a:lnRef idx="1">
-            <a:schemeClr val="accent1"/>
-          </a:lnRef>
-          <a:fillRef idx="3">
-            <a:schemeClr val="accent1"/>
-          </a:fillRef>
-          <a:effectRef idx="2">
-            <a:schemeClr val="accent1"/>
-          </a:effectRef>
-          <a:fontRef idx="minor">
-            <a:schemeClr val="lt1"/>
-          </a:fontRef>
-        </p:style>
-        <p:txBody>
-          <a:bodyPr rtlCol="0" anchor="ctr"/>
-          <a:lstStyle/>
-          <a:p>
-            <a:pPr algn="ctr"/>
+              <a:t>Separate views: projector and lecturer</a:t>
+            </a:r>
+          </a:p>
+        </p:txBody>
+      </p:sp>
+      <p:sp>
+        <p:nvSpPr>
+          <p:cNvPr id="3" name="Text Placeholder 2"/>
+          <p:cNvSpPr>
+            <a:spLocks noGrp="1"/>
+          </p:cNvSpPr>
+          <p:nvPr>
+            <p:ph type="body" idx="20"/>
+          </p:nvPr>
+        </p:nvSpPr>
+        <p:spPr/>
+        <p:txBody>
+          <a:bodyPr/>
+          <a:lstStyle/>
+          <a:p>
+            <a:r>
+              <a:t>1. Tap the two-screens button in the toolbar (in Safari; iPad with M1 chip or later)</a:t>
+            </a:r>
+          </a:p>
+        </p:txBody>
+      </p:sp>
+      <p:sp>
+        <p:nvSpPr>
+          <p:cNvPr id="4" name="Text Placeholder 3"/>
+          <p:cNvSpPr>
+            <a:spLocks noGrp="1"/>
+          </p:cNvSpPr>
+          <p:nvPr>
+            <p:ph type="body" idx="21"/>
+          </p:nvPr>
+        </p:nvSpPr>
+        <p:spPr/>
+        <p:txBody>
+          <a:bodyPr/>
+          <a:lstStyle/>
+          <a:p>
+            <a:r>
+              <a:t>2. Touch and hold Projector window, choose Open in New Window, drag it to the display</a:t>
+            </a:r>
+          </a:p>
+        </p:txBody>
+      </p:sp>
+      <p:sp>
+        <p:nvSpPr>
+          <p:cNvPr id="5" name="Text Placeholder 4"/>
+          <p:cNvSpPr>
+            <a:spLocks noGrp="1"/>
+          </p:cNvSpPr>
+          <p:nvPr>
+            <p:ph type="body" idx="22"/>
+          </p:nvPr>
+        </p:nvSpPr>
+        <p:spPr/>
+        <p:txBody>
+          <a:bodyPr/>
+          <a:lstStyle/>
+          <a:p>
+            <a:r>
+              <a:t>3. Tap the projector window to fill the screen. This iPad shows the clock and slide strip</a:t>
+            </a:r>
           </a:p>
         </p:txBody>
       </p:sp>
       <p:pic>
         <p:nvPicPr>
-          <p:cNvPr id="4" name="Picture 3" descr="save-w.png"/>
+          <p:cNvPr id="6" name="Picture 5" descr="split-w.png"/>
           <p:cNvPicPr>
             <a:picLocks noChangeAspect="1"/>
           </p:cNvPicPr>
@@ -9934,78 +9819,62 @@
         </p:blipFill>
         <p:spPr>
           <a:xfrm>
-            <a:off x="1371461" y="2106875"/>
-            <a:ext cx="2678283" cy="2678283"/>
+            <a:off x="1413179" y="1770744"/>
+            <a:ext cx="1500000" cy="1500000"/>
           </a:xfrm>
           <a:prstGeom prst="rect">
             <a:avLst/>
           </a:prstGeom>
         </p:spPr>
       </p:pic>
-      <p:sp>
-        <p:nvSpPr>
-          <p:cNvPr id="5" name="TextBox 4"/>
-          <p:cNvSpPr txBox="1"/>
+      <p:pic>
+        <p:nvPicPr>
+          <p:cNvPr id="7" name="Picture 6" descr="screen-w.png"/>
+          <p:cNvPicPr>
+            <a:picLocks noChangeAspect="1"/>
+          </p:cNvPicPr>
           <p:nvPr/>
-        </p:nvSpPr>
-        <p:spPr>
-          <a:xfrm>
-            <a:off x="4949744" y="870744"/>
-            <a:ext cx="6172380" cy="5150545"/>
+        </p:nvPicPr>
+        <p:blipFill>
+          <a:blip r:embed="rId3"/>
+          <a:stretch>
+            <a:fillRect/>
+          </a:stretch>
+        </p:blipFill>
+        <p:spPr>
+          <a:xfrm>
+            <a:off x="5351252" y="1770744"/>
+            <a:ext cx="1500000" cy="1500000"/>
           </a:xfrm>
           <a:prstGeom prst="rect">
             <a:avLst/>
           </a:prstGeom>
-          <a:noFill/>
-        </p:spPr>
-        <p:txBody>
-          <a:bodyPr wrap="square" anchor="ctr" lIns="0" rIns="0" tIns="0" bIns="0">
-            <a:spAutoFit/>
-          </a:bodyPr>
-          <a:lstStyle/>
-          <a:p>
-            <a:pPr algn="l"/>
-            <a:r>
-              <a:rPr sz="2800" b="1">
-                <a:solidFill>
-                  <a:srgbClr val="FFFFFF"/>
-                </a:solidFill>
-              </a:rPr>
-              <a:t>Save writes your ink into a new PDF</a:t>
-            </a:r>
-          </a:p>
-          <a:p>
-            <a:pPr algn="l">
-              <a:spcBef>
-                <a:spcPts val="600"/>
-              </a:spcBef>
-            </a:pPr>
-            <a:r>
-              <a:rPr sz="2000" b="0">
-                <a:solidFill>
-                  <a:srgbClr val="FFFFFF"/>
-                </a:solidFill>
-              </a:rPr>
-              <a:t>On iPad, choose Save to Files and pick a folder.</a:t>
-            </a:r>
-          </a:p>
-          <a:p>
-            <a:pPr algn="l">
-              <a:spcBef>
-                <a:spcPts val="600"/>
-              </a:spcBef>
-            </a:pPr>
-            <a:r>
-              <a:rPr sz="2000" b="0">
-                <a:solidFill>
-                  <a:srgbClr val="FFFFFF"/>
-                </a:solidFill>
-              </a:rPr>
-              <a:t>Try it: circle something on this slide, then tap Save.</a:t>
-            </a:r>
-          </a:p>
-        </p:txBody>
-      </p:sp>
+        </p:spPr>
+      </p:pic>
+      <p:pic>
+        <p:nvPicPr>
+          <p:cNvPr id="8" name="Picture 7" descr="fs-w.png"/>
+          <p:cNvPicPr>
+            <a:picLocks noChangeAspect="1"/>
+          </p:cNvPicPr>
+          <p:nvPr/>
+        </p:nvPicPr>
+        <p:blipFill>
+          <a:blip r:embed="rId4"/>
+          <a:stretch>
+            <a:fillRect/>
+          </a:stretch>
+        </p:blipFill>
+        <p:spPr>
+          <a:xfrm>
+            <a:off x="9289325" y="1770744"/>
+            <a:ext cx="1500000" cy="1500000"/>
+          </a:xfrm>
+          <a:prstGeom prst="rect">
+            <a:avLst/>
+          </a:prstGeom>
+        </p:spPr>
+      </p:pic>
     </p:spTree>
   </p:cSld>
   <p:clrMapOvr>
@@ -10040,6 +9909,177 @@
           <a:lstStyle/>
           <a:p>
             <a:r>
+              <a:t>Save keeps your notes</a:t>
+            </a:r>
+          </a:p>
+        </p:txBody>
+      </p:sp>
+      <p:sp>
+        <p:nvSpPr>
+          <p:cNvPr id="3" name="Rectangle 2"/>
+          <p:cNvSpPr/>
+          <p:nvPr/>
+        </p:nvSpPr>
+        <p:spPr>
+          <a:xfrm>
+            <a:off x="271461" y="870744"/>
+            <a:ext cx="11650663" cy="5150545"/>
+          </a:xfrm>
+          <a:prstGeom prst="rect">
+            <a:avLst/>
+          </a:prstGeom>
+          <a:solidFill>
+            <a:srgbClr val="0028A5"/>
+          </a:solidFill>
+          <a:ln>
+            <a:noFill/>
+          </a:ln>
+          <a:effectLst/>
+        </p:spPr>
+        <p:style>
+          <a:lnRef idx="1">
+            <a:schemeClr val="accent1"/>
+          </a:lnRef>
+          <a:fillRef idx="3">
+            <a:schemeClr val="accent1"/>
+          </a:fillRef>
+          <a:effectRef idx="2">
+            <a:schemeClr val="accent1"/>
+          </a:effectRef>
+          <a:fontRef idx="minor">
+            <a:schemeClr val="lt1"/>
+          </a:fontRef>
+        </p:style>
+        <p:txBody>
+          <a:bodyPr rtlCol="0" anchor="ctr"/>
+          <a:lstStyle/>
+          <a:p>
+            <a:pPr algn="ctr"/>
+          </a:p>
+        </p:txBody>
+      </p:sp>
+      <p:pic>
+        <p:nvPicPr>
+          <p:cNvPr id="4" name="Picture 3" descr="save-w.png"/>
+          <p:cNvPicPr>
+            <a:picLocks noChangeAspect="1"/>
+          </p:cNvPicPr>
+          <p:nvPr/>
+        </p:nvPicPr>
+        <p:blipFill>
+          <a:blip r:embed="rId2"/>
+          <a:stretch>
+            <a:fillRect/>
+          </a:stretch>
+        </p:blipFill>
+        <p:spPr>
+          <a:xfrm>
+            <a:off x="1371461" y="2106875"/>
+            <a:ext cx="2678283" cy="2678283"/>
+          </a:xfrm>
+          <a:prstGeom prst="rect">
+            <a:avLst/>
+          </a:prstGeom>
+        </p:spPr>
+      </p:pic>
+      <p:sp>
+        <p:nvSpPr>
+          <p:cNvPr id="5" name="TextBox 4"/>
+          <p:cNvSpPr txBox="1"/>
+          <p:nvPr/>
+        </p:nvSpPr>
+        <p:spPr>
+          <a:xfrm>
+            <a:off x="4949744" y="870744"/>
+            <a:ext cx="6172380" cy="5150545"/>
+          </a:xfrm>
+          <a:prstGeom prst="rect">
+            <a:avLst/>
+          </a:prstGeom>
+          <a:noFill/>
+        </p:spPr>
+        <p:txBody>
+          <a:bodyPr wrap="square" anchor="ctr" lIns="0" rIns="0" tIns="0" bIns="0">
+            <a:spAutoFit/>
+          </a:bodyPr>
+          <a:lstStyle/>
+          <a:p>
+            <a:pPr algn="l"/>
+            <a:r>
+              <a:rPr sz="2800" b="1">
+                <a:solidFill>
+                  <a:srgbClr val="FFFFFF"/>
+                </a:solidFill>
+              </a:rPr>
+              <a:t>Save writes your ink into a new PDF</a:t>
+            </a:r>
+          </a:p>
+          <a:p>
+            <a:pPr algn="l">
+              <a:spcBef>
+                <a:spcPts val="600"/>
+              </a:spcBef>
+            </a:pPr>
+            <a:r>
+              <a:rPr sz="2000" b="0">
+                <a:solidFill>
+                  <a:srgbClr val="FFFFFF"/>
+                </a:solidFill>
+              </a:rPr>
+              <a:t>On iPad, choose Save to Files and pick a folder.</a:t>
+            </a:r>
+          </a:p>
+          <a:p>
+            <a:pPr algn="l">
+              <a:spcBef>
+                <a:spcPts val="600"/>
+              </a:spcBef>
+            </a:pPr>
+            <a:r>
+              <a:rPr sz="2000" b="0">
+                <a:solidFill>
+                  <a:srgbClr val="FFFFFF"/>
+                </a:solidFill>
+              </a:rPr>
+              <a:t>Try it: circle something on this slide, then tap Save.</a:t>
+            </a:r>
+          </a:p>
+        </p:txBody>
+      </p:sp>
+    </p:spTree>
+  </p:cSld>
+  <p:clrMapOvr>
+    <a:masterClrMapping/>
+  </p:clrMapOvr>
+</p:sld>
+</file>
+
+<file path=ppt/slides/slide13.xml><?xml version="1.0" encoding="utf-8"?>
+<p:sld xmlns:a="http://schemas.openxmlformats.org/drawingml/2006/main" xmlns:p="http://schemas.openxmlformats.org/presentationml/2006/main" xmlns:r="http://schemas.openxmlformats.org/officeDocument/2006/relationships">
+  <p:cSld>
+    <p:spTree>
+      <p:nvGrpSpPr>
+        <p:cNvPr id="1" name=""/>
+        <p:cNvGrpSpPr/>
+        <p:nvPr/>
+      </p:nvGrpSpPr>
+      <p:grpSpPr/>
+      <p:sp>
+        <p:nvSpPr>
+          <p:cNvPr id="2" name="Title 1"/>
+          <p:cNvSpPr>
+            <a:spLocks noGrp="1"/>
+          </p:cNvSpPr>
+          <p:nvPr>
+            <p:ph type="title"/>
+          </p:nvPr>
+        </p:nvSpPr>
+        <p:spPr/>
+        <p:txBody>
+          <a:bodyPr/>
+          <a:lstStyle/>
+          <a:p>
+            <a:r>
               <a:t>Open your own PDF from the toolbar to begin</a:t>
             </a:r>
           </a:p>
@@ -10079,278 +10119,77 @@
           <a:lstStyle/>
           <a:p>
             <a:r>
-              <a:t>Tap the right third: next slide</a:t>
-            </a:r>
-          </a:p>
-        </p:txBody>
-      </p:sp>
-      <p:sp>
-        <p:nvSpPr>
-          <p:cNvPr id="3" name="Rectangle 2"/>
-          <p:cNvSpPr/>
-          <p:nvPr/>
-        </p:nvSpPr>
-        <p:spPr>
-          <a:xfrm>
-            <a:off x="271461" y="870744"/>
-            <a:ext cx="11650663" cy="5150545"/>
-          </a:xfrm>
-          <a:prstGeom prst="rect">
-            <a:avLst/>
-          </a:prstGeom>
-          <a:solidFill>
-            <a:srgbClr val="E8EBF3"/>
-          </a:solidFill>
-          <a:ln>
-            <a:noFill/>
-          </a:ln>
-          <a:effectLst/>
-        </p:spPr>
-        <p:style>
-          <a:lnRef idx="1">
-            <a:schemeClr val="accent1"/>
-          </a:lnRef>
-          <a:fillRef idx="3">
-            <a:schemeClr val="accent1"/>
-          </a:fillRef>
-          <a:effectRef idx="2">
-            <a:schemeClr val="accent1"/>
-          </a:effectRef>
-          <a:fontRef idx="minor">
-            <a:schemeClr val="lt1"/>
-          </a:fontRef>
-        </p:style>
-        <p:txBody>
-          <a:bodyPr rtlCol="0" anchor="ctr"/>
-          <a:lstStyle/>
-          <a:p>
-            <a:pPr algn="ctr"/>
-          </a:p>
-        </p:txBody>
-      </p:sp>
-      <p:sp>
-        <p:nvSpPr>
-          <p:cNvPr id="4" name="Rectangle 3"/>
-          <p:cNvSpPr/>
-          <p:nvPr/>
-        </p:nvSpPr>
-        <p:spPr>
-          <a:xfrm>
-            <a:off x="4149015" y="870744"/>
-            <a:ext cx="12000" cy="3862908"/>
-          </a:xfrm>
-          <a:prstGeom prst="rect">
-            <a:avLst/>
-          </a:prstGeom>
-          <a:solidFill>
-            <a:srgbClr val="C9CEDC"/>
-          </a:solidFill>
-          <a:ln>
-            <a:noFill/>
-          </a:ln>
-          <a:effectLst/>
-        </p:spPr>
-        <p:style>
-          <a:lnRef idx="1">
-            <a:schemeClr val="accent1"/>
-          </a:lnRef>
-          <a:fillRef idx="3">
-            <a:schemeClr val="accent1"/>
-          </a:fillRef>
-          <a:effectRef idx="2">
-            <a:schemeClr val="accent1"/>
-          </a:effectRef>
-          <a:fontRef idx="minor">
-            <a:schemeClr val="lt1"/>
-          </a:fontRef>
-        </p:style>
-        <p:txBody>
-          <a:bodyPr rtlCol="0" anchor="ctr"/>
-          <a:lstStyle/>
-          <a:p>
-            <a:pPr algn="ctr"/>
-          </a:p>
-        </p:txBody>
-      </p:sp>
-      <p:sp>
-        <p:nvSpPr>
-          <p:cNvPr id="5" name="Rectangle 4"/>
-          <p:cNvSpPr/>
-          <p:nvPr/>
-        </p:nvSpPr>
-        <p:spPr>
-          <a:xfrm>
-            <a:off x="8032569" y="870744"/>
-            <a:ext cx="12000" cy="3862908"/>
-          </a:xfrm>
-          <a:prstGeom prst="rect">
-            <a:avLst/>
-          </a:prstGeom>
-          <a:solidFill>
-            <a:srgbClr val="C9CEDC"/>
-          </a:solidFill>
-          <a:ln>
-            <a:noFill/>
-          </a:ln>
-          <a:effectLst/>
-        </p:spPr>
-        <p:style>
-          <a:lnRef idx="1">
-            <a:schemeClr val="accent1"/>
-          </a:lnRef>
-          <a:fillRef idx="3">
-            <a:schemeClr val="accent1"/>
-          </a:fillRef>
-          <a:effectRef idx="2">
-            <a:schemeClr val="accent1"/>
-          </a:effectRef>
-          <a:fontRef idx="minor">
-            <a:schemeClr val="lt1"/>
-          </a:fontRef>
-        </p:style>
-        <p:txBody>
-          <a:bodyPr rtlCol="0" anchor="ctr"/>
-          <a:lstStyle/>
-          <a:p>
-            <a:pPr algn="ctr"/>
-          </a:p>
-        </p:txBody>
-      </p:sp>
-      <p:sp>
-        <p:nvSpPr>
-          <p:cNvPr id="6" name="Rectangle 5"/>
-          <p:cNvSpPr/>
-          <p:nvPr/>
-        </p:nvSpPr>
-        <p:spPr>
-          <a:xfrm>
-            <a:off x="271461" y="4727652"/>
-            <a:ext cx="11650663" cy="12000"/>
-          </a:xfrm>
-          <a:prstGeom prst="rect">
-            <a:avLst/>
-          </a:prstGeom>
-          <a:solidFill>
-            <a:srgbClr val="C9CEDC"/>
-          </a:solidFill>
-          <a:ln>
-            <a:noFill/>
-          </a:ln>
-          <a:effectLst/>
-        </p:spPr>
-        <p:style>
-          <a:lnRef idx="1">
-            <a:schemeClr val="accent1"/>
-          </a:lnRef>
-          <a:fillRef idx="3">
-            <a:schemeClr val="accent1"/>
-          </a:fillRef>
-          <a:effectRef idx="2">
-            <a:schemeClr val="accent1"/>
-          </a:effectRef>
-          <a:fontRef idx="minor">
-            <a:schemeClr val="lt1"/>
-          </a:fontRef>
-        </p:style>
-        <p:txBody>
-          <a:bodyPr rtlCol="0" anchor="ctr"/>
-          <a:lstStyle/>
-          <a:p>
-            <a:pPr algn="ctr"/>
-          </a:p>
-        </p:txBody>
-      </p:sp>
-      <p:sp>
-        <p:nvSpPr>
-          <p:cNvPr id="7" name="Rectangle 6"/>
-          <p:cNvSpPr/>
-          <p:nvPr/>
-        </p:nvSpPr>
-        <p:spPr>
-          <a:xfrm>
-            <a:off x="4155015" y="2152380"/>
-            <a:ext cx="3883554" cy="12000"/>
-          </a:xfrm>
-          <a:prstGeom prst="rect">
-            <a:avLst/>
-          </a:prstGeom>
-          <a:solidFill>
-            <a:srgbClr val="C9CEDC"/>
-          </a:solidFill>
-          <a:ln>
-            <a:noFill/>
-          </a:ln>
-          <a:effectLst/>
-        </p:spPr>
-        <p:style>
-          <a:lnRef idx="1">
-            <a:schemeClr val="accent1"/>
-          </a:lnRef>
-          <a:fillRef idx="3">
-            <a:schemeClr val="accent1"/>
-          </a:fillRef>
-          <a:effectRef idx="2">
-            <a:schemeClr val="accent1"/>
-          </a:effectRef>
-          <a:fontRef idx="minor">
-            <a:schemeClr val="lt1"/>
-          </a:fontRef>
-        </p:style>
-        <p:txBody>
-          <a:bodyPr rtlCol="0" anchor="ctr"/>
-          <a:lstStyle/>
-          <a:p>
-            <a:pPr algn="ctr"/>
-          </a:p>
-        </p:txBody>
-      </p:sp>
-      <p:sp>
-        <p:nvSpPr>
-          <p:cNvPr id="8" name="Rectangle 7"/>
-          <p:cNvSpPr/>
-          <p:nvPr/>
-        </p:nvSpPr>
-        <p:spPr>
-          <a:xfrm>
-            <a:off x="8038569" y="870744"/>
-            <a:ext cx="3883555" cy="3862908"/>
-          </a:xfrm>
-          <a:prstGeom prst="rect">
-            <a:avLst/>
-          </a:prstGeom>
-          <a:solidFill>
-            <a:srgbClr val="0028A5"/>
-          </a:solidFill>
-          <a:ln>
-            <a:noFill/>
-          </a:ln>
-          <a:effectLst/>
-        </p:spPr>
-        <p:style>
-          <a:lnRef idx="1">
-            <a:schemeClr val="accent1"/>
-          </a:lnRef>
-          <a:fillRef idx="3">
-            <a:schemeClr val="accent1"/>
-          </a:fillRef>
-          <a:effectRef idx="2">
-            <a:schemeClr val="accent1"/>
-          </a:effectRef>
-          <a:fontRef idx="minor">
-            <a:schemeClr val="lt1"/>
-          </a:fontRef>
-        </p:style>
-        <p:txBody>
-          <a:bodyPr rtlCol="0" anchor="ctr"/>
-          <a:lstStyle/>
-          <a:p>
-            <a:pPr algn="ctr"/>
+              <a:t>Three ways to use it</a:t>
+            </a:r>
+          </a:p>
+        </p:txBody>
+      </p:sp>
+      <p:sp>
+        <p:nvSpPr>
+          <p:cNvPr id="3" name="Text Placeholder 2"/>
+          <p:cNvSpPr>
+            <a:spLocks noGrp="1"/>
+          </p:cNvSpPr>
+          <p:nvPr>
+            <p:ph type="body" idx="20"/>
+          </p:nvPr>
+        </p:nvSpPr>
+        <p:spPr/>
+        <p:txBody>
+          <a:bodyPr/>
+          <a:lstStyle/>
+          <a:p>
+            <a:r>
+              <a:t>iPad with Apple Pencil: the Pencil draws, fingers navigate. Pencil mode starts at the first Pencil touch</a:t>
+            </a:r>
+          </a:p>
+        </p:txBody>
+      </p:sp>
+      <p:sp>
+        <p:nvSpPr>
+          <p:cNvPr id="4" name="Text Placeholder 3"/>
+          <p:cNvSpPr>
+            <a:spLocks noGrp="1"/>
+          </p:cNvSpPr>
+          <p:nvPr>
+            <p:ph type="body" idx="21"/>
+          </p:nvPr>
+        </p:nvSpPr>
+        <p:spPr/>
+        <p:txBody>
+          <a:bodyPr/>
+          <a:lstStyle/>
+          <a:p>
+            <a:r>
+              <a:t>Computer with a mouse: click to turn pages, pick a tool to draw, Esc to go back to Navigate</a:t>
+            </a:r>
+          </a:p>
+        </p:txBody>
+      </p:sp>
+      <p:sp>
+        <p:nvSpPr>
+          <p:cNvPr id="5" name="Text Placeholder 4"/>
+          <p:cNvSpPr>
+            <a:spLocks noGrp="1"/>
+          </p:cNvSpPr>
+          <p:nvPr>
+            <p:ph type="body" idx="22"/>
+          </p:nvPr>
+        </p:nvSpPr>
+        <p:spPr/>
+        <p:txBody>
+          <a:bodyPr/>
+          <a:lstStyle/>
+          <a:p>
+            <a:r>
+              <a:t>Phone or tablet with a finger: works like the mouse, and two fingers always zoom</a:t>
+            </a:r>
           </a:p>
         </p:txBody>
       </p:sp>
       <p:pic>
         <p:nvPicPr>
-          <p:cNvPr id="9" name="Picture 8" descr="tap.png"/>
+          <p:cNvPr id="6" name="Picture 5" descr="pen-w.png"/>
           <p:cNvPicPr>
             <a:picLocks noChangeAspect="1"/>
           </p:cNvPicPr>
@@ -10364,63 +10203,62 @@
         </p:blipFill>
         <p:spPr>
           <a:xfrm>
-            <a:off x="9087129" y="1488809"/>
-            <a:ext cx="1786435" cy="1786435"/>
+            <a:off x="1413179" y="1570744"/>
+            <a:ext cx="1500000" cy="1500000"/>
           </a:xfrm>
           <a:prstGeom prst="rect">
             <a:avLst/>
           </a:prstGeom>
         </p:spPr>
       </p:pic>
-      <p:sp>
-        <p:nvSpPr>
-          <p:cNvPr id="10" name="TextBox 9"/>
-          <p:cNvSpPr txBox="1"/>
+      <p:pic>
+        <p:nvPicPr>
+          <p:cNvPr id="7" name="Picture 6" descr="mouse-w.png"/>
+          <p:cNvPicPr>
+            <a:picLocks noChangeAspect="1"/>
+          </p:cNvPicPr>
           <p:nvPr/>
-        </p:nvSpPr>
-        <p:spPr>
-          <a:xfrm>
-            <a:off x="8238569" y="3525244"/>
-            <a:ext cx="3483555" cy="1400000"/>
+        </p:nvPicPr>
+        <p:blipFill>
+          <a:blip r:embed="rId3"/>
+          <a:stretch>
+            <a:fillRect/>
+          </a:stretch>
+        </p:blipFill>
+        <p:spPr>
+          <a:xfrm>
+            <a:off x="5351252" y="1570744"/>
+            <a:ext cx="1500000" cy="1500000"/>
           </a:xfrm>
           <a:prstGeom prst="rect">
             <a:avLst/>
           </a:prstGeom>
-          <a:noFill/>
-        </p:spPr>
-        <p:txBody>
-          <a:bodyPr wrap="square" anchor="t" lIns="0" rIns="0" tIns="0" bIns="0">
-            <a:spAutoFit/>
-          </a:bodyPr>
-          <a:lstStyle/>
-          <a:p>
-            <a:pPr algn="ctr"/>
-            <a:r>
-              <a:rPr sz="2800" b="1">
-                <a:solidFill>
-                  <a:srgbClr val="FFFFFF"/>
-                </a:solidFill>
-              </a:rPr>
-              <a:t>Tap here</a:t>
-            </a:r>
-          </a:p>
-          <a:p>
-            <a:pPr algn="ctr">
-              <a:spcBef>
-                <a:spcPts val="600"/>
-              </a:spcBef>
-            </a:pPr>
-            <a:r>
-              <a:rPr sz="2000" b="0">
-                <a:solidFill>
-                  <a:srgbClr val="FFFFFF"/>
-                </a:solidFill>
-              </a:rPr>
-              <a:t>Next slide</a:t>
-            </a:r>
-          </a:p>
-        </p:txBody>
-      </p:sp>
+        </p:spPr>
+      </p:pic>
+      <p:pic>
+        <p:nvPicPr>
+          <p:cNvPr id="8" name="Picture 7" descr="tap.png"/>
+          <p:cNvPicPr>
+            <a:picLocks noChangeAspect="1"/>
+          </p:cNvPicPr>
+          <p:nvPr/>
+        </p:nvPicPr>
+        <p:blipFill>
+          <a:blip r:embed="rId4"/>
+          <a:stretch>
+            <a:fillRect/>
+          </a:stretch>
+        </p:blipFill>
+        <p:spPr>
+          <a:xfrm>
+            <a:off x="9289325" y="1570744"/>
+            <a:ext cx="1500000" cy="1500000"/>
+          </a:xfrm>
+          <a:prstGeom prst="rect">
+            <a:avLst/>
+          </a:prstGeom>
+        </p:spPr>
+      </p:pic>
     </p:spTree>
   </p:cSld>
   <p:clrMapOvr>
@@ -10455,7 +10293,7 @@
           <a:lstStyle/>
           <a:p>
             <a:r>
-              <a:t>Tap the left third: previous slide</a:t>
+              <a:t>Tap the right third: next slide</a:t>
             </a:r>
           </a:p>
         </p:txBody>
@@ -10688,8 +10526,8 @@
         </p:nvSpPr>
         <p:spPr>
           <a:xfrm>
-            <a:off x="271461" y="870744"/>
-            <a:ext cx="3883554" cy="3862908"/>
+            <a:off x="8038569" y="870744"/>
+            <a:ext cx="3883555" cy="3862908"/>
           </a:xfrm>
           <a:prstGeom prst="rect">
             <a:avLst/>
@@ -10740,8 +10578,8 @@
         </p:blipFill>
         <p:spPr>
           <a:xfrm>
-            <a:off x="1320021" y="1488809"/>
-            <a:ext cx="1786434" cy="1786434"/>
+            <a:off x="9087129" y="1488809"/>
+            <a:ext cx="1786435" cy="1786435"/>
           </a:xfrm>
           <a:prstGeom prst="rect">
             <a:avLst/>
@@ -10756,8 +10594,8 @@
         </p:nvSpPr>
         <p:spPr>
           <a:xfrm>
-            <a:off x="471461" y="3525243"/>
-            <a:ext cx="3483554" cy="1400000"/>
+            <a:off x="8238569" y="3525244"/>
+            <a:ext cx="3483555" cy="1400000"/>
           </a:xfrm>
           <a:prstGeom prst="rect">
             <a:avLst/>
@@ -10792,7 +10630,7 @@
                   <a:srgbClr val="FFFFFF"/>
                 </a:solidFill>
               </a:rPr>
-              <a:t>Previous slide</a:t>
+              <a:t>Next slide</a:t>
             </a:r>
           </a:p>
         </p:txBody>
@@ -10831,7 +10669,7 @@
           <a:lstStyle/>
           <a:p>
             <a:r>
-              <a:t>Tap the top centre: show or hide the toolbar</a:t>
+              <a:t>Tap the left third: previous slide</a:t>
             </a:r>
           </a:p>
         </p:txBody>
@@ -11064,8 +10902,8 @@
         </p:nvSpPr>
         <p:spPr>
           <a:xfrm>
-            <a:off x="4155015" y="870744"/>
-            <a:ext cx="3883554" cy="1287636"/>
+            <a:off x="271461" y="870744"/>
+            <a:ext cx="3883554" cy="3862908"/>
           </a:xfrm>
           <a:prstGeom prst="rect">
             <a:avLst/>
@@ -11116,8 +10954,8 @@
         </p:blipFill>
         <p:spPr>
           <a:xfrm>
-            <a:off x="4455015" y="1051013"/>
-            <a:ext cx="927097" cy="927097"/>
+            <a:off x="1320021" y="1488809"/>
+            <a:ext cx="1786434" cy="1786434"/>
           </a:xfrm>
           <a:prstGeom prst="rect">
             <a:avLst/>
@@ -11132,8 +10970,8 @@
         </p:nvSpPr>
         <p:spPr>
           <a:xfrm>
-            <a:off x="5682112" y="870744"/>
-            <a:ext cx="2206457" cy="1287636"/>
+            <a:off x="471461" y="3525243"/>
+            <a:ext cx="3483554" cy="1400000"/>
           </a:xfrm>
           <a:prstGeom prst="rect">
             <a:avLst/>
@@ -11141,12 +10979,12 @@
           <a:noFill/>
         </p:spPr>
         <p:txBody>
-          <a:bodyPr wrap="square" anchor="ctr" lIns="0" rIns="0" tIns="0" bIns="0">
+          <a:bodyPr wrap="square" anchor="t" lIns="0" rIns="0" tIns="0" bIns="0">
             <a:spAutoFit/>
           </a:bodyPr>
           <a:lstStyle/>
           <a:p>
-            <a:pPr algn="l"/>
+            <a:pPr algn="ctr"/>
             <a:r>
               <a:rPr sz="2800" b="1">
                 <a:solidFill>
@@ -11157,7 +10995,7 @@
             </a:r>
           </a:p>
           <a:p>
-            <a:pPr algn="l">
+            <a:pPr algn="ctr">
               <a:spcBef>
                 <a:spcPts val="600"/>
               </a:spcBef>
@@ -11168,7 +11006,7 @@
                   <a:srgbClr val="FFFFFF"/>
                 </a:solidFill>
               </a:rPr>
-              <a:t>Toolbar on or off</a:t>
+              <a:t>Previous slide</a:t>
             </a:r>
           </a:p>
         </p:txBody>
@@ -11207,7 +11045,7 @@
           <a:lstStyle/>
           <a:p>
             <a:r>
-              <a:t>Triple-tap the lower quarter: slide overview</a:t>
+              <a:t>Tap the top centre: show or hide the toolbar</a:t>
             </a:r>
           </a:p>
         </p:txBody>
@@ -11440,8 +11278,8 @@
         </p:nvSpPr>
         <p:spPr>
           <a:xfrm>
-            <a:off x="271461" y="4733652"/>
-            <a:ext cx="11650663" cy="1287637"/>
+            <a:off x="4155015" y="870744"/>
+            <a:ext cx="3883554" cy="1287636"/>
           </a:xfrm>
           <a:prstGeom prst="rect">
             <a:avLst/>
@@ -11492,8 +11330,8 @@
         </p:blipFill>
         <p:spPr>
           <a:xfrm>
-            <a:off x="3766659" y="4913921"/>
-            <a:ext cx="927098" cy="927098"/>
+            <a:off x="4455015" y="1051013"/>
+            <a:ext cx="927097" cy="927097"/>
           </a:xfrm>
           <a:prstGeom prst="rect">
             <a:avLst/>
@@ -11508,42 +11346,8 @@
         </p:nvSpPr>
         <p:spPr>
           <a:xfrm>
-            <a:off x="4693757" y="4913921"/>
-            <a:ext cx="900000" cy="600000"/>
-          </a:xfrm>
-          <a:prstGeom prst="rect">
-            <a:avLst/>
-          </a:prstGeom>
-          <a:noFill/>
-        </p:spPr>
-        <p:txBody>
-          <a:bodyPr wrap="square" anchor="t" lIns="0" rIns="0" tIns="0" bIns="0">
-            <a:spAutoFit/>
-          </a:bodyPr>
-          <a:lstStyle/>
-          <a:p>
-            <a:pPr algn="l"/>
-            <a:r>
-              <a:rPr sz="3000" b="1">
-                <a:solidFill>
-                  <a:srgbClr val="FFFFFF"/>
-                </a:solidFill>
-              </a:rPr>
-              <a:t>×3</a:t>
-            </a:r>
-          </a:p>
-        </p:txBody>
-      </p:sp>
-      <p:sp>
-        <p:nvSpPr>
-          <p:cNvPr id="11" name="TextBox 10"/>
-          <p:cNvSpPr txBox="1"/>
-          <p:nvPr/>
-        </p:nvSpPr>
-        <p:spPr>
-          <a:xfrm>
-            <a:off x="5693757" y="4733652"/>
-            <a:ext cx="6078367" cy="1287637"/>
+            <a:off x="5682112" y="870744"/>
+            <a:ext cx="2206457" cy="1287636"/>
           </a:xfrm>
           <a:prstGeom prst="rect">
             <a:avLst/>
@@ -11563,7 +11367,7 @@
                   <a:srgbClr val="FFFFFF"/>
                 </a:solidFill>
               </a:rPr>
-              <a:t>Triple-tap here</a:t>
+              <a:t>Tap here</a:t>
             </a:r>
           </a:p>
           <a:p>
@@ -11578,7 +11382,7 @@
                   <a:srgbClr val="FFFFFF"/>
                 </a:solidFill>
               </a:rPr>
-              <a:t>Opens the strip of slides; tap one to jump to it</a:t>
+              <a:t>Toolbar on or off</a:t>
             </a:r>
           </a:p>
         </p:txBody>
@@ -11617,7 +11421,7 @@
           <a:lstStyle/>
           <a:p>
             <a:r>
-              <a:t>Pinch to zoom</a:t>
+              <a:t>Triple-tap the lower quarter: slide overview</a:t>
             </a:r>
           </a:p>
         </p:txBody>
@@ -11632,6 +11436,226 @@
           <a:xfrm>
             <a:off x="271461" y="870744"/>
             <a:ext cx="11650663" cy="5150545"/>
+          </a:xfrm>
+          <a:prstGeom prst="rect">
+            <a:avLst/>
+          </a:prstGeom>
+          <a:solidFill>
+            <a:srgbClr val="E8EBF3"/>
+          </a:solidFill>
+          <a:ln>
+            <a:noFill/>
+          </a:ln>
+          <a:effectLst/>
+        </p:spPr>
+        <p:style>
+          <a:lnRef idx="1">
+            <a:schemeClr val="accent1"/>
+          </a:lnRef>
+          <a:fillRef idx="3">
+            <a:schemeClr val="accent1"/>
+          </a:fillRef>
+          <a:effectRef idx="2">
+            <a:schemeClr val="accent1"/>
+          </a:effectRef>
+          <a:fontRef idx="minor">
+            <a:schemeClr val="lt1"/>
+          </a:fontRef>
+        </p:style>
+        <p:txBody>
+          <a:bodyPr rtlCol="0" anchor="ctr"/>
+          <a:lstStyle/>
+          <a:p>
+            <a:pPr algn="ctr"/>
+          </a:p>
+        </p:txBody>
+      </p:sp>
+      <p:sp>
+        <p:nvSpPr>
+          <p:cNvPr id="4" name="Rectangle 3"/>
+          <p:cNvSpPr/>
+          <p:nvPr/>
+        </p:nvSpPr>
+        <p:spPr>
+          <a:xfrm>
+            <a:off x="4149015" y="870744"/>
+            <a:ext cx="12000" cy="3862908"/>
+          </a:xfrm>
+          <a:prstGeom prst="rect">
+            <a:avLst/>
+          </a:prstGeom>
+          <a:solidFill>
+            <a:srgbClr val="C9CEDC"/>
+          </a:solidFill>
+          <a:ln>
+            <a:noFill/>
+          </a:ln>
+          <a:effectLst/>
+        </p:spPr>
+        <p:style>
+          <a:lnRef idx="1">
+            <a:schemeClr val="accent1"/>
+          </a:lnRef>
+          <a:fillRef idx="3">
+            <a:schemeClr val="accent1"/>
+          </a:fillRef>
+          <a:effectRef idx="2">
+            <a:schemeClr val="accent1"/>
+          </a:effectRef>
+          <a:fontRef idx="minor">
+            <a:schemeClr val="lt1"/>
+          </a:fontRef>
+        </p:style>
+        <p:txBody>
+          <a:bodyPr rtlCol="0" anchor="ctr"/>
+          <a:lstStyle/>
+          <a:p>
+            <a:pPr algn="ctr"/>
+          </a:p>
+        </p:txBody>
+      </p:sp>
+      <p:sp>
+        <p:nvSpPr>
+          <p:cNvPr id="5" name="Rectangle 4"/>
+          <p:cNvSpPr/>
+          <p:nvPr/>
+        </p:nvSpPr>
+        <p:spPr>
+          <a:xfrm>
+            <a:off x="8032569" y="870744"/>
+            <a:ext cx="12000" cy="3862908"/>
+          </a:xfrm>
+          <a:prstGeom prst="rect">
+            <a:avLst/>
+          </a:prstGeom>
+          <a:solidFill>
+            <a:srgbClr val="C9CEDC"/>
+          </a:solidFill>
+          <a:ln>
+            <a:noFill/>
+          </a:ln>
+          <a:effectLst/>
+        </p:spPr>
+        <p:style>
+          <a:lnRef idx="1">
+            <a:schemeClr val="accent1"/>
+          </a:lnRef>
+          <a:fillRef idx="3">
+            <a:schemeClr val="accent1"/>
+          </a:fillRef>
+          <a:effectRef idx="2">
+            <a:schemeClr val="accent1"/>
+          </a:effectRef>
+          <a:fontRef idx="minor">
+            <a:schemeClr val="lt1"/>
+          </a:fontRef>
+        </p:style>
+        <p:txBody>
+          <a:bodyPr rtlCol="0" anchor="ctr"/>
+          <a:lstStyle/>
+          <a:p>
+            <a:pPr algn="ctr"/>
+          </a:p>
+        </p:txBody>
+      </p:sp>
+      <p:sp>
+        <p:nvSpPr>
+          <p:cNvPr id="6" name="Rectangle 5"/>
+          <p:cNvSpPr/>
+          <p:nvPr/>
+        </p:nvSpPr>
+        <p:spPr>
+          <a:xfrm>
+            <a:off x="271461" y="4727652"/>
+            <a:ext cx="11650663" cy="12000"/>
+          </a:xfrm>
+          <a:prstGeom prst="rect">
+            <a:avLst/>
+          </a:prstGeom>
+          <a:solidFill>
+            <a:srgbClr val="C9CEDC"/>
+          </a:solidFill>
+          <a:ln>
+            <a:noFill/>
+          </a:ln>
+          <a:effectLst/>
+        </p:spPr>
+        <p:style>
+          <a:lnRef idx="1">
+            <a:schemeClr val="accent1"/>
+          </a:lnRef>
+          <a:fillRef idx="3">
+            <a:schemeClr val="accent1"/>
+          </a:fillRef>
+          <a:effectRef idx="2">
+            <a:schemeClr val="accent1"/>
+          </a:effectRef>
+          <a:fontRef idx="minor">
+            <a:schemeClr val="lt1"/>
+          </a:fontRef>
+        </p:style>
+        <p:txBody>
+          <a:bodyPr rtlCol="0" anchor="ctr"/>
+          <a:lstStyle/>
+          <a:p>
+            <a:pPr algn="ctr"/>
+          </a:p>
+        </p:txBody>
+      </p:sp>
+      <p:sp>
+        <p:nvSpPr>
+          <p:cNvPr id="7" name="Rectangle 6"/>
+          <p:cNvSpPr/>
+          <p:nvPr/>
+        </p:nvSpPr>
+        <p:spPr>
+          <a:xfrm>
+            <a:off x="4155015" y="2152380"/>
+            <a:ext cx="3883554" cy="12000"/>
+          </a:xfrm>
+          <a:prstGeom prst="rect">
+            <a:avLst/>
+          </a:prstGeom>
+          <a:solidFill>
+            <a:srgbClr val="C9CEDC"/>
+          </a:solidFill>
+          <a:ln>
+            <a:noFill/>
+          </a:ln>
+          <a:effectLst/>
+        </p:spPr>
+        <p:style>
+          <a:lnRef idx="1">
+            <a:schemeClr val="accent1"/>
+          </a:lnRef>
+          <a:fillRef idx="3">
+            <a:schemeClr val="accent1"/>
+          </a:fillRef>
+          <a:effectRef idx="2">
+            <a:schemeClr val="accent1"/>
+          </a:effectRef>
+          <a:fontRef idx="minor">
+            <a:schemeClr val="lt1"/>
+          </a:fontRef>
+        </p:style>
+        <p:txBody>
+          <a:bodyPr rtlCol="0" anchor="ctr"/>
+          <a:lstStyle/>
+          <a:p>
+            <a:pPr algn="ctr"/>
+          </a:p>
+        </p:txBody>
+      </p:sp>
+      <p:sp>
+        <p:nvSpPr>
+          <p:cNvPr id="8" name="Rectangle 7"/>
+          <p:cNvSpPr/>
+          <p:nvPr/>
+        </p:nvSpPr>
+        <p:spPr>
+          <a:xfrm>
+            <a:off x="271461" y="4733652"/>
+            <a:ext cx="11650663" cy="1287637"/>
           </a:xfrm>
           <a:prstGeom prst="rect">
             <a:avLst/>
@@ -11668,7 +11692,7 @@
       </p:sp>
       <p:pic>
         <p:nvPicPr>
-          <p:cNvPr id="4" name="Picture 3" descr="pinch.png"/>
+          <p:cNvPr id="9" name="Picture 8" descr="tap.png"/>
           <p:cNvPicPr>
             <a:picLocks noChangeAspect="1"/>
           </p:cNvPicPr>
@@ -11682,8 +11706,8 @@
         </p:blipFill>
         <p:spPr>
           <a:xfrm>
-            <a:off x="1171461" y="1643326"/>
-            <a:ext cx="3605381" cy="3605381"/>
+            <a:off x="3766659" y="4913921"/>
+            <a:ext cx="927098" cy="927098"/>
           </a:xfrm>
           <a:prstGeom prst="rect">
             <a:avLst/>
@@ -11692,14 +11716,48 @@
       </p:pic>
       <p:sp>
         <p:nvSpPr>
-          <p:cNvPr id="5" name="TextBox 4"/>
+          <p:cNvPr id="10" name="TextBox 9"/>
           <p:cNvSpPr txBox="1"/>
           <p:nvPr/>
         </p:nvSpPr>
         <p:spPr>
           <a:xfrm>
-            <a:off x="5476842" y="870744"/>
-            <a:ext cx="5745282" cy="5150545"/>
+            <a:off x="4693757" y="4913921"/>
+            <a:ext cx="900000" cy="600000"/>
+          </a:xfrm>
+          <a:prstGeom prst="rect">
+            <a:avLst/>
+          </a:prstGeom>
+          <a:noFill/>
+        </p:spPr>
+        <p:txBody>
+          <a:bodyPr wrap="square" anchor="t" lIns="0" rIns="0" tIns="0" bIns="0">
+            <a:spAutoFit/>
+          </a:bodyPr>
+          <a:lstStyle/>
+          <a:p>
+            <a:pPr algn="l"/>
+            <a:r>
+              <a:rPr sz="3000" b="1">
+                <a:solidFill>
+                  <a:srgbClr val="FFFFFF"/>
+                </a:solidFill>
+              </a:rPr>
+              <a:t>×3</a:t>
+            </a:r>
+          </a:p>
+        </p:txBody>
+      </p:sp>
+      <p:sp>
+        <p:nvSpPr>
+          <p:cNvPr id="11" name="TextBox 10"/>
+          <p:cNvSpPr txBox="1"/>
+          <p:nvPr/>
+        </p:nvSpPr>
+        <p:spPr>
+          <a:xfrm>
+            <a:off x="5693757" y="4733652"/>
+            <a:ext cx="6078367" cy="1287637"/>
           </a:xfrm>
           <a:prstGeom prst="rect">
             <a:avLst/>
@@ -11719,7 +11777,7 @@
                   <a:srgbClr val="FFFFFF"/>
                 </a:solidFill>
               </a:rPr>
-              <a:t>Pinch with two fingers to zoom</a:t>
+              <a:t>Triple-tap here</a:t>
             </a:r>
           </a:p>
           <a:p>
@@ -11734,37 +11792,7 @@
                   <a:srgbClr val="FFFFFF"/>
                 </a:solidFill>
               </a:rPr>
-              <a:t>Drag with one finger to move around while zoomed in.</a:t>
-            </a:r>
-          </a:p>
-          <a:p>
-            <a:pPr algn="l">
-              <a:spcBef>
-                <a:spcPts val="600"/>
-              </a:spcBef>
-            </a:pPr>
-            <a:r>
-              <a:rPr sz="2000" b="0">
-                <a:solidFill>
-                  <a:srgbClr val="FFFFFF"/>
-                </a:solidFill>
-              </a:rPr>
-              <a:t>Double-tap to fit the whole slide again.</a:t>
-            </a:r>
-          </a:p>
-          <a:p>
-            <a:pPr algn="l">
-              <a:spcBef>
-                <a:spcPts val="600"/>
-              </a:spcBef>
-            </a:pPr>
-            <a:r>
-              <a:rPr sz="2000" b="0">
-                <a:solidFill>
-                  <a:srgbClr val="FFFFFF"/>
-                </a:solidFill>
-              </a:rPr>
-              <a:t>The Pencil keeps writing while you are zoomed in.</a:t>
+              <a:t>Opens the strip of slides; tap one to jump to it</a:t>
             </a:r>
           </a:p>
         </p:txBody>
@@ -11803,14 +11831,58 @@
           <a:lstStyle/>
           <a:p>
             <a:r>
-              <a:t>Writing tools: only the Pencil draws</a:t>
-            </a:r>
+              <a:t>Pinch to zoom</a:t>
+            </a:r>
+          </a:p>
+        </p:txBody>
+      </p:sp>
+      <p:sp>
+        <p:nvSpPr>
+          <p:cNvPr id="3" name="Rectangle 2"/>
+          <p:cNvSpPr/>
+          <p:nvPr/>
+        </p:nvSpPr>
+        <p:spPr>
+          <a:xfrm>
+            <a:off x="271461" y="870744"/>
+            <a:ext cx="11650663" cy="5150545"/>
+          </a:xfrm>
+          <a:prstGeom prst="rect">
+            <a:avLst/>
+          </a:prstGeom>
+          <a:solidFill>
+            <a:srgbClr val="0028A5"/>
+          </a:solidFill>
+          <a:ln>
+            <a:noFill/>
+          </a:ln>
+          <a:effectLst/>
+        </p:spPr>
+        <p:style>
+          <a:lnRef idx="1">
+            <a:schemeClr val="accent1"/>
+          </a:lnRef>
+          <a:fillRef idx="3">
+            <a:schemeClr val="accent1"/>
+          </a:fillRef>
+          <a:effectRef idx="2">
+            <a:schemeClr val="accent1"/>
+          </a:effectRef>
+          <a:fontRef idx="minor">
+            <a:schemeClr val="lt1"/>
+          </a:fontRef>
+        </p:style>
+        <p:txBody>
+          <a:bodyPr rtlCol="0" anchor="ctr"/>
+          <a:lstStyle/>
+          <a:p>
+            <a:pPr algn="ctr"/>
           </a:p>
         </p:txBody>
       </p:sp>
       <p:pic>
         <p:nvPicPr>
-          <p:cNvPr id="3" name="Picture 2" descr="pen.png"/>
+          <p:cNvPr id="4" name="Picture 3" descr="pinch.png"/>
           <p:cNvPicPr>
             <a:picLocks noChangeAspect="1"/>
           </p:cNvPicPr>
@@ -11824,8 +11896,8 @@
         </p:blipFill>
         <p:spPr>
           <a:xfrm>
-            <a:off x="271461" y="1134562"/>
-            <a:ext cx="760000" cy="760000"/>
+            <a:off x="1171461" y="1643326"/>
+            <a:ext cx="3605381" cy="3605381"/>
           </a:xfrm>
           <a:prstGeom prst="rect">
             <a:avLst/>
@@ -11834,14 +11906,14 @@
       </p:pic>
       <p:sp>
         <p:nvSpPr>
-          <p:cNvPr id="4" name="TextBox 3"/>
+          <p:cNvPr id="5" name="TextBox 4"/>
           <p:cNvSpPr txBox="1"/>
           <p:nvPr/>
         </p:nvSpPr>
         <p:spPr>
           <a:xfrm>
-            <a:off x="1331461" y="1104562"/>
-            <a:ext cx="5200000" cy="760000"/>
+            <a:off x="5476842" y="870744"/>
+            <a:ext cx="5745282" cy="5150545"/>
           </a:xfrm>
           <a:prstGeom prst="rect">
             <a:avLst/>
@@ -11856,12 +11928,12 @@
           <a:p>
             <a:pPr algn="l"/>
             <a:r>
-              <a:rPr sz="2400" b="1">
+              <a:rPr sz="2800" b="1">
                 <a:solidFill>
-                  <a:srgbClr val="111111"/>
+                  <a:srgbClr val="FFFFFF"/>
                 </a:solidFill>
               </a:rPr>
-              <a:t>Pen</a:t>
+              <a:t>Pinch with two fingers to zoom</a:t>
             </a:r>
           </a:p>
           <a:p>
@@ -11871,380 +11943,12 @@
               </a:spcBef>
             </a:pPr>
             <a:r>
-              <a:rPr sz="1800" b="0">
+              <a:rPr sz="2000" b="0">
                 <a:solidFill>
-                  <a:srgbClr val="555B6B"/>
+                  <a:srgbClr val="FFFFFF"/>
                 </a:solidFill>
               </a:rPr>
-              <a:t>Pressure-sensitive ink, up to 10 UZH colours.</a:t>
-            </a:r>
-          </a:p>
-        </p:txBody>
-      </p:sp>
-      <p:sp>
-        <p:nvSpPr>
-          <p:cNvPr id="5" name="Oval 4"/>
-          <p:cNvSpPr/>
-          <p:nvPr/>
-        </p:nvSpPr>
-        <p:spPr>
-          <a:xfrm>
-            <a:off x="6771461" y="1274562"/>
-            <a:ext cx="480000" cy="480000"/>
-          </a:xfrm>
-          <a:prstGeom prst="ellipse">
-            <a:avLst/>
-          </a:prstGeom>
-          <a:solidFill>
-            <a:srgbClr val="0028A5"/>
-          </a:solidFill>
-          <a:ln>
-            <a:noFill/>
-          </a:ln>
-          <a:effectLst/>
-        </p:spPr>
-        <p:style>
-          <a:lnRef idx="1">
-            <a:schemeClr val="accent1"/>
-          </a:lnRef>
-          <a:fillRef idx="3">
-            <a:schemeClr val="accent1"/>
-          </a:fillRef>
-          <a:effectRef idx="2">
-            <a:schemeClr val="accent1"/>
-          </a:effectRef>
-          <a:fontRef idx="minor">
-            <a:schemeClr val="lt1"/>
-          </a:fontRef>
-        </p:style>
-        <p:txBody>
-          <a:bodyPr rtlCol="0" anchor="ctr"/>
-          <a:lstStyle/>
-          <a:p>
-            <a:pPr algn="ctr"/>
-          </a:p>
-        </p:txBody>
-      </p:sp>
-      <p:sp>
-        <p:nvSpPr>
-          <p:cNvPr id="6" name="Oval 5"/>
-          <p:cNvSpPr/>
-          <p:nvPr/>
-        </p:nvSpPr>
-        <p:spPr>
-          <a:xfrm>
-            <a:off x="7421461" y="1274562"/>
-            <a:ext cx="480000" cy="480000"/>
-          </a:xfrm>
-          <a:prstGeom prst="ellipse">
-            <a:avLst/>
-          </a:prstGeom>
-          <a:solidFill>
-            <a:srgbClr val="FC4C02"/>
-          </a:solidFill>
-          <a:ln>
-            <a:noFill/>
-          </a:ln>
-          <a:effectLst/>
-        </p:spPr>
-        <p:style>
-          <a:lnRef idx="1">
-            <a:schemeClr val="accent1"/>
-          </a:lnRef>
-          <a:fillRef idx="3">
-            <a:schemeClr val="accent1"/>
-          </a:fillRef>
-          <a:effectRef idx="2">
-            <a:schemeClr val="accent1"/>
-          </a:effectRef>
-          <a:fontRef idx="minor">
-            <a:schemeClr val="lt1"/>
-          </a:fontRef>
-        </p:style>
-        <p:txBody>
-          <a:bodyPr rtlCol="0" anchor="ctr"/>
-          <a:lstStyle/>
-          <a:p>
-            <a:pPr algn="ctr"/>
-          </a:p>
-        </p:txBody>
-      </p:sp>
-      <p:sp>
-        <p:nvSpPr>
-          <p:cNvPr id="7" name="Oval 6"/>
-          <p:cNvSpPr/>
-          <p:nvPr/>
-        </p:nvSpPr>
-        <p:spPr>
-          <a:xfrm>
-            <a:off x="8071461" y="1274562"/>
-            <a:ext cx="480000" cy="480000"/>
-          </a:xfrm>
-          <a:prstGeom prst="ellipse">
-            <a:avLst/>
-          </a:prstGeom>
-          <a:solidFill>
-            <a:srgbClr val="FFC845"/>
-          </a:solidFill>
-          <a:ln>
-            <a:noFill/>
-          </a:ln>
-          <a:effectLst/>
-        </p:spPr>
-        <p:style>
-          <a:lnRef idx="1">
-            <a:schemeClr val="accent1"/>
-          </a:lnRef>
-          <a:fillRef idx="3">
-            <a:schemeClr val="accent1"/>
-          </a:fillRef>
-          <a:effectRef idx="2">
-            <a:schemeClr val="accent1"/>
-          </a:effectRef>
-          <a:fontRef idx="minor">
-            <a:schemeClr val="lt1"/>
-          </a:fontRef>
-        </p:style>
-        <p:txBody>
-          <a:bodyPr rtlCol="0" anchor="ctr"/>
-          <a:lstStyle/>
-          <a:p>
-            <a:pPr algn="ctr"/>
-          </a:p>
-        </p:txBody>
-      </p:sp>
-      <p:sp>
-        <p:nvSpPr>
-          <p:cNvPr id="8" name="Oval 7"/>
-          <p:cNvSpPr/>
-          <p:nvPr/>
-        </p:nvSpPr>
-        <p:spPr>
-          <a:xfrm>
-            <a:off x="8721461" y="1274562"/>
-            <a:ext cx="480000" cy="480000"/>
-          </a:xfrm>
-          <a:prstGeom prst="ellipse">
-            <a:avLst/>
-          </a:prstGeom>
-          <a:solidFill>
-            <a:srgbClr val="A4D233"/>
-          </a:solidFill>
-          <a:ln>
-            <a:noFill/>
-          </a:ln>
-          <a:effectLst/>
-        </p:spPr>
-        <p:style>
-          <a:lnRef idx="1">
-            <a:schemeClr val="accent1"/>
-          </a:lnRef>
-          <a:fillRef idx="3">
-            <a:schemeClr val="accent1"/>
-          </a:fillRef>
-          <a:effectRef idx="2">
-            <a:schemeClr val="accent1"/>
-          </a:effectRef>
-          <a:fontRef idx="minor">
-            <a:schemeClr val="lt1"/>
-          </a:fontRef>
-        </p:style>
-        <p:txBody>
-          <a:bodyPr rtlCol="0" anchor="ctr"/>
-          <a:lstStyle/>
-          <a:p>
-            <a:pPr algn="ctr"/>
-          </a:p>
-        </p:txBody>
-      </p:sp>
-      <p:sp>
-        <p:nvSpPr>
-          <p:cNvPr id="9" name="Oval 8"/>
-          <p:cNvSpPr/>
-          <p:nvPr/>
-        </p:nvSpPr>
-        <p:spPr>
-          <a:xfrm>
-            <a:off x="9371461" y="1274562"/>
-            <a:ext cx="480000" cy="480000"/>
-          </a:xfrm>
-          <a:prstGeom prst="ellipse">
-            <a:avLst/>
-          </a:prstGeom>
-          <a:solidFill>
-            <a:srgbClr val="000000"/>
-          </a:solidFill>
-          <a:ln>
-            <a:noFill/>
-          </a:ln>
-          <a:effectLst/>
-        </p:spPr>
-        <p:style>
-          <a:lnRef idx="1">
-            <a:schemeClr val="accent1"/>
-          </a:lnRef>
-          <a:fillRef idx="3">
-            <a:schemeClr val="accent1"/>
-          </a:fillRef>
-          <a:effectRef idx="2">
-            <a:schemeClr val="accent1"/>
-          </a:effectRef>
-          <a:fontRef idx="minor">
-            <a:schemeClr val="lt1"/>
-          </a:fontRef>
-        </p:style>
-        <p:txBody>
-          <a:bodyPr rtlCol="0" anchor="ctr"/>
-          <a:lstStyle/>
-          <a:p>
-            <a:pPr algn="ctr"/>
-          </a:p>
-        </p:txBody>
-      </p:sp>
-      <p:sp>
-        <p:nvSpPr>
-          <p:cNvPr id="10" name="Oval 9"/>
-          <p:cNvSpPr/>
-          <p:nvPr/>
-        </p:nvSpPr>
-        <p:spPr>
-          <a:xfrm>
-            <a:off x="10021461" y="1274562"/>
-            <a:ext cx="480000" cy="480000"/>
-          </a:xfrm>
-          <a:prstGeom prst="ellipse">
-            <a:avLst/>
-          </a:prstGeom>
-          <a:solidFill>
-            <a:srgbClr val="FFFFFF"/>
-          </a:solidFill>
-          <a:ln w="15875">
-            <a:solidFill>
-              <a:srgbClr val="C9CEDC"/>
-            </a:solidFill>
-          </a:ln>
-          <a:effectLst/>
-        </p:spPr>
-        <p:style>
-          <a:lnRef idx="1">
-            <a:schemeClr val="accent1"/>
-          </a:lnRef>
-          <a:fillRef idx="3">
-            <a:schemeClr val="accent1"/>
-          </a:fillRef>
-          <a:effectRef idx="2">
-            <a:schemeClr val="accent1"/>
-          </a:effectRef>
-          <a:fontRef idx="minor">
-            <a:schemeClr val="lt1"/>
-          </a:fontRef>
-        </p:style>
-        <p:txBody>
-          <a:bodyPr rtlCol="0" anchor="ctr"/>
-          <a:lstStyle/>
-          <a:p>
-            <a:pPr algn="ctr"/>
-          </a:p>
-        </p:txBody>
-      </p:sp>
-      <p:sp>
-        <p:nvSpPr>
-          <p:cNvPr id="11" name="Rectangle 10"/>
-          <p:cNvSpPr/>
-          <p:nvPr/>
-        </p:nvSpPr>
-        <p:spPr>
-          <a:xfrm>
-            <a:off x="271461" y="2154380"/>
-            <a:ext cx="11650663" cy="8000"/>
-          </a:xfrm>
-          <a:prstGeom prst="rect">
-            <a:avLst/>
-          </a:prstGeom>
-          <a:solidFill>
-            <a:srgbClr val="C9CEDC"/>
-          </a:solidFill>
-          <a:ln>
-            <a:noFill/>
-          </a:ln>
-          <a:effectLst/>
-        </p:spPr>
-        <p:style>
-          <a:lnRef idx="1">
-            <a:schemeClr val="accent1"/>
-          </a:lnRef>
-          <a:fillRef idx="3">
-            <a:schemeClr val="accent1"/>
-          </a:fillRef>
-          <a:effectRef idx="2">
-            <a:schemeClr val="accent1"/>
-          </a:effectRef>
-          <a:fontRef idx="minor">
-            <a:schemeClr val="lt1"/>
-          </a:fontRef>
-        </p:style>
-        <p:txBody>
-          <a:bodyPr rtlCol="0" anchor="ctr"/>
-          <a:lstStyle/>
-          <a:p>
-            <a:pPr algn="ctr"/>
-          </a:p>
-        </p:txBody>
-      </p:sp>
-      <p:pic>
-        <p:nvPicPr>
-          <p:cNvPr id="12" name="Picture 11" descr="highlighter.png"/>
-          <p:cNvPicPr>
-            <a:picLocks noChangeAspect="1"/>
-          </p:cNvPicPr>
-          <p:nvPr/>
-        </p:nvPicPr>
-        <p:blipFill>
-          <a:blip r:embed="rId3"/>
-          <a:stretch>
-            <a:fillRect/>
-          </a:stretch>
-        </p:blipFill>
-        <p:spPr>
-          <a:xfrm>
-            <a:off x="271461" y="2422198"/>
-            <a:ext cx="760000" cy="760000"/>
-          </a:xfrm>
-          <a:prstGeom prst="rect">
-            <a:avLst/>
-          </a:prstGeom>
-        </p:spPr>
-      </p:pic>
-      <p:sp>
-        <p:nvSpPr>
-          <p:cNvPr id="13" name="TextBox 12"/>
-          <p:cNvSpPr txBox="1"/>
-          <p:nvPr/>
-        </p:nvSpPr>
-        <p:spPr>
-          <a:xfrm>
-            <a:off x="1331461" y="2392198"/>
-            <a:ext cx="5200000" cy="760000"/>
-          </a:xfrm>
-          <a:prstGeom prst="rect">
-            <a:avLst/>
-          </a:prstGeom>
-          <a:noFill/>
-        </p:spPr>
-        <p:txBody>
-          <a:bodyPr wrap="square" anchor="ctr" lIns="0" rIns="0" tIns="0" bIns="0">
-            <a:spAutoFit/>
-          </a:bodyPr>
-          <a:lstStyle/>
-          <a:p>
-            <a:pPr algn="l"/>
-            <a:r>
-              <a:rPr sz="2400" b="1">
-                <a:solidFill>
-                  <a:srgbClr val="111111"/>
-                </a:solidFill>
-              </a:rPr>
-              <a:t>Highlighter</a:t>
+              <a:t>Drag with one finger to move around while zoomed in.</a:t>
             </a:r>
           </a:p>
           <a:p>
@@ -12254,334 +11958,12 @@
               </a:spcBef>
             </a:pPr>
             <a:r>
-              <a:rPr sz="1800" b="0">
+              <a:rPr sz="2000" b="0">
                 <a:solidFill>
-                  <a:srgbClr val="555B6B"/>
+                  <a:srgbClr val="FFFFFF"/>
                 </a:solidFill>
               </a:rPr>
-              <a:t>Transparent marks in the six UZH accent colours.</a:t>
-            </a:r>
-          </a:p>
-        </p:txBody>
-      </p:sp>
-      <p:sp>
-        <p:nvSpPr>
-          <p:cNvPr id="14" name="Oval 13"/>
-          <p:cNvSpPr/>
-          <p:nvPr/>
-        </p:nvSpPr>
-        <p:spPr>
-          <a:xfrm>
-            <a:off x="6771461" y="2562198"/>
-            <a:ext cx="480000" cy="480000"/>
-          </a:xfrm>
-          <a:prstGeom prst="ellipse">
-            <a:avLst/>
-          </a:prstGeom>
-          <a:solidFill>
-            <a:srgbClr val="FFC845"/>
-          </a:solidFill>
-          <a:ln>
-            <a:noFill/>
-          </a:ln>
-          <a:effectLst/>
-        </p:spPr>
-        <p:style>
-          <a:lnRef idx="1">
-            <a:schemeClr val="accent1"/>
-          </a:lnRef>
-          <a:fillRef idx="3">
-            <a:schemeClr val="accent1"/>
-          </a:fillRef>
-          <a:effectRef idx="2">
-            <a:schemeClr val="accent1"/>
-          </a:effectRef>
-          <a:fontRef idx="minor">
-            <a:schemeClr val="lt1"/>
-          </a:fontRef>
-        </p:style>
-        <p:txBody>
-          <a:bodyPr rtlCol="0" anchor="ctr"/>
-          <a:lstStyle/>
-          <a:p>
-            <a:pPr algn="ctr"/>
-          </a:p>
-        </p:txBody>
-      </p:sp>
-      <p:sp>
-        <p:nvSpPr>
-          <p:cNvPr id="15" name="Oval 14"/>
-          <p:cNvSpPr/>
-          <p:nvPr/>
-        </p:nvSpPr>
-        <p:spPr>
-          <a:xfrm>
-            <a:off x="7421461" y="2562198"/>
-            <a:ext cx="480000" cy="480000"/>
-          </a:xfrm>
-          <a:prstGeom prst="ellipse">
-            <a:avLst/>
-          </a:prstGeom>
-          <a:solidFill>
-            <a:srgbClr val="A4D233"/>
-          </a:solidFill>
-          <a:ln>
-            <a:noFill/>
-          </a:ln>
-          <a:effectLst/>
-        </p:spPr>
-        <p:style>
-          <a:lnRef idx="1">
-            <a:schemeClr val="accent1"/>
-          </a:lnRef>
-          <a:fillRef idx="3">
-            <a:schemeClr val="accent1"/>
-          </a:fillRef>
-          <a:effectRef idx="2">
-            <a:schemeClr val="accent1"/>
-          </a:effectRef>
-          <a:fontRef idx="minor">
-            <a:schemeClr val="lt1"/>
-          </a:fontRef>
-        </p:style>
-        <p:txBody>
-          <a:bodyPr rtlCol="0" anchor="ctr"/>
-          <a:lstStyle/>
-          <a:p>
-            <a:pPr algn="ctr"/>
-          </a:p>
-        </p:txBody>
-      </p:sp>
-      <p:sp>
-        <p:nvSpPr>
-          <p:cNvPr id="16" name="Oval 15"/>
-          <p:cNvSpPr/>
-          <p:nvPr/>
-        </p:nvSpPr>
-        <p:spPr>
-          <a:xfrm>
-            <a:off x="8071461" y="2562198"/>
-            <a:ext cx="480000" cy="480000"/>
-          </a:xfrm>
-          <a:prstGeom prst="ellipse">
-            <a:avLst/>
-          </a:prstGeom>
-          <a:solidFill>
-            <a:srgbClr val="4AC9E3"/>
-          </a:solidFill>
-          <a:ln>
-            <a:noFill/>
-          </a:ln>
-          <a:effectLst/>
-        </p:spPr>
-        <p:style>
-          <a:lnRef idx="1">
-            <a:schemeClr val="accent1"/>
-          </a:lnRef>
-          <a:fillRef idx="3">
-            <a:schemeClr val="accent1"/>
-          </a:fillRef>
-          <a:effectRef idx="2">
-            <a:schemeClr val="accent1"/>
-          </a:effectRef>
-          <a:fontRef idx="minor">
-            <a:schemeClr val="lt1"/>
-          </a:fontRef>
-        </p:style>
-        <p:txBody>
-          <a:bodyPr rtlCol="0" anchor="ctr"/>
-          <a:lstStyle/>
-          <a:p>
-            <a:pPr algn="ctr"/>
-          </a:p>
-        </p:txBody>
-      </p:sp>
-      <p:sp>
-        <p:nvSpPr>
-          <p:cNvPr id="17" name="Oval 16"/>
-          <p:cNvSpPr/>
-          <p:nvPr/>
-        </p:nvSpPr>
-        <p:spPr>
-          <a:xfrm>
-            <a:off x="8721461" y="2562198"/>
-            <a:ext cx="480000" cy="480000"/>
-          </a:xfrm>
-          <a:prstGeom prst="ellipse">
-            <a:avLst/>
-          </a:prstGeom>
-          <a:solidFill>
-            <a:srgbClr val="FC4C02"/>
-          </a:solidFill>
-          <a:ln>
-            <a:noFill/>
-          </a:ln>
-          <a:effectLst/>
-        </p:spPr>
-        <p:style>
-          <a:lnRef idx="1">
-            <a:schemeClr val="accent1"/>
-          </a:lnRef>
-          <a:fillRef idx="3">
-            <a:schemeClr val="accent1"/>
-          </a:fillRef>
-          <a:effectRef idx="2">
-            <a:schemeClr val="accent1"/>
-          </a:effectRef>
-          <a:fontRef idx="minor">
-            <a:schemeClr val="lt1"/>
-          </a:fontRef>
-        </p:style>
-        <p:txBody>
-          <a:bodyPr rtlCol="0" anchor="ctr"/>
-          <a:lstStyle/>
-          <a:p>
-            <a:pPr algn="ctr"/>
-          </a:p>
-        </p:txBody>
-      </p:sp>
-      <p:sp>
-        <p:nvSpPr>
-          <p:cNvPr id="18" name="Oval 17"/>
-          <p:cNvSpPr/>
-          <p:nvPr/>
-        </p:nvSpPr>
-        <p:spPr>
-          <a:xfrm>
-            <a:off x="9371461" y="2562198"/>
-            <a:ext cx="480000" cy="480000"/>
-          </a:xfrm>
-          <a:prstGeom prst="ellipse">
-            <a:avLst/>
-          </a:prstGeom>
-          <a:solidFill>
-            <a:srgbClr val="BF0D3E"/>
-          </a:solidFill>
-          <a:ln>
-            <a:noFill/>
-          </a:ln>
-          <a:effectLst/>
-        </p:spPr>
-        <p:style>
-          <a:lnRef idx="1">
-            <a:schemeClr val="accent1"/>
-          </a:lnRef>
-          <a:fillRef idx="3">
-            <a:schemeClr val="accent1"/>
-          </a:fillRef>
-          <a:effectRef idx="2">
-            <a:schemeClr val="accent1"/>
-          </a:effectRef>
-          <a:fontRef idx="minor">
-            <a:schemeClr val="lt1"/>
-          </a:fontRef>
-        </p:style>
-        <p:txBody>
-          <a:bodyPr rtlCol="0" anchor="ctr"/>
-          <a:lstStyle/>
-          <a:p>
-            <a:pPr algn="ctr"/>
-          </a:p>
-        </p:txBody>
-      </p:sp>
-      <p:sp>
-        <p:nvSpPr>
-          <p:cNvPr id="19" name="Rectangle 18"/>
-          <p:cNvSpPr/>
-          <p:nvPr/>
-        </p:nvSpPr>
-        <p:spPr>
-          <a:xfrm>
-            <a:off x="271461" y="3442016"/>
-            <a:ext cx="11650663" cy="8000"/>
-          </a:xfrm>
-          <a:prstGeom prst="rect">
-            <a:avLst/>
-          </a:prstGeom>
-          <a:solidFill>
-            <a:srgbClr val="C9CEDC"/>
-          </a:solidFill>
-          <a:ln>
-            <a:noFill/>
-          </a:ln>
-          <a:effectLst/>
-        </p:spPr>
-        <p:style>
-          <a:lnRef idx="1">
-            <a:schemeClr val="accent1"/>
-          </a:lnRef>
-          <a:fillRef idx="3">
-            <a:schemeClr val="accent1"/>
-          </a:fillRef>
-          <a:effectRef idx="2">
-            <a:schemeClr val="accent1"/>
-          </a:effectRef>
-          <a:fontRef idx="minor">
-            <a:schemeClr val="lt1"/>
-          </a:fontRef>
-        </p:style>
-        <p:txBody>
-          <a:bodyPr rtlCol="0" anchor="ctr"/>
-          <a:lstStyle/>
-          <a:p>
-            <a:pPr algn="ctr"/>
-          </a:p>
-        </p:txBody>
-      </p:sp>
-      <p:pic>
-        <p:nvPicPr>
-          <p:cNvPr id="20" name="Picture 19" descr="laser.png"/>
-          <p:cNvPicPr>
-            <a:picLocks noChangeAspect="1"/>
-          </p:cNvPicPr>
-          <p:nvPr/>
-        </p:nvPicPr>
-        <p:blipFill>
-          <a:blip r:embed="rId4"/>
-          <a:stretch>
-            <a:fillRect/>
-          </a:stretch>
-        </p:blipFill>
-        <p:spPr>
-          <a:xfrm>
-            <a:off x="271461" y="3709834"/>
-            <a:ext cx="760000" cy="760000"/>
-          </a:xfrm>
-          <a:prstGeom prst="rect">
-            <a:avLst/>
-          </a:prstGeom>
-        </p:spPr>
-      </p:pic>
-      <p:sp>
-        <p:nvSpPr>
-          <p:cNvPr id="21" name="TextBox 20"/>
-          <p:cNvSpPr txBox="1"/>
-          <p:nvPr/>
-        </p:nvSpPr>
-        <p:spPr>
-          <a:xfrm>
-            <a:off x="1331461" y="3679834"/>
-            <a:ext cx="5200000" cy="760000"/>
-          </a:xfrm>
-          <a:prstGeom prst="rect">
-            <a:avLst/>
-          </a:prstGeom>
-          <a:noFill/>
-        </p:spPr>
-        <p:txBody>
-          <a:bodyPr wrap="square" anchor="ctr" lIns="0" rIns="0" tIns="0" bIns="0">
-            <a:spAutoFit/>
-          </a:bodyPr>
-          <a:lstStyle/>
-          <a:p>
-            <a:pPr algn="l"/>
-            <a:r>
-              <a:rPr sz="2400" b="1">
-                <a:solidFill>
-                  <a:srgbClr val="111111"/>
-                </a:solidFill>
-              </a:rPr>
-              <a:t>Laser pointer</a:t>
+              <a:t>Double-tap to fit the whole slide again.</a:t>
             </a:r>
           </a:p>
           <a:p>
@@ -12591,217 +11973,12 @@
               </a:spcBef>
             </a:pPr>
             <a:r>
-              <a:rPr sz="1800" b="0">
+              <a:rPr sz="2000" b="0">
                 <a:solidFill>
-                  <a:srgbClr val="555B6B"/>
+                  <a:srgbClr val="FFFFFF"/>
                 </a:solidFill>
               </a:rPr>
-              <a:t>A fading trail that points without marking.</a:t>
-            </a:r>
-          </a:p>
-        </p:txBody>
-      </p:sp>
-      <p:sp>
-        <p:nvSpPr>
-          <p:cNvPr id="22" name="Oval 21"/>
-          <p:cNvSpPr/>
-          <p:nvPr/>
-        </p:nvSpPr>
-        <p:spPr>
-          <a:xfrm>
-            <a:off x="6771461" y="3849834"/>
-            <a:ext cx="480000" cy="480000"/>
-          </a:xfrm>
-          <a:prstGeom prst="ellipse">
-            <a:avLst/>
-          </a:prstGeom>
-          <a:solidFill>
-            <a:srgbClr val="BF0D3E"/>
-          </a:solidFill>
-          <a:ln>
-            <a:noFill/>
-          </a:ln>
-          <a:effectLst/>
-        </p:spPr>
-        <p:style>
-          <a:lnRef idx="1">
-            <a:schemeClr val="accent1"/>
-          </a:lnRef>
-          <a:fillRef idx="3">
-            <a:schemeClr val="accent1"/>
-          </a:fillRef>
-          <a:effectRef idx="2">
-            <a:schemeClr val="accent1"/>
-          </a:effectRef>
-          <a:fontRef idx="minor">
-            <a:schemeClr val="lt1"/>
-          </a:fontRef>
-        </p:style>
-        <p:txBody>
-          <a:bodyPr rtlCol="0" anchor="ctr"/>
-          <a:lstStyle/>
-          <a:p>
-            <a:pPr algn="ctr"/>
-          </a:p>
-        </p:txBody>
-      </p:sp>
-      <p:sp>
-        <p:nvSpPr>
-          <p:cNvPr id="23" name="Oval 22"/>
-          <p:cNvSpPr/>
-          <p:nvPr/>
-        </p:nvSpPr>
-        <p:spPr>
-          <a:xfrm>
-            <a:off x="7421461" y="3849834"/>
-            <a:ext cx="480000" cy="480000"/>
-          </a:xfrm>
-          <a:prstGeom prst="ellipse">
-            <a:avLst/>
-          </a:prstGeom>
-          <a:solidFill>
-            <a:srgbClr val="4E6B12"/>
-          </a:solidFill>
-          <a:ln>
-            <a:noFill/>
-          </a:ln>
-          <a:effectLst/>
-        </p:spPr>
-        <p:style>
-          <a:lnRef idx="1">
-            <a:schemeClr val="accent1"/>
-          </a:lnRef>
-          <a:fillRef idx="3">
-            <a:schemeClr val="accent1"/>
-          </a:fillRef>
-          <a:effectRef idx="2">
-            <a:schemeClr val="accent1"/>
-          </a:effectRef>
-          <a:fontRef idx="minor">
-            <a:schemeClr val="lt1"/>
-          </a:fontRef>
-        </p:style>
-        <p:txBody>
-          <a:bodyPr rtlCol="0" anchor="ctr"/>
-          <a:lstStyle/>
-          <a:p>
-            <a:pPr algn="ctr"/>
-          </a:p>
-        </p:txBody>
-      </p:sp>
-      <p:sp>
-        <p:nvSpPr>
-          <p:cNvPr id="24" name="Rectangle 23"/>
-          <p:cNvSpPr/>
-          <p:nvPr/>
-        </p:nvSpPr>
-        <p:spPr>
-          <a:xfrm>
-            <a:off x="271461" y="4729652"/>
-            <a:ext cx="11650663" cy="8000"/>
-          </a:xfrm>
-          <a:prstGeom prst="rect">
-            <a:avLst/>
-          </a:prstGeom>
-          <a:solidFill>
-            <a:srgbClr val="C9CEDC"/>
-          </a:solidFill>
-          <a:ln>
-            <a:noFill/>
-          </a:ln>
-          <a:effectLst/>
-        </p:spPr>
-        <p:style>
-          <a:lnRef idx="1">
-            <a:schemeClr val="accent1"/>
-          </a:lnRef>
-          <a:fillRef idx="3">
-            <a:schemeClr val="accent1"/>
-          </a:fillRef>
-          <a:effectRef idx="2">
-            <a:schemeClr val="accent1"/>
-          </a:effectRef>
-          <a:fontRef idx="minor">
-            <a:schemeClr val="lt1"/>
-          </a:fontRef>
-        </p:style>
-        <p:txBody>
-          <a:bodyPr rtlCol="0" anchor="ctr"/>
-          <a:lstStyle/>
-          <a:p>
-            <a:pPr algn="ctr"/>
-          </a:p>
-        </p:txBody>
-      </p:sp>
-      <p:pic>
-        <p:nvPicPr>
-          <p:cNvPr id="25" name="Picture 24" descr="eraser.png"/>
-          <p:cNvPicPr>
-            <a:picLocks noChangeAspect="1"/>
-          </p:cNvPicPr>
-          <p:nvPr/>
-        </p:nvPicPr>
-        <p:blipFill>
-          <a:blip r:embed="rId5"/>
-          <a:stretch>
-            <a:fillRect/>
-          </a:stretch>
-        </p:blipFill>
-        <p:spPr>
-          <a:xfrm>
-            <a:off x="271461" y="4997470"/>
-            <a:ext cx="760000" cy="760000"/>
-          </a:xfrm>
-          <a:prstGeom prst="rect">
-            <a:avLst/>
-          </a:prstGeom>
-        </p:spPr>
-      </p:pic>
-      <p:sp>
-        <p:nvSpPr>
-          <p:cNvPr id="26" name="TextBox 25"/>
-          <p:cNvSpPr txBox="1"/>
-          <p:nvPr/>
-        </p:nvSpPr>
-        <p:spPr>
-          <a:xfrm>
-            <a:off x="1331461" y="4967470"/>
-            <a:ext cx="5200000" cy="760000"/>
-          </a:xfrm>
-          <a:prstGeom prst="rect">
-            <a:avLst/>
-          </a:prstGeom>
-          <a:noFill/>
-        </p:spPr>
-        <p:txBody>
-          <a:bodyPr wrap="square" anchor="ctr" lIns="0" rIns="0" tIns="0" bIns="0">
-            <a:spAutoFit/>
-          </a:bodyPr>
-          <a:lstStyle/>
-          <a:p>
-            <a:pPr algn="l"/>
-            <a:r>
-              <a:rPr sz="2400" b="1">
-                <a:solidFill>
-                  <a:srgbClr val="111111"/>
-                </a:solidFill>
-              </a:rPr>
-              <a:t>Eraser</a:t>
-            </a:r>
-          </a:p>
-          <a:p>
-            <a:pPr algn="l">
-              <a:spcBef>
-                <a:spcPts val="600"/>
-              </a:spcBef>
-            </a:pPr>
-            <a:r>
-              <a:rPr sz="1800" b="0">
-                <a:solidFill>
-                  <a:srgbClr val="555B6B"/>
-                </a:solidFill>
-              </a:rPr>
-              <a:t>Touch a stroke with the Pencil to remove it.</a:t>
+              <a:t>The Pencil keeps writing while you are zoomed in.</a:t>
             </a:r>
           </a:p>
         </p:txBody>
@@ -12840,14 +12017,14 @@
           <a:lstStyle/>
           <a:p>
             <a:r>
-              <a:t>The toolbar, button by button</a:t>
+              <a:t>Tools: navigate, write, point, erase</a:t>
             </a:r>
           </a:p>
         </p:txBody>
       </p:sp>
       <p:pic>
         <p:nvPicPr>
-          <p:cNvPr id="3" name="Picture 2" descr="open.png"/>
+          <p:cNvPr id="3" name="Picture 2" descr="hand.png"/>
           <p:cNvPicPr>
             <a:picLocks noChangeAspect="1"/>
           </p:cNvPicPr>
@@ -12861,8 +12038,8 @@
         </p:blipFill>
         <p:spPr>
           <a:xfrm>
-            <a:off x="271461" y="1085798"/>
-            <a:ext cx="600000" cy="600000"/>
+            <a:off x="271461" y="1065798"/>
+            <a:ext cx="640000" cy="640000"/>
           </a:xfrm>
           <a:prstGeom prst="rect">
             <a:avLst/>
@@ -12877,8 +12054,8 @@
         </p:nvSpPr>
         <p:spPr>
           <a:xfrm>
-            <a:off x="1841461" y="1065798"/>
-            <a:ext cx="4055331" cy="600000"/>
+            <a:off x="1211461" y="1035798"/>
+            <a:ext cx="5200000" cy="640000"/>
           </a:xfrm>
           <a:prstGeom prst="rect">
             <a:avLst/>
@@ -12898,7 +12075,7 @@
                   <a:srgbClr val="111111"/>
                 </a:solidFill>
               </a:rPr>
-              <a:t>Open</a:t>
+              <a:t>Navigate</a:t>
             </a:r>
           </a:p>
           <a:p>
@@ -12913,14 +12090,58 @@
                   <a:srgbClr val="555B6B"/>
                 </a:solidFill>
               </a:rPr>
-              <a:t>Load a PDF from Files or iCloud Drive.</a:t>
-            </a:r>
+              <a:t>Tap or click to turn pages (Esc returns here).</a:t>
+            </a:r>
+          </a:p>
+        </p:txBody>
+      </p:sp>
+      <p:sp>
+        <p:nvSpPr>
+          <p:cNvPr id="5" name="Rectangle 4"/>
+          <p:cNvSpPr/>
+          <p:nvPr/>
+        </p:nvSpPr>
+        <p:spPr>
+          <a:xfrm>
+            <a:off x="271461" y="1896853"/>
+            <a:ext cx="11650663" cy="8000"/>
+          </a:xfrm>
+          <a:prstGeom prst="rect">
+            <a:avLst/>
+          </a:prstGeom>
+          <a:solidFill>
+            <a:srgbClr val="C9CEDC"/>
+          </a:solidFill>
+          <a:ln>
+            <a:noFill/>
+          </a:ln>
+          <a:effectLst/>
+        </p:spPr>
+        <p:style>
+          <a:lnRef idx="1">
+            <a:schemeClr val="accent1"/>
+          </a:lnRef>
+          <a:fillRef idx="3">
+            <a:schemeClr val="accent1"/>
+          </a:fillRef>
+          <a:effectRef idx="2">
+            <a:schemeClr val="accent1"/>
+          </a:effectRef>
+          <a:fontRef idx="minor">
+            <a:schemeClr val="lt1"/>
+          </a:fontRef>
+        </p:style>
+        <p:txBody>
+          <a:bodyPr rtlCol="0" anchor="ctr"/>
+          <a:lstStyle/>
+          <a:p>
+            <a:pPr algn="ctr"/>
           </a:p>
         </p:txBody>
       </p:sp>
       <p:pic>
         <p:nvPicPr>
-          <p:cNvPr id="5" name="Picture 4" descr="prev.png"/>
+          <p:cNvPr id="6" name="Picture 5" descr="pen.png"/>
           <p:cNvPicPr>
             <a:picLocks noChangeAspect="1"/>
           </p:cNvPicPr>
@@ -12934,17 +12155,376 @@
         </p:blipFill>
         <p:spPr>
           <a:xfrm>
-            <a:off x="271461" y="2115907"/>
-            <a:ext cx="600000" cy="600000"/>
+            <a:off x="271461" y="2095907"/>
+            <a:ext cx="640000" cy="640000"/>
           </a:xfrm>
           <a:prstGeom prst="rect">
             <a:avLst/>
           </a:prstGeom>
         </p:spPr>
       </p:pic>
+      <p:sp>
+        <p:nvSpPr>
+          <p:cNvPr id="7" name="TextBox 6"/>
+          <p:cNvSpPr txBox="1"/>
+          <p:nvPr/>
+        </p:nvSpPr>
+        <p:spPr>
+          <a:xfrm>
+            <a:off x="1211461" y="2065907"/>
+            <a:ext cx="5200000" cy="640000"/>
+          </a:xfrm>
+          <a:prstGeom prst="rect">
+            <a:avLst/>
+          </a:prstGeom>
+          <a:noFill/>
+        </p:spPr>
+        <p:txBody>
+          <a:bodyPr wrap="square" anchor="ctr" lIns="0" rIns="0" tIns="0" bIns="0">
+            <a:spAutoFit/>
+          </a:bodyPr>
+          <a:lstStyle/>
+          <a:p>
+            <a:pPr algn="l"/>
+            <a:r>
+              <a:rPr sz="2200" b="1">
+                <a:solidFill>
+                  <a:srgbClr val="111111"/>
+                </a:solidFill>
+              </a:rPr>
+              <a:t>Pen</a:t>
+            </a:r>
+          </a:p>
+          <a:p>
+            <a:pPr algn="l">
+              <a:spcBef>
+                <a:spcPts val="600"/>
+              </a:spcBef>
+            </a:pPr>
+            <a:r>
+              <a:rPr sz="1700" b="0">
+                <a:solidFill>
+                  <a:srgbClr val="555B6B"/>
+                </a:solidFill>
+              </a:rPr>
+              <a:t>Pressure-sensitive ink, up to 10 UZH colours.</a:t>
+            </a:r>
+          </a:p>
+        </p:txBody>
+      </p:sp>
+      <p:sp>
+        <p:nvSpPr>
+          <p:cNvPr id="8" name="Oval 7"/>
+          <p:cNvSpPr/>
+          <p:nvPr/>
+        </p:nvSpPr>
+        <p:spPr>
+          <a:xfrm>
+            <a:off x="6771461" y="2175907"/>
+            <a:ext cx="480000" cy="480000"/>
+          </a:xfrm>
+          <a:prstGeom prst="ellipse">
+            <a:avLst/>
+          </a:prstGeom>
+          <a:solidFill>
+            <a:srgbClr val="0028A5"/>
+          </a:solidFill>
+          <a:ln>
+            <a:noFill/>
+          </a:ln>
+          <a:effectLst/>
+        </p:spPr>
+        <p:style>
+          <a:lnRef idx="1">
+            <a:schemeClr val="accent1"/>
+          </a:lnRef>
+          <a:fillRef idx="3">
+            <a:schemeClr val="accent1"/>
+          </a:fillRef>
+          <a:effectRef idx="2">
+            <a:schemeClr val="accent1"/>
+          </a:effectRef>
+          <a:fontRef idx="minor">
+            <a:schemeClr val="lt1"/>
+          </a:fontRef>
+        </p:style>
+        <p:txBody>
+          <a:bodyPr rtlCol="0" anchor="ctr"/>
+          <a:lstStyle/>
+          <a:p>
+            <a:pPr algn="ctr"/>
+          </a:p>
+        </p:txBody>
+      </p:sp>
+      <p:sp>
+        <p:nvSpPr>
+          <p:cNvPr id="9" name="Oval 8"/>
+          <p:cNvSpPr/>
+          <p:nvPr/>
+        </p:nvSpPr>
+        <p:spPr>
+          <a:xfrm>
+            <a:off x="7421461" y="2175907"/>
+            <a:ext cx="480000" cy="480000"/>
+          </a:xfrm>
+          <a:prstGeom prst="ellipse">
+            <a:avLst/>
+          </a:prstGeom>
+          <a:solidFill>
+            <a:srgbClr val="FC4C02"/>
+          </a:solidFill>
+          <a:ln>
+            <a:noFill/>
+          </a:ln>
+          <a:effectLst/>
+        </p:spPr>
+        <p:style>
+          <a:lnRef idx="1">
+            <a:schemeClr val="accent1"/>
+          </a:lnRef>
+          <a:fillRef idx="3">
+            <a:schemeClr val="accent1"/>
+          </a:fillRef>
+          <a:effectRef idx="2">
+            <a:schemeClr val="accent1"/>
+          </a:effectRef>
+          <a:fontRef idx="minor">
+            <a:schemeClr val="lt1"/>
+          </a:fontRef>
+        </p:style>
+        <p:txBody>
+          <a:bodyPr rtlCol="0" anchor="ctr"/>
+          <a:lstStyle/>
+          <a:p>
+            <a:pPr algn="ctr"/>
+          </a:p>
+        </p:txBody>
+      </p:sp>
+      <p:sp>
+        <p:nvSpPr>
+          <p:cNvPr id="10" name="Oval 9"/>
+          <p:cNvSpPr/>
+          <p:nvPr/>
+        </p:nvSpPr>
+        <p:spPr>
+          <a:xfrm>
+            <a:off x="8071461" y="2175907"/>
+            <a:ext cx="480000" cy="480000"/>
+          </a:xfrm>
+          <a:prstGeom prst="ellipse">
+            <a:avLst/>
+          </a:prstGeom>
+          <a:solidFill>
+            <a:srgbClr val="FFC845"/>
+          </a:solidFill>
+          <a:ln>
+            <a:noFill/>
+          </a:ln>
+          <a:effectLst/>
+        </p:spPr>
+        <p:style>
+          <a:lnRef idx="1">
+            <a:schemeClr val="accent1"/>
+          </a:lnRef>
+          <a:fillRef idx="3">
+            <a:schemeClr val="accent1"/>
+          </a:fillRef>
+          <a:effectRef idx="2">
+            <a:schemeClr val="accent1"/>
+          </a:effectRef>
+          <a:fontRef idx="minor">
+            <a:schemeClr val="lt1"/>
+          </a:fontRef>
+        </p:style>
+        <p:txBody>
+          <a:bodyPr rtlCol="0" anchor="ctr"/>
+          <a:lstStyle/>
+          <a:p>
+            <a:pPr algn="ctr"/>
+          </a:p>
+        </p:txBody>
+      </p:sp>
+      <p:sp>
+        <p:nvSpPr>
+          <p:cNvPr id="11" name="Oval 10"/>
+          <p:cNvSpPr/>
+          <p:nvPr/>
+        </p:nvSpPr>
+        <p:spPr>
+          <a:xfrm>
+            <a:off x="8721461" y="2175907"/>
+            <a:ext cx="480000" cy="480000"/>
+          </a:xfrm>
+          <a:prstGeom prst="ellipse">
+            <a:avLst/>
+          </a:prstGeom>
+          <a:solidFill>
+            <a:srgbClr val="A4D233"/>
+          </a:solidFill>
+          <a:ln>
+            <a:noFill/>
+          </a:ln>
+          <a:effectLst/>
+        </p:spPr>
+        <p:style>
+          <a:lnRef idx="1">
+            <a:schemeClr val="accent1"/>
+          </a:lnRef>
+          <a:fillRef idx="3">
+            <a:schemeClr val="accent1"/>
+          </a:fillRef>
+          <a:effectRef idx="2">
+            <a:schemeClr val="accent1"/>
+          </a:effectRef>
+          <a:fontRef idx="minor">
+            <a:schemeClr val="lt1"/>
+          </a:fontRef>
+        </p:style>
+        <p:txBody>
+          <a:bodyPr rtlCol="0" anchor="ctr"/>
+          <a:lstStyle/>
+          <a:p>
+            <a:pPr algn="ctr"/>
+          </a:p>
+        </p:txBody>
+      </p:sp>
+      <p:sp>
+        <p:nvSpPr>
+          <p:cNvPr id="12" name="Oval 11"/>
+          <p:cNvSpPr/>
+          <p:nvPr/>
+        </p:nvSpPr>
+        <p:spPr>
+          <a:xfrm>
+            <a:off x="9371461" y="2175907"/>
+            <a:ext cx="480000" cy="480000"/>
+          </a:xfrm>
+          <a:prstGeom prst="ellipse">
+            <a:avLst/>
+          </a:prstGeom>
+          <a:solidFill>
+            <a:srgbClr val="000000"/>
+          </a:solidFill>
+          <a:ln>
+            <a:noFill/>
+          </a:ln>
+          <a:effectLst/>
+        </p:spPr>
+        <p:style>
+          <a:lnRef idx="1">
+            <a:schemeClr val="accent1"/>
+          </a:lnRef>
+          <a:fillRef idx="3">
+            <a:schemeClr val="accent1"/>
+          </a:fillRef>
+          <a:effectRef idx="2">
+            <a:schemeClr val="accent1"/>
+          </a:effectRef>
+          <a:fontRef idx="minor">
+            <a:schemeClr val="lt1"/>
+          </a:fontRef>
+        </p:style>
+        <p:txBody>
+          <a:bodyPr rtlCol="0" anchor="ctr"/>
+          <a:lstStyle/>
+          <a:p>
+            <a:pPr algn="ctr"/>
+          </a:p>
+        </p:txBody>
+      </p:sp>
+      <p:sp>
+        <p:nvSpPr>
+          <p:cNvPr id="13" name="Oval 12"/>
+          <p:cNvSpPr/>
+          <p:nvPr/>
+        </p:nvSpPr>
+        <p:spPr>
+          <a:xfrm>
+            <a:off x="10021461" y="2175907"/>
+            <a:ext cx="480000" cy="480000"/>
+          </a:xfrm>
+          <a:prstGeom prst="ellipse">
+            <a:avLst/>
+          </a:prstGeom>
+          <a:solidFill>
+            <a:srgbClr val="FFFFFF"/>
+          </a:solidFill>
+          <a:ln w="15875">
+            <a:solidFill>
+              <a:srgbClr val="C9CEDC"/>
+            </a:solidFill>
+          </a:ln>
+          <a:effectLst/>
+        </p:spPr>
+        <p:style>
+          <a:lnRef idx="1">
+            <a:schemeClr val="accent1"/>
+          </a:lnRef>
+          <a:fillRef idx="3">
+            <a:schemeClr val="accent1"/>
+          </a:fillRef>
+          <a:effectRef idx="2">
+            <a:schemeClr val="accent1"/>
+          </a:effectRef>
+          <a:fontRef idx="minor">
+            <a:schemeClr val="lt1"/>
+          </a:fontRef>
+        </p:style>
+        <p:txBody>
+          <a:bodyPr rtlCol="0" anchor="ctr"/>
+          <a:lstStyle/>
+          <a:p>
+            <a:pPr algn="ctr"/>
+          </a:p>
+        </p:txBody>
+      </p:sp>
+      <p:sp>
+        <p:nvSpPr>
+          <p:cNvPr id="14" name="Rectangle 13"/>
+          <p:cNvSpPr/>
+          <p:nvPr/>
+        </p:nvSpPr>
+        <p:spPr>
+          <a:xfrm>
+            <a:off x="271461" y="2926962"/>
+            <a:ext cx="11650663" cy="8000"/>
+          </a:xfrm>
+          <a:prstGeom prst="rect">
+            <a:avLst/>
+          </a:prstGeom>
+          <a:solidFill>
+            <a:srgbClr val="C9CEDC"/>
+          </a:solidFill>
+          <a:ln>
+            <a:noFill/>
+          </a:ln>
+          <a:effectLst/>
+        </p:spPr>
+        <p:style>
+          <a:lnRef idx="1">
+            <a:schemeClr val="accent1"/>
+          </a:lnRef>
+          <a:fillRef idx="3">
+            <a:schemeClr val="accent1"/>
+          </a:fillRef>
+          <a:effectRef idx="2">
+            <a:schemeClr val="accent1"/>
+          </a:effectRef>
+          <a:fontRef idx="minor">
+            <a:schemeClr val="lt1"/>
+          </a:fontRef>
+        </p:style>
+        <p:txBody>
+          <a:bodyPr rtlCol="0" anchor="ctr"/>
+          <a:lstStyle/>
+          <a:p>
+            <a:pPr algn="ctr"/>
+          </a:p>
+        </p:txBody>
+      </p:sp>
       <p:pic>
         <p:nvPicPr>
-          <p:cNvPr id="6" name="Picture 5" descr="next.png"/>
+          <p:cNvPr id="15" name="Picture 14" descr="highlighter.png"/>
           <p:cNvPicPr>
             <a:picLocks noChangeAspect="1"/>
           </p:cNvPicPr>
@@ -12958,8 +12538,8 @@
         </p:blipFill>
         <p:spPr>
           <a:xfrm>
-            <a:off x="961461" y="2115907"/>
-            <a:ext cx="600000" cy="600000"/>
+            <a:off x="271461" y="3126016"/>
+            <a:ext cx="640000" cy="640000"/>
           </a:xfrm>
           <a:prstGeom prst="rect">
             <a:avLst/>
@@ -12968,14 +12548,14 @@
       </p:pic>
       <p:sp>
         <p:nvSpPr>
-          <p:cNvPr id="7" name="TextBox 6"/>
+          <p:cNvPr id="16" name="TextBox 15"/>
           <p:cNvSpPr txBox="1"/>
           <p:nvPr/>
         </p:nvSpPr>
         <p:spPr>
           <a:xfrm>
-            <a:off x="1841461" y="2095907"/>
-            <a:ext cx="4055331" cy="600000"/>
+            <a:off x="1211461" y="3096016"/>
+            <a:ext cx="5200000" cy="640000"/>
           </a:xfrm>
           <a:prstGeom prst="rect">
             <a:avLst/>
@@ -12995,7 +12575,7 @@
                   <a:srgbClr val="111111"/>
                 </a:solidFill>
               </a:rPr>
-              <a:t>Previous / next</a:t>
+              <a:t>Highlighter</a:t>
             </a:r>
           </a:p>
           <a:p>
@@ -13010,14 +12590,278 @@
                   <a:srgbClr val="555B6B"/>
                 </a:solidFill>
               </a:rPr>
-              <a:t>Same as tapping the left or right third.</a:t>
-            </a:r>
+              <a:t>Transparent marks in the six UZH accent colours.</a:t>
+            </a:r>
+          </a:p>
+        </p:txBody>
+      </p:sp>
+      <p:sp>
+        <p:nvSpPr>
+          <p:cNvPr id="17" name="Oval 16"/>
+          <p:cNvSpPr/>
+          <p:nvPr/>
+        </p:nvSpPr>
+        <p:spPr>
+          <a:xfrm>
+            <a:off x="6771461" y="3206016"/>
+            <a:ext cx="480000" cy="480000"/>
+          </a:xfrm>
+          <a:prstGeom prst="ellipse">
+            <a:avLst/>
+          </a:prstGeom>
+          <a:solidFill>
+            <a:srgbClr val="FFC845"/>
+          </a:solidFill>
+          <a:ln>
+            <a:noFill/>
+          </a:ln>
+          <a:effectLst/>
+        </p:spPr>
+        <p:style>
+          <a:lnRef idx="1">
+            <a:schemeClr val="accent1"/>
+          </a:lnRef>
+          <a:fillRef idx="3">
+            <a:schemeClr val="accent1"/>
+          </a:fillRef>
+          <a:effectRef idx="2">
+            <a:schemeClr val="accent1"/>
+          </a:effectRef>
+          <a:fontRef idx="minor">
+            <a:schemeClr val="lt1"/>
+          </a:fontRef>
+        </p:style>
+        <p:txBody>
+          <a:bodyPr rtlCol="0" anchor="ctr"/>
+          <a:lstStyle/>
+          <a:p>
+            <a:pPr algn="ctr"/>
+          </a:p>
+        </p:txBody>
+      </p:sp>
+      <p:sp>
+        <p:nvSpPr>
+          <p:cNvPr id="18" name="Oval 17"/>
+          <p:cNvSpPr/>
+          <p:nvPr/>
+        </p:nvSpPr>
+        <p:spPr>
+          <a:xfrm>
+            <a:off x="7421461" y="3206016"/>
+            <a:ext cx="480000" cy="480000"/>
+          </a:xfrm>
+          <a:prstGeom prst="ellipse">
+            <a:avLst/>
+          </a:prstGeom>
+          <a:solidFill>
+            <a:srgbClr val="A4D233"/>
+          </a:solidFill>
+          <a:ln>
+            <a:noFill/>
+          </a:ln>
+          <a:effectLst/>
+        </p:spPr>
+        <p:style>
+          <a:lnRef idx="1">
+            <a:schemeClr val="accent1"/>
+          </a:lnRef>
+          <a:fillRef idx="3">
+            <a:schemeClr val="accent1"/>
+          </a:fillRef>
+          <a:effectRef idx="2">
+            <a:schemeClr val="accent1"/>
+          </a:effectRef>
+          <a:fontRef idx="minor">
+            <a:schemeClr val="lt1"/>
+          </a:fontRef>
+        </p:style>
+        <p:txBody>
+          <a:bodyPr rtlCol="0" anchor="ctr"/>
+          <a:lstStyle/>
+          <a:p>
+            <a:pPr algn="ctr"/>
+          </a:p>
+        </p:txBody>
+      </p:sp>
+      <p:sp>
+        <p:nvSpPr>
+          <p:cNvPr id="19" name="Oval 18"/>
+          <p:cNvSpPr/>
+          <p:nvPr/>
+        </p:nvSpPr>
+        <p:spPr>
+          <a:xfrm>
+            <a:off x="8071461" y="3206016"/>
+            <a:ext cx="480000" cy="480000"/>
+          </a:xfrm>
+          <a:prstGeom prst="ellipse">
+            <a:avLst/>
+          </a:prstGeom>
+          <a:solidFill>
+            <a:srgbClr val="4AC9E3"/>
+          </a:solidFill>
+          <a:ln>
+            <a:noFill/>
+          </a:ln>
+          <a:effectLst/>
+        </p:spPr>
+        <p:style>
+          <a:lnRef idx="1">
+            <a:schemeClr val="accent1"/>
+          </a:lnRef>
+          <a:fillRef idx="3">
+            <a:schemeClr val="accent1"/>
+          </a:fillRef>
+          <a:effectRef idx="2">
+            <a:schemeClr val="accent1"/>
+          </a:effectRef>
+          <a:fontRef idx="minor">
+            <a:schemeClr val="lt1"/>
+          </a:fontRef>
+        </p:style>
+        <p:txBody>
+          <a:bodyPr rtlCol="0" anchor="ctr"/>
+          <a:lstStyle/>
+          <a:p>
+            <a:pPr algn="ctr"/>
+          </a:p>
+        </p:txBody>
+      </p:sp>
+      <p:sp>
+        <p:nvSpPr>
+          <p:cNvPr id="20" name="Oval 19"/>
+          <p:cNvSpPr/>
+          <p:nvPr/>
+        </p:nvSpPr>
+        <p:spPr>
+          <a:xfrm>
+            <a:off x="8721461" y="3206016"/>
+            <a:ext cx="480000" cy="480000"/>
+          </a:xfrm>
+          <a:prstGeom prst="ellipse">
+            <a:avLst/>
+          </a:prstGeom>
+          <a:solidFill>
+            <a:srgbClr val="FC4C02"/>
+          </a:solidFill>
+          <a:ln>
+            <a:noFill/>
+          </a:ln>
+          <a:effectLst/>
+        </p:spPr>
+        <p:style>
+          <a:lnRef idx="1">
+            <a:schemeClr val="accent1"/>
+          </a:lnRef>
+          <a:fillRef idx="3">
+            <a:schemeClr val="accent1"/>
+          </a:fillRef>
+          <a:effectRef idx="2">
+            <a:schemeClr val="accent1"/>
+          </a:effectRef>
+          <a:fontRef idx="minor">
+            <a:schemeClr val="lt1"/>
+          </a:fontRef>
+        </p:style>
+        <p:txBody>
+          <a:bodyPr rtlCol="0" anchor="ctr"/>
+          <a:lstStyle/>
+          <a:p>
+            <a:pPr algn="ctr"/>
+          </a:p>
+        </p:txBody>
+      </p:sp>
+      <p:sp>
+        <p:nvSpPr>
+          <p:cNvPr id="21" name="Oval 20"/>
+          <p:cNvSpPr/>
+          <p:nvPr/>
+        </p:nvSpPr>
+        <p:spPr>
+          <a:xfrm>
+            <a:off x="9371461" y="3206016"/>
+            <a:ext cx="480000" cy="480000"/>
+          </a:xfrm>
+          <a:prstGeom prst="ellipse">
+            <a:avLst/>
+          </a:prstGeom>
+          <a:solidFill>
+            <a:srgbClr val="BF0D3E"/>
+          </a:solidFill>
+          <a:ln>
+            <a:noFill/>
+          </a:ln>
+          <a:effectLst/>
+        </p:spPr>
+        <p:style>
+          <a:lnRef idx="1">
+            <a:schemeClr val="accent1"/>
+          </a:lnRef>
+          <a:fillRef idx="3">
+            <a:schemeClr val="accent1"/>
+          </a:fillRef>
+          <a:effectRef idx="2">
+            <a:schemeClr val="accent1"/>
+          </a:effectRef>
+          <a:fontRef idx="minor">
+            <a:schemeClr val="lt1"/>
+          </a:fontRef>
+        </p:style>
+        <p:txBody>
+          <a:bodyPr rtlCol="0" anchor="ctr"/>
+          <a:lstStyle/>
+          <a:p>
+            <a:pPr algn="ctr"/>
+          </a:p>
+        </p:txBody>
+      </p:sp>
+      <p:sp>
+        <p:nvSpPr>
+          <p:cNvPr id="22" name="Rectangle 21"/>
+          <p:cNvSpPr/>
+          <p:nvPr/>
+        </p:nvSpPr>
+        <p:spPr>
+          <a:xfrm>
+            <a:off x="271461" y="3957071"/>
+            <a:ext cx="11650663" cy="8000"/>
+          </a:xfrm>
+          <a:prstGeom prst="rect">
+            <a:avLst/>
+          </a:prstGeom>
+          <a:solidFill>
+            <a:srgbClr val="C9CEDC"/>
+          </a:solidFill>
+          <a:ln>
+            <a:noFill/>
+          </a:ln>
+          <a:effectLst/>
+        </p:spPr>
+        <p:style>
+          <a:lnRef idx="1">
+            <a:schemeClr val="accent1"/>
+          </a:lnRef>
+          <a:fillRef idx="3">
+            <a:schemeClr val="accent1"/>
+          </a:fillRef>
+          <a:effectRef idx="2">
+            <a:schemeClr val="accent1"/>
+          </a:effectRef>
+          <a:fontRef idx="minor">
+            <a:schemeClr val="lt1"/>
+          </a:fontRef>
+        </p:style>
+        <p:txBody>
+          <a:bodyPr rtlCol="0" anchor="ctr"/>
+          <a:lstStyle/>
+          <a:p>
+            <a:pPr algn="ctr"/>
           </a:p>
         </p:txBody>
       </p:sp>
       <p:pic>
         <p:nvPicPr>
-          <p:cNvPr id="8" name="Picture 7" descr="grid.png"/>
+          <p:cNvPr id="23" name="Picture 22" descr="laser.png"/>
           <p:cNvPicPr>
             <a:picLocks noChangeAspect="1"/>
           </p:cNvPicPr>
@@ -13031,8 +12875,8 @@
         </p:blipFill>
         <p:spPr>
           <a:xfrm>
-            <a:off x="271461" y="3146016"/>
-            <a:ext cx="600000" cy="600000"/>
+            <a:off x="271461" y="4156125"/>
+            <a:ext cx="640000" cy="640000"/>
           </a:xfrm>
           <a:prstGeom prst="rect">
             <a:avLst/>
@@ -13041,14 +12885,14 @@
       </p:pic>
       <p:sp>
         <p:nvSpPr>
-          <p:cNvPr id="9" name="TextBox 8"/>
+          <p:cNvPr id="24" name="TextBox 23"/>
           <p:cNvSpPr txBox="1"/>
           <p:nvPr/>
         </p:nvSpPr>
         <p:spPr>
           <a:xfrm>
-            <a:off x="1841461" y="3126016"/>
-            <a:ext cx="4055331" cy="600000"/>
+            <a:off x="1211461" y="4126125"/>
+            <a:ext cx="5200000" cy="640000"/>
           </a:xfrm>
           <a:prstGeom prst="rect">
             <a:avLst/>
@@ -13068,7 +12912,7 @@
                   <a:srgbClr val="111111"/>
                 </a:solidFill>
               </a:rPr>
-              <a:t>Slide overview</a:t>
+              <a:t>Laser pointer</a:t>
             </a:r>
           </a:p>
           <a:p>
@@ -13083,14 +12927,146 @@
                   <a:srgbClr val="555B6B"/>
                 </a:solidFill>
               </a:rPr>
-              <a:t>Same as the lower-quarter triple-tap.</a:t>
-            </a:r>
+              <a:t>A fading trail that points without marking.</a:t>
+            </a:r>
+          </a:p>
+        </p:txBody>
+      </p:sp>
+      <p:sp>
+        <p:nvSpPr>
+          <p:cNvPr id="25" name="Oval 24"/>
+          <p:cNvSpPr/>
+          <p:nvPr/>
+        </p:nvSpPr>
+        <p:spPr>
+          <a:xfrm>
+            <a:off x="6771461" y="4236125"/>
+            <a:ext cx="480000" cy="480000"/>
+          </a:xfrm>
+          <a:prstGeom prst="ellipse">
+            <a:avLst/>
+          </a:prstGeom>
+          <a:solidFill>
+            <a:srgbClr val="BF0D3E"/>
+          </a:solidFill>
+          <a:ln>
+            <a:noFill/>
+          </a:ln>
+          <a:effectLst/>
+        </p:spPr>
+        <p:style>
+          <a:lnRef idx="1">
+            <a:schemeClr val="accent1"/>
+          </a:lnRef>
+          <a:fillRef idx="3">
+            <a:schemeClr val="accent1"/>
+          </a:fillRef>
+          <a:effectRef idx="2">
+            <a:schemeClr val="accent1"/>
+          </a:effectRef>
+          <a:fontRef idx="minor">
+            <a:schemeClr val="lt1"/>
+          </a:fontRef>
+        </p:style>
+        <p:txBody>
+          <a:bodyPr rtlCol="0" anchor="ctr"/>
+          <a:lstStyle/>
+          <a:p>
+            <a:pPr algn="ctr"/>
+          </a:p>
+        </p:txBody>
+      </p:sp>
+      <p:sp>
+        <p:nvSpPr>
+          <p:cNvPr id="26" name="Oval 25"/>
+          <p:cNvSpPr/>
+          <p:nvPr/>
+        </p:nvSpPr>
+        <p:spPr>
+          <a:xfrm>
+            <a:off x="7421461" y="4236125"/>
+            <a:ext cx="480000" cy="480000"/>
+          </a:xfrm>
+          <a:prstGeom prst="ellipse">
+            <a:avLst/>
+          </a:prstGeom>
+          <a:solidFill>
+            <a:srgbClr val="4E6B12"/>
+          </a:solidFill>
+          <a:ln>
+            <a:noFill/>
+          </a:ln>
+          <a:effectLst/>
+        </p:spPr>
+        <p:style>
+          <a:lnRef idx="1">
+            <a:schemeClr val="accent1"/>
+          </a:lnRef>
+          <a:fillRef idx="3">
+            <a:schemeClr val="accent1"/>
+          </a:fillRef>
+          <a:effectRef idx="2">
+            <a:schemeClr val="accent1"/>
+          </a:effectRef>
+          <a:fontRef idx="minor">
+            <a:schemeClr val="lt1"/>
+          </a:fontRef>
+        </p:style>
+        <p:txBody>
+          <a:bodyPr rtlCol="0" anchor="ctr"/>
+          <a:lstStyle/>
+          <a:p>
+            <a:pPr algn="ctr"/>
+          </a:p>
+        </p:txBody>
+      </p:sp>
+      <p:sp>
+        <p:nvSpPr>
+          <p:cNvPr id="27" name="Rectangle 26"/>
+          <p:cNvSpPr/>
+          <p:nvPr/>
+        </p:nvSpPr>
+        <p:spPr>
+          <a:xfrm>
+            <a:off x="271461" y="4987180"/>
+            <a:ext cx="11650663" cy="8000"/>
+          </a:xfrm>
+          <a:prstGeom prst="rect">
+            <a:avLst/>
+          </a:prstGeom>
+          <a:solidFill>
+            <a:srgbClr val="C9CEDC"/>
+          </a:solidFill>
+          <a:ln>
+            <a:noFill/>
+          </a:ln>
+          <a:effectLst/>
+        </p:spPr>
+        <p:style>
+          <a:lnRef idx="1">
+            <a:schemeClr val="accent1"/>
+          </a:lnRef>
+          <a:fillRef idx="3">
+            <a:schemeClr val="accent1"/>
+          </a:fillRef>
+          <a:effectRef idx="2">
+            <a:schemeClr val="accent1"/>
+          </a:effectRef>
+          <a:fontRef idx="minor">
+            <a:schemeClr val="lt1"/>
+          </a:fontRef>
+        </p:style>
+        <p:txBody>
+          <a:bodyPr rtlCol="0" anchor="ctr"/>
+          <a:lstStyle/>
+          <a:p>
+            <a:pPr algn="ctr"/>
           </a:p>
         </p:txBody>
       </p:sp>
       <p:pic>
         <p:nvPicPr>
-          <p:cNvPr id="10" name="Picture 9" descr="undo.png"/>
+          <p:cNvPr id="28" name="Picture 27" descr="eraser.png"/>
           <p:cNvPicPr>
             <a:picLocks noChangeAspect="1"/>
           </p:cNvPicPr>
@@ -13104,8 +13080,8 @@
         </p:blipFill>
         <p:spPr>
           <a:xfrm>
-            <a:off x="271461" y="4176125"/>
-            <a:ext cx="600000" cy="600000"/>
+            <a:off x="271461" y="5186234"/>
+            <a:ext cx="640000" cy="640000"/>
           </a:xfrm>
           <a:prstGeom prst="rect">
             <a:avLst/>
@@ -13114,14 +13090,14 @@
       </p:pic>
       <p:sp>
         <p:nvSpPr>
-          <p:cNvPr id="11" name="TextBox 10"/>
+          <p:cNvPr id="29" name="TextBox 28"/>
           <p:cNvSpPr txBox="1"/>
           <p:nvPr/>
         </p:nvSpPr>
         <p:spPr>
           <a:xfrm>
-            <a:off x="1841461" y="4156125"/>
-            <a:ext cx="4055331" cy="600000"/>
+            <a:off x="1211461" y="5156234"/>
+            <a:ext cx="5200000" cy="640000"/>
           </a:xfrm>
           <a:prstGeom prst="rect">
             <a:avLst/>
@@ -13141,7 +13117,7 @@
                   <a:srgbClr val="111111"/>
                 </a:solidFill>
               </a:rPr>
-              <a:t>Undo</a:t>
+              <a:t>Eraser</a:t>
             </a:r>
           </a:p>
           <a:p>
@@ -13156,445 +13132,7 @@
                   <a:srgbClr val="555B6B"/>
                 </a:solidFill>
               </a:rPr>
-              <a:t>Takes back the last change on this slide.</a:t>
-            </a:r>
-          </a:p>
-        </p:txBody>
-      </p:sp>
-      <p:pic>
-        <p:nvPicPr>
-          <p:cNvPr id="12" name="Picture 11" descr="clear.png"/>
-          <p:cNvPicPr>
-            <a:picLocks noChangeAspect="1"/>
-          </p:cNvPicPr>
-          <p:nvPr/>
-        </p:nvPicPr>
-        <p:blipFill>
-          <a:blip r:embed="rId7"/>
-          <a:stretch>
-            <a:fillRect/>
-          </a:stretch>
-        </p:blipFill>
-        <p:spPr>
-          <a:xfrm>
-            <a:off x="271461" y="5206234"/>
-            <a:ext cx="600000" cy="600000"/>
-          </a:xfrm>
-          <a:prstGeom prst="rect">
-            <a:avLst/>
-          </a:prstGeom>
-        </p:spPr>
-      </p:pic>
-      <p:sp>
-        <p:nvSpPr>
-          <p:cNvPr id="13" name="TextBox 12"/>
-          <p:cNvSpPr txBox="1"/>
-          <p:nvPr/>
-        </p:nvSpPr>
-        <p:spPr>
-          <a:xfrm>
-            <a:off x="1841461" y="5186234"/>
-            <a:ext cx="4055331" cy="600000"/>
-          </a:xfrm>
-          <a:prstGeom prst="rect">
-            <a:avLst/>
-          </a:prstGeom>
-          <a:noFill/>
-        </p:spPr>
-        <p:txBody>
-          <a:bodyPr wrap="square" anchor="ctr" lIns="0" rIns="0" tIns="0" bIns="0">
-            <a:spAutoFit/>
-          </a:bodyPr>
-          <a:lstStyle/>
-          <a:p>
-            <a:pPr algn="l"/>
-            <a:r>
-              <a:rPr sz="2200" b="1">
-                <a:solidFill>
-                  <a:srgbClr val="111111"/>
-                </a:solidFill>
-              </a:rPr>
-              <a:t>Clear</a:t>
-            </a:r>
-          </a:p>
-          <a:p>
-            <a:pPr algn="l">
-              <a:spcBef>
-                <a:spcPts val="600"/>
-              </a:spcBef>
-            </a:pPr>
-            <a:r>
-              <a:rPr sz="1700" b="0">
-                <a:solidFill>
-                  <a:srgbClr val="555B6B"/>
-                </a:solidFill>
-              </a:rPr>
-              <a:t>Removes all ink on this slide.</a:t>
-            </a:r>
-          </a:p>
-        </p:txBody>
-      </p:sp>
-      <p:pic>
-        <p:nvPicPr>
-          <p:cNvPr id="14" name="Picture 13" descr="save.png"/>
-          <p:cNvPicPr>
-            <a:picLocks noChangeAspect="1"/>
-          </p:cNvPicPr>
-          <p:nvPr/>
-        </p:nvPicPr>
-        <p:blipFill>
-          <a:blip r:embed="rId8"/>
-          <a:stretch>
-            <a:fillRect/>
-          </a:stretch>
-        </p:blipFill>
-        <p:spPr>
-          <a:xfrm>
-            <a:off x="6096792" y="1085798"/>
-            <a:ext cx="600000" cy="600000"/>
-          </a:xfrm>
-          <a:prstGeom prst="rect">
-            <a:avLst/>
-          </a:prstGeom>
-        </p:spPr>
-      </p:pic>
-      <p:sp>
-        <p:nvSpPr>
-          <p:cNvPr id="15" name="TextBox 14"/>
-          <p:cNvSpPr txBox="1"/>
-          <p:nvPr/>
-        </p:nvSpPr>
-        <p:spPr>
-          <a:xfrm>
-            <a:off x="7666792" y="1065798"/>
-            <a:ext cx="4055331" cy="600000"/>
-          </a:xfrm>
-          <a:prstGeom prst="rect">
-            <a:avLst/>
-          </a:prstGeom>
-          <a:noFill/>
-        </p:spPr>
-        <p:txBody>
-          <a:bodyPr wrap="square" anchor="ctr" lIns="0" rIns="0" tIns="0" bIns="0">
-            <a:spAutoFit/>
-          </a:bodyPr>
-          <a:lstStyle/>
-          <a:p>
-            <a:pPr algn="l"/>
-            <a:r>
-              <a:rPr sz="2200" b="1">
-                <a:solidFill>
-                  <a:srgbClr val="111111"/>
-                </a:solidFill>
-              </a:rPr>
-              <a:t>Save</a:t>
-            </a:r>
-          </a:p>
-          <a:p>
-            <a:pPr algn="l">
-              <a:spcBef>
-                <a:spcPts val="600"/>
-              </a:spcBef>
-            </a:pPr>
-            <a:r>
-              <a:rPr sz="1700" b="0">
-                <a:solidFill>
-                  <a:srgbClr val="555B6B"/>
-                </a:solidFill>
-              </a:rPr>
-              <a:t>Writes your ink into a new PDF.</a:t>
-            </a:r>
-          </a:p>
-        </p:txBody>
-      </p:sp>
-      <p:pic>
-        <p:nvPicPr>
-          <p:cNvPr id="16" name="Picture 15" descr="fs.png"/>
-          <p:cNvPicPr>
-            <a:picLocks noChangeAspect="1"/>
-          </p:cNvPicPr>
-          <p:nvPr/>
-        </p:nvPicPr>
-        <p:blipFill>
-          <a:blip r:embed="rId9"/>
-          <a:stretch>
-            <a:fillRect/>
-          </a:stretch>
-        </p:blipFill>
-        <p:spPr>
-          <a:xfrm>
-            <a:off x="6096792" y="2115907"/>
-            <a:ext cx="600000" cy="600000"/>
-          </a:xfrm>
-          <a:prstGeom prst="rect">
-            <a:avLst/>
-          </a:prstGeom>
-        </p:spPr>
-      </p:pic>
-      <p:sp>
-        <p:nvSpPr>
-          <p:cNvPr id="17" name="TextBox 16"/>
-          <p:cNvSpPr txBox="1"/>
-          <p:nvPr/>
-        </p:nvSpPr>
-        <p:spPr>
-          <a:xfrm>
-            <a:off x="7666792" y="2095907"/>
-            <a:ext cx="4055331" cy="600000"/>
-          </a:xfrm>
-          <a:prstGeom prst="rect">
-            <a:avLst/>
-          </a:prstGeom>
-          <a:noFill/>
-        </p:spPr>
-        <p:txBody>
-          <a:bodyPr wrap="square" anchor="ctr" lIns="0" rIns="0" tIns="0" bIns="0">
-            <a:spAutoFit/>
-          </a:bodyPr>
-          <a:lstStyle/>
-          <a:p>
-            <a:pPr algn="l"/>
-            <a:r>
-              <a:rPr sz="2200" b="1">
-                <a:solidFill>
-                  <a:srgbClr val="111111"/>
-                </a:solidFill>
-              </a:rPr>
-              <a:t>Full screen</a:t>
-            </a:r>
-          </a:p>
-          <a:p>
-            <a:pPr algn="l">
-              <a:spcBef>
-                <a:spcPts val="600"/>
-              </a:spcBef>
-            </a:pPr>
-            <a:r>
-              <a:rPr sz="1700" b="0">
-                <a:solidFill>
-                  <a:srgbClr val="555B6B"/>
-                </a:solidFill>
-              </a:rPr>
-              <a:t>Hides the browser bars where allowed.</a:t>
-            </a:r>
-          </a:p>
-        </p:txBody>
-      </p:sp>
-      <p:pic>
-        <p:nvPicPr>
-          <p:cNvPr id="18" name="Picture 17" descr="split.png"/>
-          <p:cNvPicPr>
-            <a:picLocks noChangeAspect="1"/>
-          </p:cNvPicPr>
-          <p:nvPr/>
-        </p:nvPicPr>
-        <p:blipFill>
-          <a:blip r:embed="rId10"/>
-          <a:stretch>
-            <a:fillRect/>
-          </a:stretch>
-        </p:blipFill>
-        <p:spPr>
-          <a:xfrm>
-            <a:off x="6096792" y="3146016"/>
-            <a:ext cx="600000" cy="600000"/>
-          </a:xfrm>
-          <a:prstGeom prst="rect">
-            <a:avLst/>
-          </a:prstGeom>
-        </p:spPr>
-      </p:pic>
-      <p:sp>
-        <p:nvSpPr>
-          <p:cNvPr id="19" name="TextBox 18"/>
-          <p:cNvSpPr txBox="1"/>
-          <p:nvPr/>
-        </p:nvSpPr>
-        <p:spPr>
-          <a:xfrm>
-            <a:off x="7666792" y="3126016"/>
-            <a:ext cx="4055331" cy="600000"/>
-          </a:xfrm>
-          <a:prstGeom prst="rect">
-            <a:avLst/>
-          </a:prstGeom>
-          <a:noFill/>
-        </p:spPr>
-        <p:txBody>
-          <a:bodyPr wrap="square" anchor="ctr" lIns="0" rIns="0" tIns="0" bIns="0">
-            <a:spAutoFit/>
-          </a:bodyPr>
-          <a:lstStyle/>
-          <a:p>
-            <a:pPr algn="l"/>
-            <a:r>
-              <a:rPr sz="2200" b="1">
-                <a:solidFill>
-                  <a:srgbClr val="111111"/>
-                </a:solidFill>
-              </a:rPr>
-              <a:t>Same or separate views</a:t>
-            </a:r>
-          </a:p>
-          <a:p>
-            <a:pPr algn="l">
-              <a:spcBef>
-                <a:spcPts val="600"/>
-              </a:spcBef>
-            </a:pPr>
-            <a:r>
-              <a:rPr sz="1700" b="0">
-                <a:solidFill>
-                  <a:srgbClr val="555B6B"/>
-                </a:solidFill>
-              </a:rPr>
-              <a:t>Mirror one screen, or projector plus lecturer view.</a:t>
-            </a:r>
-          </a:p>
-        </p:txBody>
-      </p:sp>
-      <p:pic>
-        <p:nvPicPr>
-          <p:cNvPr id="20" name="Picture 19" descr="settings.png"/>
-          <p:cNvPicPr>
-            <a:picLocks noChangeAspect="1"/>
-          </p:cNvPicPr>
-          <p:nvPr/>
-        </p:nvPicPr>
-        <p:blipFill>
-          <a:blip r:embed="rId11"/>
-          <a:stretch>
-            <a:fillRect/>
-          </a:stretch>
-        </p:blipFill>
-        <p:spPr>
-          <a:xfrm>
-            <a:off x="6096792" y="4176125"/>
-            <a:ext cx="600000" cy="600000"/>
-          </a:xfrm>
-          <a:prstGeom prst="rect">
-            <a:avLst/>
-          </a:prstGeom>
-        </p:spPr>
-      </p:pic>
-      <p:sp>
-        <p:nvSpPr>
-          <p:cNvPr id="21" name="TextBox 20"/>
-          <p:cNvSpPr txBox="1"/>
-          <p:nvPr/>
-        </p:nvSpPr>
-        <p:spPr>
-          <a:xfrm>
-            <a:off x="7666792" y="4156125"/>
-            <a:ext cx="4055331" cy="600000"/>
-          </a:xfrm>
-          <a:prstGeom prst="rect">
-            <a:avLst/>
-          </a:prstGeom>
-          <a:noFill/>
-        </p:spPr>
-        <p:txBody>
-          <a:bodyPr wrap="square" anchor="ctr" lIns="0" rIns="0" tIns="0" bIns="0">
-            <a:spAutoFit/>
-          </a:bodyPr>
-          <a:lstStyle/>
-          <a:p>
-            <a:pPr algn="l"/>
-            <a:r>
-              <a:rPr sz="2200" b="1">
-                <a:solidFill>
-                  <a:srgbClr val="111111"/>
-                </a:solidFill>
-              </a:rPr>
-              <a:t>Settings</a:t>
-            </a:r>
-          </a:p>
-          <a:p>
-            <a:pPr algn="l">
-              <a:spcBef>
-                <a:spcPts val="600"/>
-              </a:spcBef>
-            </a:pPr>
-            <a:r>
-              <a:rPr sz="1700" b="0">
-                <a:solidFill>
-                  <a:srgbClr val="555B6B"/>
-                </a:solidFill>
-              </a:rPr>
-              <a:t>Colours, slide strip speed and glide.</a:t>
-            </a:r>
-          </a:p>
-        </p:txBody>
-      </p:sp>
-      <p:pic>
-        <p:nvPicPr>
-          <p:cNvPr id="22" name="Picture 21" descr="hide.png"/>
-          <p:cNvPicPr>
-            <a:picLocks noChangeAspect="1"/>
-          </p:cNvPicPr>
-          <p:nvPr/>
-        </p:nvPicPr>
-        <p:blipFill>
-          <a:blip r:embed="rId12"/>
-          <a:stretch>
-            <a:fillRect/>
-          </a:stretch>
-        </p:blipFill>
-        <p:spPr>
-          <a:xfrm>
-            <a:off x="6096792" y="5206234"/>
-            <a:ext cx="600000" cy="600000"/>
-          </a:xfrm>
-          <a:prstGeom prst="rect">
-            <a:avLst/>
-          </a:prstGeom>
-        </p:spPr>
-      </p:pic>
-      <p:sp>
-        <p:nvSpPr>
-          <p:cNvPr id="23" name="TextBox 22"/>
-          <p:cNvSpPr txBox="1"/>
-          <p:nvPr/>
-        </p:nvSpPr>
-        <p:spPr>
-          <a:xfrm>
-            <a:off x="7666792" y="5186234"/>
-            <a:ext cx="4055331" cy="600000"/>
-          </a:xfrm>
-          <a:prstGeom prst="rect">
-            <a:avLst/>
-          </a:prstGeom>
-          <a:noFill/>
-        </p:spPr>
-        <p:txBody>
-          <a:bodyPr wrap="square" anchor="ctr" lIns="0" rIns="0" tIns="0" bIns="0">
-            <a:spAutoFit/>
-          </a:bodyPr>
-          <a:lstStyle/>
-          <a:p>
-            <a:pPr algn="l"/>
-            <a:r>
-              <a:rPr sz="2200" b="1">
-                <a:solidFill>
-                  <a:srgbClr val="111111"/>
-                </a:solidFill>
-              </a:rPr>
-              <a:t>Hide toolbar</a:t>
-            </a:r>
-          </a:p>
-          <a:p>
-            <a:pPr algn="l">
-              <a:spcBef>
-                <a:spcPts val="600"/>
-              </a:spcBef>
-            </a:pPr>
-            <a:r>
-              <a:rPr sz="1700" b="0">
-                <a:solidFill>
-                  <a:srgbClr val="555B6B"/>
-                </a:solidFill>
-              </a:rPr>
-              <a:t>Tap the top centre of the slide to bring it back.</a:t>
+              <a:t>Touch a stroke to remove it.</a:t>
             </a:r>
           </a:p>
         </p:txBody>
@@ -13633,7 +13171,761 @@
           <a:lstStyle/>
           <a:p>
             <a:r>
-              <a:t>Same view: mirror the iPad, then tap the top centre to hide the toolbar</a:t>
+              <a:t>The toolbar, button by button</a:t>
+            </a:r>
+          </a:p>
+        </p:txBody>
+      </p:sp>
+      <p:pic>
+        <p:nvPicPr>
+          <p:cNvPr id="3" name="Picture 2" descr="open.png"/>
+          <p:cNvPicPr>
+            <a:picLocks noChangeAspect="1"/>
+          </p:cNvPicPr>
+          <p:nvPr/>
+        </p:nvPicPr>
+        <p:blipFill>
+          <a:blip r:embed="rId2"/>
+          <a:stretch>
+            <a:fillRect/>
+          </a:stretch>
+        </p:blipFill>
+        <p:spPr>
+          <a:xfrm>
+            <a:off x="271461" y="1085798"/>
+            <a:ext cx="600000" cy="600000"/>
+          </a:xfrm>
+          <a:prstGeom prst="rect">
+            <a:avLst/>
+          </a:prstGeom>
+        </p:spPr>
+      </p:pic>
+      <p:sp>
+        <p:nvSpPr>
+          <p:cNvPr id="4" name="TextBox 3"/>
+          <p:cNvSpPr txBox="1"/>
+          <p:nvPr/>
+        </p:nvSpPr>
+        <p:spPr>
+          <a:xfrm>
+            <a:off x="1841461" y="1065798"/>
+            <a:ext cx="4055331" cy="600000"/>
+          </a:xfrm>
+          <a:prstGeom prst="rect">
+            <a:avLst/>
+          </a:prstGeom>
+          <a:noFill/>
+        </p:spPr>
+        <p:txBody>
+          <a:bodyPr wrap="square" anchor="ctr" lIns="0" rIns="0" tIns="0" bIns="0">
+            <a:spAutoFit/>
+          </a:bodyPr>
+          <a:lstStyle/>
+          <a:p>
+            <a:pPr algn="l"/>
+            <a:r>
+              <a:rPr sz="2200" b="1">
+                <a:solidFill>
+                  <a:srgbClr val="111111"/>
+                </a:solidFill>
+              </a:rPr>
+              <a:t>Open</a:t>
+            </a:r>
+          </a:p>
+          <a:p>
+            <a:pPr algn="l">
+              <a:spcBef>
+                <a:spcPts val="600"/>
+              </a:spcBef>
+            </a:pPr>
+            <a:r>
+              <a:rPr sz="1700" b="0">
+                <a:solidFill>
+                  <a:srgbClr val="555B6B"/>
+                </a:solidFill>
+              </a:rPr>
+              <a:t>Load a PDF from Files or iCloud Drive.</a:t>
+            </a:r>
+          </a:p>
+        </p:txBody>
+      </p:sp>
+      <p:pic>
+        <p:nvPicPr>
+          <p:cNvPr id="5" name="Picture 4" descr="prev.png"/>
+          <p:cNvPicPr>
+            <a:picLocks noChangeAspect="1"/>
+          </p:cNvPicPr>
+          <p:nvPr/>
+        </p:nvPicPr>
+        <p:blipFill>
+          <a:blip r:embed="rId3"/>
+          <a:stretch>
+            <a:fillRect/>
+          </a:stretch>
+        </p:blipFill>
+        <p:spPr>
+          <a:xfrm>
+            <a:off x="271461" y="2115907"/>
+            <a:ext cx="600000" cy="600000"/>
+          </a:xfrm>
+          <a:prstGeom prst="rect">
+            <a:avLst/>
+          </a:prstGeom>
+        </p:spPr>
+      </p:pic>
+      <p:pic>
+        <p:nvPicPr>
+          <p:cNvPr id="6" name="Picture 5" descr="next.png"/>
+          <p:cNvPicPr>
+            <a:picLocks noChangeAspect="1"/>
+          </p:cNvPicPr>
+          <p:nvPr/>
+        </p:nvPicPr>
+        <p:blipFill>
+          <a:blip r:embed="rId4"/>
+          <a:stretch>
+            <a:fillRect/>
+          </a:stretch>
+        </p:blipFill>
+        <p:spPr>
+          <a:xfrm>
+            <a:off x="961461" y="2115907"/>
+            <a:ext cx="600000" cy="600000"/>
+          </a:xfrm>
+          <a:prstGeom prst="rect">
+            <a:avLst/>
+          </a:prstGeom>
+        </p:spPr>
+      </p:pic>
+      <p:sp>
+        <p:nvSpPr>
+          <p:cNvPr id="7" name="TextBox 6"/>
+          <p:cNvSpPr txBox="1"/>
+          <p:nvPr/>
+        </p:nvSpPr>
+        <p:spPr>
+          <a:xfrm>
+            <a:off x="1841461" y="2095907"/>
+            <a:ext cx="4055331" cy="600000"/>
+          </a:xfrm>
+          <a:prstGeom prst="rect">
+            <a:avLst/>
+          </a:prstGeom>
+          <a:noFill/>
+        </p:spPr>
+        <p:txBody>
+          <a:bodyPr wrap="square" anchor="ctr" lIns="0" rIns="0" tIns="0" bIns="0">
+            <a:spAutoFit/>
+          </a:bodyPr>
+          <a:lstStyle/>
+          <a:p>
+            <a:pPr algn="l"/>
+            <a:r>
+              <a:rPr sz="2200" b="1">
+                <a:solidFill>
+                  <a:srgbClr val="111111"/>
+                </a:solidFill>
+              </a:rPr>
+              <a:t>Previous / next</a:t>
+            </a:r>
+          </a:p>
+          <a:p>
+            <a:pPr algn="l">
+              <a:spcBef>
+                <a:spcPts val="600"/>
+              </a:spcBef>
+            </a:pPr>
+            <a:r>
+              <a:rPr sz="1700" b="0">
+                <a:solidFill>
+                  <a:srgbClr val="555B6B"/>
+                </a:solidFill>
+              </a:rPr>
+              <a:t>Same as tapping the left or right third.</a:t>
+            </a:r>
+          </a:p>
+        </p:txBody>
+      </p:sp>
+      <p:pic>
+        <p:nvPicPr>
+          <p:cNvPr id="8" name="Picture 7" descr="grid.png"/>
+          <p:cNvPicPr>
+            <a:picLocks noChangeAspect="1"/>
+          </p:cNvPicPr>
+          <p:nvPr/>
+        </p:nvPicPr>
+        <p:blipFill>
+          <a:blip r:embed="rId5"/>
+          <a:stretch>
+            <a:fillRect/>
+          </a:stretch>
+        </p:blipFill>
+        <p:spPr>
+          <a:xfrm>
+            <a:off x="271461" y="3146016"/>
+            <a:ext cx="600000" cy="600000"/>
+          </a:xfrm>
+          <a:prstGeom prst="rect">
+            <a:avLst/>
+          </a:prstGeom>
+        </p:spPr>
+      </p:pic>
+      <p:sp>
+        <p:nvSpPr>
+          <p:cNvPr id="9" name="TextBox 8"/>
+          <p:cNvSpPr txBox="1"/>
+          <p:nvPr/>
+        </p:nvSpPr>
+        <p:spPr>
+          <a:xfrm>
+            <a:off x="1841461" y="3126016"/>
+            <a:ext cx="4055331" cy="600000"/>
+          </a:xfrm>
+          <a:prstGeom prst="rect">
+            <a:avLst/>
+          </a:prstGeom>
+          <a:noFill/>
+        </p:spPr>
+        <p:txBody>
+          <a:bodyPr wrap="square" anchor="ctr" lIns="0" rIns="0" tIns="0" bIns="0">
+            <a:spAutoFit/>
+          </a:bodyPr>
+          <a:lstStyle/>
+          <a:p>
+            <a:pPr algn="l"/>
+            <a:r>
+              <a:rPr sz="2200" b="1">
+                <a:solidFill>
+                  <a:srgbClr val="111111"/>
+                </a:solidFill>
+              </a:rPr>
+              <a:t>Slide overview</a:t>
+            </a:r>
+          </a:p>
+          <a:p>
+            <a:pPr algn="l">
+              <a:spcBef>
+                <a:spcPts val="600"/>
+              </a:spcBef>
+            </a:pPr>
+            <a:r>
+              <a:rPr sz="1700" b="0">
+                <a:solidFill>
+                  <a:srgbClr val="555B6B"/>
+                </a:solidFill>
+              </a:rPr>
+              <a:t>Same as the lower-quarter triple-tap.</a:t>
+            </a:r>
+          </a:p>
+        </p:txBody>
+      </p:sp>
+      <p:pic>
+        <p:nvPicPr>
+          <p:cNvPr id="10" name="Picture 9" descr="undo.png"/>
+          <p:cNvPicPr>
+            <a:picLocks noChangeAspect="1"/>
+          </p:cNvPicPr>
+          <p:nvPr/>
+        </p:nvPicPr>
+        <p:blipFill>
+          <a:blip r:embed="rId6"/>
+          <a:stretch>
+            <a:fillRect/>
+          </a:stretch>
+        </p:blipFill>
+        <p:spPr>
+          <a:xfrm>
+            <a:off x="271461" y="4176125"/>
+            <a:ext cx="600000" cy="600000"/>
+          </a:xfrm>
+          <a:prstGeom prst="rect">
+            <a:avLst/>
+          </a:prstGeom>
+        </p:spPr>
+      </p:pic>
+      <p:sp>
+        <p:nvSpPr>
+          <p:cNvPr id="11" name="TextBox 10"/>
+          <p:cNvSpPr txBox="1"/>
+          <p:nvPr/>
+        </p:nvSpPr>
+        <p:spPr>
+          <a:xfrm>
+            <a:off x="1841461" y="4156125"/>
+            <a:ext cx="4055331" cy="600000"/>
+          </a:xfrm>
+          <a:prstGeom prst="rect">
+            <a:avLst/>
+          </a:prstGeom>
+          <a:noFill/>
+        </p:spPr>
+        <p:txBody>
+          <a:bodyPr wrap="square" anchor="ctr" lIns="0" rIns="0" tIns="0" bIns="0">
+            <a:spAutoFit/>
+          </a:bodyPr>
+          <a:lstStyle/>
+          <a:p>
+            <a:pPr algn="l"/>
+            <a:r>
+              <a:rPr sz="2200" b="1">
+                <a:solidFill>
+                  <a:srgbClr val="111111"/>
+                </a:solidFill>
+              </a:rPr>
+              <a:t>Undo</a:t>
+            </a:r>
+          </a:p>
+          <a:p>
+            <a:pPr algn="l">
+              <a:spcBef>
+                <a:spcPts val="600"/>
+              </a:spcBef>
+            </a:pPr>
+            <a:r>
+              <a:rPr sz="1700" b="0">
+                <a:solidFill>
+                  <a:srgbClr val="555B6B"/>
+                </a:solidFill>
+              </a:rPr>
+              <a:t>Takes back the last change on this slide.</a:t>
+            </a:r>
+          </a:p>
+        </p:txBody>
+      </p:sp>
+      <p:pic>
+        <p:nvPicPr>
+          <p:cNvPr id="12" name="Picture 11" descr="clear.png"/>
+          <p:cNvPicPr>
+            <a:picLocks noChangeAspect="1"/>
+          </p:cNvPicPr>
+          <p:nvPr/>
+        </p:nvPicPr>
+        <p:blipFill>
+          <a:blip r:embed="rId7"/>
+          <a:stretch>
+            <a:fillRect/>
+          </a:stretch>
+        </p:blipFill>
+        <p:spPr>
+          <a:xfrm>
+            <a:off x="271461" y="5206234"/>
+            <a:ext cx="600000" cy="600000"/>
+          </a:xfrm>
+          <a:prstGeom prst="rect">
+            <a:avLst/>
+          </a:prstGeom>
+        </p:spPr>
+      </p:pic>
+      <p:sp>
+        <p:nvSpPr>
+          <p:cNvPr id="13" name="TextBox 12"/>
+          <p:cNvSpPr txBox="1"/>
+          <p:nvPr/>
+        </p:nvSpPr>
+        <p:spPr>
+          <a:xfrm>
+            <a:off x="1841461" y="5186234"/>
+            <a:ext cx="4055331" cy="600000"/>
+          </a:xfrm>
+          <a:prstGeom prst="rect">
+            <a:avLst/>
+          </a:prstGeom>
+          <a:noFill/>
+        </p:spPr>
+        <p:txBody>
+          <a:bodyPr wrap="square" anchor="ctr" lIns="0" rIns="0" tIns="0" bIns="0">
+            <a:spAutoFit/>
+          </a:bodyPr>
+          <a:lstStyle/>
+          <a:p>
+            <a:pPr algn="l"/>
+            <a:r>
+              <a:rPr sz="2200" b="1">
+                <a:solidFill>
+                  <a:srgbClr val="111111"/>
+                </a:solidFill>
+              </a:rPr>
+              <a:t>Clear</a:t>
+            </a:r>
+          </a:p>
+          <a:p>
+            <a:pPr algn="l">
+              <a:spcBef>
+                <a:spcPts val="600"/>
+              </a:spcBef>
+            </a:pPr>
+            <a:r>
+              <a:rPr sz="1700" b="0">
+                <a:solidFill>
+                  <a:srgbClr val="555B6B"/>
+                </a:solidFill>
+              </a:rPr>
+              <a:t>Removes all ink on this slide.</a:t>
+            </a:r>
+          </a:p>
+        </p:txBody>
+      </p:sp>
+      <p:pic>
+        <p:nvPicPr>
+          <p:cNvPr id="14" name="Picture 13" descr="save.png"/>
+          <p:cNvPicPr>
+            <a:picLocks noChangeAspect="1"/>
+          </p:cNvPicPr>
+          <p:nvPr/>
+        </p:nvPicPr>
+        <p:blipFill>
+          <a:blip r:embed="rId8"/>
+          <a:stretch>
+            <a:fillRect/>
+          </a:stretch>
+        </p:blipFill>
+        <p:spPr>
+          <a:xfrm>
+            <a:off x="6096792" y="1085798"/>
+            <a:ext cx="600000" cy="600000"/>
+          </a:xfrm>
+          <a:prstGeom prst="rect">
+            <a:avLst/>
+          </a:prstGeom>
+        </p:spPr>
+      </p:pic>
+      <p:sp>
+        <p:nvSpPr>
+          <p:cNvPr id="15" name="TextBox 14"/>
+          <p:cNvSpPr txBox="1"/>
+          <p:nvPr/>
+        </p:nvSpPr>
+        <p:spPr>
+          <a:xfrm>
+            <a:off x="7666792" y="1065798"/>
+            <a:ext cx="4055331" cy="600000"/>
+          </a:xfrm>
+          <a:prstGeom prst="rect">
+            <a:avLst/>
+          </a:prstGeom>
+          <a:noFill/>
+        </p:spPr>
+        <p:txBody>
+          <a:bodyPr wrap="square" anchor="ctr" lIns="0" rIns="0" tIns="0" bIns="0">
+            <a:spAutoFit/>
+          </a:bodyPr>
+          <a:lstStyle/>
+          <a:p>
+            <a:pPr algn="l"/>
+            <a:r>
+              <a:rPr sz="2200" b="1">
+                <a:solidFill>
+                  <a:srgbClr val="111111"/>
+                </a:solidFill>
+              </a:rPr>
+              <a:t>Save</a:t>
+            </a:r>
+          </a:p>
+          <a:p>
+            <a:pPr algn="l">
+              <a:spcBef>
+                <a:spcPts val="600"/>
+              </a:spcBef>
+            </a:pPr>
+            <a:r>
+              <a:rPr sz="1700" b="0">
+                <a:solidFill>
+                  <a:srgbClr val="555B6B"/>
+                </a:solidFill>
+              </a:rPr>
+              <a:t>Writes your ink into a new PDF.</a:t>
+            </a:r>
+          </a:p>
+        </p:txBody>
+      </p:sp>
+      <p:pic>
+        <p:nvPicPr>
+          <p:cNvPr id="16" name="Picture 15" descr="fs.png"/>
+          <p:cNvPicPr>
+            <a:picLocks noChangeAspect="1"/>
+          </p:cNvPicPr>
+          <p:nvPr/>
+        </p:nvPicPr>
+        <p:blipFill>
+          <a:blip r:embed="rId9"/>
+          <a:stretch>
+            <a:fillRect/>
+          </a:stretch>
+        </p:blipFill>
+        <p:spPr>
+          <a:xfrm>
+            <a:off x="6096792" y="2115907"/>
+            <a:ext cx="600000" cy="600000"/>
+          </a:xfrm>
+          <a:prstGeom prst="rect">
+            <a:avLst/>
+          </a:prstGeom>
+        </p:spPr>
+      </p:pic>
+      <p:sp>
+        <p:nvSpPr>
+          <p:cNvPr id="17" name="TextBox 16"/>
+          <p:cNvSpPr txBox="1"/>
+          <p:nvPr/>
+        </p:nvSpPr>
+        <p:spPr>
+          <a:xfrm>
+            <a:off x="7666792" y="2095907"/>
+            <a:ext cx="4055331" cy="600000"/>
+          </a:xfrm>
+          <a:prstGeom prst="rect">
+            <a:avLst/>
+          </a:prstGeom>
+          <a:noFill/>
+        </p:spPr>
+        <p:txBody>
+          <a:bodyPr wrap="square" anchor="ctr" lIns="0" rIns="0" tIns="0" bIns="0">
+            <a:spAutoFit/>
+          </a:bodyPr>
+          <a:lstStyle/>
+          <a:p>
+            <a:pPr algn="l"/>
+            <a:r>
+              <a:rPr sz="2200" b="1">
+                <a:solidFill>
+                  <a:srgbClr val="111111"/>
+                </a:solidFill>
+              </a:rPr>
+              <a:t>Full screen</a:t>
+            </a:r>
+          </a:p>
+          <a:p>
+            <a:pPr algn="l">
+              <a:spcBef>
+                <a:spcPts val="600"/>
+              </a:spcBef>
+            </a:pPr>
+            <a:r>
+              <a:rPr sz="1700" b="0">
+                <a:solidFill>
+                  <a:srgbClr val="555B6B"/>
+                </a:solidFill>
+              </a:rPr>
+              <a:t>Hides the browser bars where allowed.</a:t>
+            </a:r>
+          </a:p>
+        </p:txBody>
+      </p:sp>
+      <p:pic>
+        <p:nvPicPr>
+          <p:cNvPr id="18" name="Picture 17" descr="split.png"/>
+          <p:cNvPicPr>
+            <a:picLocks noChangeAspect="1"/>
+          </p:cNvPicPr>
+          <p:nvPr/>
+        </p:nvPicPr>
+        <p:blipFill>
+          <a:blip r:embed="rId10"/>
+          <a:stretch>
+            <a:fillRect/>
+          </a:stretch>
+        </p:blipFill>
+        <p:spPr>
+          <a:xfrm>
+            <a:off x="6096792" y="3146016"/>
+            <a:ext cx="600000" cy="600000"/>
+          </a:xfrm>
+          <a:prstGeom prst="rect">
+            <a:avLst/>
+          </a:prstGeom>
+        </p:spPr>
+      </p:pic>
+      <p:sp>
+        <p:nvSpPr>
+          <p:cNvPr id="19" name="TextBox 18"/>
+          <p:cNvSpPr txBox="1"/>
+          <p:nvPr/>
+        </p:nvSpPr>
+        <p:spPr>
+          <a:xfrm>
+            <a:off x="7666792" y="3126016"/>
+            <a:ext cx="4055331" cy="600000"/>
+          </a:xfrm>
+          <a:prstGeom prst="rect">
+            <a:avLst/>
+          </a:prstGeom>
+          <a:noFill/>
+        </p:spPr>
+        <p:txBody>
+          <a:bodyPr wrap="square" anchor="ctr" lIns="0" rIns="0" tIns="0" bIns="0">
+            <a:spAutoFit/>
+          </a:bodyPr>
+          <a:lstStyle/>
+          <a:p>
+            <a:pPr algn="l"/>
+            <a:r>
+              <a:rPr sz="2200" b="1">
+                <a:solidFill>
+                  <a:srgbClr val="111111"/>
+                </a:solidFill>
+              </a:rPr>
+              <a:t>Same or separate views</a:t>
+            </a:r>
+          </a:p>
+          <a:p>
+            <a:pPr algn="l">
+              <a:spcBef>
+                <a:spcPts val="600"/>
+              </a:spcBef>
+            </a:pPr>
+            <a:r>
+              <a:rPr sz="1700" b="0">
+                <a:solidFill>
+                  <a:srgbClr val="555B6B"/>
+                </a:solidFill>
+              </a:rPr>
+              <a:t>Mirror one screen, or projector plus lecturer view.</a:t>
+            </a:r>
+          </a:p>
+        </p:txBody>
+      </p:sp>
+      <p:pic>
+        <p:nvPicPr>
+          <p:cNvPr id="20" name="Picture 19" descr="settings.png"/>
+          <p:cNvPicPr>
+            <a:picLocks noChangeAspect="1"/>
+          </p:cNvPicPr>
+          <p:nvPr/>
+        </p:nvPicPr>
+        <p:blipFill>
+          <a:blip r:embed="rId11"/>
+          <a:stretch>
+            <a:fillRect/>
+          </a:stretch>
+        </p:blipFill>
+        <p:spPr>
+          <a:xfrm>
+            <a:off x="6096792" y="4176125"/>
+            <a:ext cx="600000" cy="600000"/>
+          </a:xfrm>
+          <a:prstGeom prst="rect">
+            <a:avLst/>
+          </a:prstGeom>
+        </p:spPr>
+      </p:pic>
+      <p:sp>
+        <p:nvSpPr>
+          <p:cNvPr id="21" name="TextBox 20"/>
+          <p:cNvSpPr txBox="1"/>
+          <p:nvPr/>
+        </p:nvSpPr>
+        <p:spPr>
+          <a:xfrm>
+            <a:off x="7666792" y="4156125"/>
+            <a:ext cx="4055331" cy="600000"/>
+          </a:xfrm>
+          <a:prstGeom prst="rect">
+            <a:avLst/>
+          </a:prstGeom>
+          <a:noFill/>
+        </p:spPr>
+        <p:txBody>
+          <a:bodyPr wrap="square" anchor="ctr" lIns="0" rIns="0" tIns="0" bIns="0">
+            <a:spAutoFit/>
+          </a:bodyPr>
+          <a:lstStyle/>
+          <a:p>
+            <a:pPr algn="l"/>
+            <a:r>
+              <a:rPr sz="2200" b="1">
+                <a:solidFill>
+                  <a:srgbClr val="111111"/>
+                </a:solidFill>
+              </a:rPr>
+              <a:t>Settings</a:t>
+            </a:r>
+          </a:p>
+          <a:p>
+            <a:pPr algn="l">
+              <a:spcBef>
+                <a:spcPts val="600"/>
+              </a:spcBef>
+            </a:pPr>
+            <a:r>
+              <a:rPr sz="1700" b="0">
+                <a:solidFill>
+                  <a:srgbClr val="555B6B"/>
+                </a:solidFill>
+              </a:rPr>
+              <a:t>Colours, slide strip speed and glide.</a:t>
+            </a:r>
+          </a:p>
+        </p:txBody>
+      </p:sp>
+      <p:pic>
+        <p:nvPicPr>
+          <p:cNvPr id="22" name="Picture 21" descr="hide.png"/>
+          <p:cNvPicPr>
+            <a:picLocks noChangeAspect="1"/>
+          </p:cNvPicPr>
+          <p:nvPr/>
+        </p:nvPicPr>
+        <p:blipFill>
+          <a:blip r:embed="rId12"/>
+          <a:stretch>
+            <a:fillRect/>
+          </a:stretch>
+        </p:blipFill>
+        <p:spPr>
+          <a:xfrm>
+            <a:off x="6096792" y="5206234"/>
+            <a:ext cx="600000" cy="600000"/>
+          </a:xfrm>
+          <a:prstGeom prst="rect">
+            <a:avLst/>
+          </a:prstGeom>
+        </p:spPr>
+      </p:pic>
+      <p:sp>
+        <p:nvSpPr>
+          <p:cNvPr id="23" name="TextBox 22"/>
+          <p:cNvSpPr txBox="1"/>
+          <p:nvPr/>
+        </p:nvSpPr>
+        <p:spPr>
+          <a:xfrm>
+            <a:off x="7666792" y="5186234"/>
+            <a:ext cx="4055331" cy="600000"/>
+          </a:xfrm>
+          <a:prstGeom prst="rect">
+            <a:avLst/>
+          </a:prstGeom>
+          <a:noFill/>
+        </p:spPr>
+        <p:txBody>
+          <a:bodyPr wrap="square" anchor="ctr" lIns="0" rIns="0" tIns="0" bIns="0">
+            <a:spAutoFit/>
+          </a:bodyPr>
+          <a:lstStyle/>
+          <a:p>
+            <a:pPr algn="l"/>
+            <a:r>
+              <a:rPr sz="2200" b="1">
+                <a:solidFill>
+                  <a:srgbClr val="111111"/>
+                </a:solidFill>
+              </a:rPr>
+              <a:t>Hide toolbar</a:t>
+            </a:r>
+          </a:p>
+          <a:p>
+            <a:pPr algn="l">
+              <a:spcBef>
+                <a:spcPts val="600"/>
+              </a:spcBef>
+            </a:pPr>
+            <a:r>
+              <a:rPr sz="1700" b="0">
+                <a:solidFill>
+                  <a:srgbClr val="555B6B"/>
+                </a:solidFill>
+              </a:rPr>
+              <a:t>Tap the top centre of the slide to bring it back.</a:t>
             </a:r>
           </a:p>
         </p:txBody>

</xml_diff>

<commit_message>
Release 1.2.0: first/last slide, reload, desktop shortcuts, redo
- First and last slide buttons in the toolbar and at the ends of the slide overview
- Reload button and Cmd/Ctrl+R: reads the PDF again, keeps slide and ink
- Cmd/Ctrl+O open, +S save, +Z undo, Shift+Z or Y redo
- Opened or dropped files reload by themselves in Chrome and Edge
- A green dot on Reload shows that the PDF is watched
- Guide deck: toolbar slide updated

Co-Authored-By: Claude Opus 5.5 <noreply@anthropic.com>
Claude-Session: https://claude.ai/code/session_01V4q6MUNQzbvGfyJNvW5Le1
</commit_message>
<xml_diff>
--- a/source/guide-deck.pptx
+++ b/source/guide-deck.pptx
@@ -13192,8 +13192,8 @@
         </p:blipFill>
         <p:spPr>
           <a:xfrm>
-            <a:off x="271461" y="1085798"/>
-            <a:ext cx="600000" cy="600000"/>
+            <a:off x="271461" y="1039956"/>
+            <a:ext cx="520000" cy="520000"/>
           </a:xfrm>
           <a:prstGeom prst="rect">
             <a:avLst/>
@@ -13208,8 +13208,8 @@
         </p:nvSpPr>
         <p:spPr>
           <a:xfrm>
-            <a:off x="1841461" y="1065798"/>
-            <a:ext cx="4055331" cy="600000"/>
+            <a:off x="1681461" y="1019956"/>
+            <a:ext cx="4215331" cy="520000"/>
           </a:xfrm>
           <a:prstGeom prst="rect">
             <a:avLst/>
@@ -13244,14 +13244,14 @@
                   <a:srgbClr val="555B6B"/>
                 </a:solidFill>
               </a:rPr>
-              <a:t>Load a PDF from Files or iCloud Drive.</a:t>
+              <a:t>Load a PDF from Files or iCloud Drive (⌘O).</a:t>
             </a:r>
           </a:p>
         </p:txBody>
       </p:sp>
       <p:pic>
         <p:nvPicPr>
-          <p:cNvPr id="5" name="Picture 4" descr="prev.png"/>
+          <p:cNvPr id="5" name="Picture 4" descr="reload.png"/>
           <p:cNvPicPr>
             <a:picLocks noChangeAspect="1"/>
           </p:cNvPicPr>
@@ -13265,17 +13265,66 @@
         </p:blipFill>
         <p:spPr>
           <a:xfrm>
-            <a:off x="271461" y="2115907"/>
-            <a:ext cx="600000" cy="600000"/>
+            <a:off x="271461" y="1898380"/>
+            <a:ext cx="520000" cy="520000"/>
           </a:xfrm>
           <a:prstGeom prst="rect">
             <a:avLst/>
           </a:prstGeom>
         </p:spPr>
       </p:pic>
+      <p:sp>
+        <p:nvSpPr>
+          <p:cNvPr id="6" name="TextBox 5"/>
+          <p:cNvSpPr txBox="1"/>
+          <p:nvPr/>
+        </p:nvSpPr>
+        <p:spPr>
+          <a:xfrm>
+            <a:off x="1681461" y="1878380"/>
+            <a:ext cx="4215331" cy="520000"/>
+          </a:xfrm>
+          <a:prstGeom prst="rect">
+            <a:avLst/>
+          </a:prstGeom>
+          <a:noFill/>
+        </p:spPr>
+        <p:txBody>
+          <a:bodyPr wrap="square" anchor="ctr" lIns="0" rIns="0" tIns="0" bIns="0">
+            <a:spAutoFit/>
+          </a:bodyPr>
+          <a:lstStyle/>
+          <a:p>
+            <a:pPr algn="l"/>
+            <a:r>
+              <a:rPr sz="2200" b="1">
+                <a:solidFill>
+                  <a:srgbClr val="111111"/>
+                </a:solidFill>
+              </a:rPr>
+              <a:t>Reload</a:t>
+            </a:r>
+          </a:p>
+          <a:p>
+            <a:pPr algn="l">
+              <a:spcBef>
+                <a:spcPts val="600"/>
+              </a:spcBef>
+            </a:pPr>
+            <a:r>
+              <a:rPr sz="1700" b="0">
+                <a:solidFill>
+                  <a:srgbClr val="555B6B"/>
+                </a:solidFill>
+              </a:rPr>
+              <a:t>Reads the PDF again; slide and ink stay (⌘R).</a:t>
+            </a:r>
+          </a:p>
+        </p:txBody>
+      </p:sp>
       <p:pic>
         <p:nvPicPr>
-          <p:cNvPr id="6" name="Picture 5" descr="next.png"/>
+          <p:cNvPr id="7" name="Picture 6" descr="first.png"/>
           <p:cNvPicPr>
             <a:picLocks noChangeAspect="1"/>
           </p:cNvPicPr>
@@ -13289,66 +13338,17 @@
         </p:blipFill>
         <p:spPr>
           <a:xfrm>
-            <a:off x="961461" y="2115907"/>
-            <a:ext cx="600000" cy="600000"/>
+            <a:off x="271461" y="2756804"/>
+            <a:ext cx="520000" cy="520000"/>
           </a:xfrm>
           <a:prstGeom prst="rect">
             <a:avLst/>
           </a:prstGeom>
         </p:spPr>
       </p:pic>
-      <p:sp>
-        <p:nvSpPr>
-          <p:cNvPr id="7" name="TextBox 6"/>
-          <p:cNvSpPr txBox="1"/>
-          <p:nvPr/>
-        </p:nvSpPr>
-        <p:spPr>
-          <a:xfrm>
-            <a:off x="1841461" y="2095907"/>
-            <a:ext cx="4055331" cy="600000"/>
-          </a:xfrm>
-          <a:prstGeom prst="rect">
-            <a:avLst/>
-          </a:prstGeom>
-          <a:noFill/>
-        </p:spPr>
-        <p:txBody>
-          <a:bodyPr wrap="square" anchor="ctr" lIns="0" rIns="0" tIns="0" bIns="0">
-            <a:spAutoFit/>
-          </a:bodyPr>
-          <a:lstStyle/>
-          <a:p>
-            <a:pPr algn="l"/>
-            <a:r>
-              <a:rPr sz="2200" b="1">
-                <a:solidFill>
-                  <a:srgbClr val="111111"/>
-                </a:solidFill>
-              </a:rPr>
-              <a:t>Previous / next</a:t>
-            </a:r>
-          </a:p>
-          <a:p>
-            <a:pPr algn="l">
-              <a:spcBef>
-                <a:spcPts val="600"/>
-              </a:spcBef>
-            </a:pPr>
-            <a:r>
-              <a:rPr sz="1700" b="0">
-                <a:solidFill>
-                  <a:srgbClr val="555B6B"/>
-                </a:solidFill>
-              </a:rPr>
-              <a:t>Same as tapping the left or right third.</a:t>
-            </a:r>
-          </a:p>
-        </p:txBody>
-      </p:sp>
       <p:pic>
         <p:nvPicPr>
-          <p:cNvPr id="8" name="Picture 7" descr="grid.png"/>
+          <p:cNvPr id="8" name="Picture 7" descr="last.png"/>
           <p:cNvPicPr>
             <a:picLocks noChangeAspect="1"/>
           </p:cNvPicPr>
@@ -13362,8 +13362,8 @@
         </p:blipFill>
         <p:spPr>
           <a:xfrm>
-            <a:off x="271461" y="3146016"/>
-            <a:ext cx="600000" cy="600000"/>
+            <a:off x="881461" y="2756804"/>
+            <a:ext cx="520000" cy="520000"/>
           </a:xfrm>
           <a:prstGeom prst="rect">
             <a:avLst/>
@@ -13378,8 +13378,8 @@
         </p:nvSpPr>
         <p:spPr>
           <a:xfrm>
-            <a:off x="1841461" y="3126016"/>
-            <a:ext cx="4055331" cy="600000"/>
+            <a:off x="1681461" y="2736804"/>
+            <a:ext cx="4215331" cy="520000"/>
           </a:xfrm>
           <a:prstGeom prst="rect">
             <a:avLst/>
@@ -13399,7 +13399,7 @@
                   <a:srgbClr val="111111"/>
                 </a:solidFill>
               </a:rPr>
-              <a:t>Slide overview</a:t>
+              <a:t>First / last slide</a:t>
             </a:r>
           </a:p>
           <a:p>
@@ -13414,14 +13414,14 @@
                   <a:srgbClr val="555B6B"/>
                 </a:solidFill>
               </a:rPr>
-              <a:t>Same as the lower-quarter triple-tap.</a:t>
+              <a:t>Also at both ends of the slide overview.</a:t>
             </a:r>
           </a:p>
         </p:txBody>
       </p:sp>
       <p:pic>
         <p:nvPicPr>
-          <p:cNvPr id="10" name="Picture 9" descr="undo.png"/>
+          <p:cNvPr id="10" name="Picture 9" descr="prev.png"/>
           <p:cNvPicPr>
             <a:picLocks noChangeAspect="1"/>
           </p:cNvPicPr>
@@ -13435,66 +13435,17 @@
         </p:blipFill>
         <p:spPr>
           <a:xfrm>
-            <a:off x="271461" y="4176125"/>
-            <a:ext cx="600000" cy="600000"/>
+            <a:off x="271461" y="3615228"/>
+            <a:ext cx="520000" cy="520000"/>
           </a:xfrm>
           <a:prstGeom prst="rect">
             <a:avLst/>
           </a:prstGeom>
         </p:spPr>
       </p:pic>
-      <p:sp>
-        <p:nvSpPr>
-          <p:cNvPr id="11" name="TextBox 10"/>
-          <p:cNvSpPr txBox="1"/>
-          <p:nvPr/>
-        </p:nvSpPr>
-        <p:spPr>
-          <a:xfrm>
-            <a:off x="1841461" y="4156125"/>
-            <a:ext cx="4055331" cy="600000"/>
-          </a:xfrm>
-          <a:prstGeom prst="rect">
-            <a:avLst/>
-          </a:prstGeom>
-          <a:noFill/>
-        </p:spPr>
-        <p:txBody>
-          <a:bodyPr wrap="square" anchor="ctr" lIns="0" rIns="0" tIns="0" bIns="0">
-            <a:spAutoFit/>
-          </a:bodyPr>
-          <a:lstStyle/>
-          <a:p>
-            <a:pPr algn="l"/>
-            <a:r>
-              <a:rPr sz="2200" b="1">
-                <a:solidFill>
-                  <a:srgbClr val="111111"/>
-                </a:solidFill>
-              </a:rPr>
-              <a:t>Undo</a:t>
-            </a:r>
-          </a:p>
-          <a:p>
-            <a:pPr algn="l">
-              <a:spcBef>
-                <a:spcPts val="600"/>
-              </a:spcBef>
-            </a:pPr>
-            <a:r>
-              <a:rPr sz="1700" b="0">
-                <a:solidFill>
-                  <a:srgbClr val="555B6B"/>
-                </a:solidFill>
-              </a:rPr>
-              <a:t>Takes back the last change on this slide.</a:t>
-            </a:r>
-          </a:p>
-        </p:txBody>
-      </p:sp>
       <p:pic>
         <p:nvPicPr>
-          <p:cNvPr id="12" name="Picture 11" descr="clear.png"/>
+          <p:cNvPr id="11" name="Picture 10" descr="next.png"/>
           <p:cNvPicPr>
             <a:picLocks noChangeAspect="1"/>
           </p:cNvPicPr>
@@ -13508,8 +13459,8 @@
         </p:blipFill>
         <p:spPr>
           <a:xfrm>
-            <a:off x="271461" y="5206234"/>
-            <a:ext cx="600000" cy="600000"/>
+            <a:off x="881461" y="3615228"/>
+            <a:ext cx="520000" cy="520000"/>
           </a:xfrm>
           <a:prstGeom prst="rect">
             <a:avLst/>
@@ -13518,14 +13469,14 @@
       </p:pic>
       <p:sp>
         <p:nvSpPr>
-          <p:cNvPr id="13" name="TextBox 12"/>
+          <p:cNvPr id="12" name="TextBox 11"/>
           <p:cNvSpPr txBox="1"/>
           <p:nvPr/>
         </p:nvSpPr>
         <p:spPr>
           <a:xfrm>
-            <a:off x="1841461" y="5186234"/>
-            <a:ext cx="4055331" cy="600000"/>
+            <a:off x="1681461" y="3595228"/>
+            <a:ext cx="4215331" cy="520000"/>
           </a:xfrm>
           <a:prstGeom prst="rect">
             <a:avLst/>
@@ -13545,7 +13496,7 @@
                   <a:srgbClr val="111111"/>
                 </a:solidFill>
               </a:rPr>
-              <a:t>Clear</a:t>
+              <a:t>Previous / next</a:t>
             </a:r>
           </a:p>
           <a:p>
@@ -13560,14 +13511,14 @@
                   <a:srgbClr val="555B6B"/>
                 </a:solidFill>
               </a:rPr>
-              <a:t>Removes all ink on this slide.</a:t>
+              <a:t>Same as tapping the left or right third.</a:t>
             </a:r>
           </a:p>
         </p:txBody>
       </p:sp>
       <p:pic>
         <p:nvPicPr>
-          <p:cNvPr id="14" name="Picture 13" descr="save.png"/>
+          <p:cNvPr id="13" name="Picture 12" descr="grid.png"/>
           <p:cNvPicPr>
             <a:picLocks noChangeAspect="1"/>
           </p:cNvPicPr>
@@ -13581,8 +13532,8 @@
         </p:blipFill>
         <p:spPr>
           <a:xfrm>
-            <a:off x="6096792" y="1085798"/>
-            <a:ext cx="600000" cy="600000"/>
+            <a:off x="271461" y="4473652"/>
+            <a:ext cx="520000" cy="520000"/>
           </a:xfrm>
           <a:prstGeom prst="rect">
             <a:avLst/>
@@ -13591,14 +13542,14 @@
       </p:pic>
       <p:sp>
         <p:nvSpPr>
-          <p:cNvPr id="15" name="TextBox 14"/>
+          <p:cNvPr id="14" name="TextBox 13"/>
           <p:cNvSpPr txBox="1"/>
           <p:nvPr/>
         </p:nvSpPr>
         <p:spPr>
           <a:xfrm>
-            <a:off x="7666792" y="1065798"/>
-            <a:ext cx="4055331" cy="600000"/>
+            <a:off x="1681461" y="4453652"/>
+            <a:ext cx="4215331" cy="520000"/>
           </a:xfrm>
           <a:prstGeom prst="rect">
             <a:avLst/>
@@ -13618,7 +13569,7 @@
                   <a:srgbClr val="111111"/>
                 </a:solidFill>
               </a:rPr>
-              <a:t>Save</a:t>
+              <a:t>Slide overview</a:t>
             </a:r>
           </a:p>
           <a:p>
@@ -13633,14 +13584,14 @@
                   <a:srgbClr val="555B6B"/>
                 </a:solidFill>
               </a:rPr>
-              <a:t>Writes your ink into a new PDF.</a:t>
+              <a:t>Same as the lower-quarter triple-tap.</a:t>
             </a:r>
           </a:p>
         </p:txBody>
       </p:sp>
       <p:pic>
         <p:nvPicPr>
-          <p:cNvPr id="16" name="Picture 15" descr="fs.png"/>
+          <p:cNvPr id="15" name="Picture 14" descr="undo.png"/>
           <p:cNvPicPr>
             <a:picLocks noChangeAspect="1"/>
           </p:cNvPicPr>
@@ -13654,8 +13605,8 @@
         </p:blipFill>
         <p:spPr>
           <a:xfrm>
-            <a:off x="6096792" y="2115907"/>
-            <a:ext cx="600000" cy="600000"/>
+            <a:off x="271461" y="5332076"/>
+            <a:ext cx="520000" cy="520000"/>
           </a:xfrm>
           <a:prstGeom prst="rect">
             <a:avLst/>
@@ -13664,14 +13615,14 @@
       </p:pic>
       <p:sp>
         <p:nvSpPr>
-          <p:cNvPr id="17" name="TextBox 16"/>
+          <p:cNvPr id="16" name="TextBox 15"/>
           <p:cNvSpPr txBox="1"/>
           <p:nvPr/>
         </p:nvSpPr>
         <p:spPr>
           <a:xfrm>
-            <a:off x="7666792" y="2095907"/>
-            <a:ext cx="4055331" cy="600000"/>
+            <a:off x="1681461" y="5312076"/>
+            <a:ext cx="4215331" cy="520000"/>
           </a:xfrm>
           <a:prstGeom prst="rect">
             <a:avLst/>
@@ -13691,7 +13642,7 @@
                   <a:srgbClr val="111111"/>
                 </a:solidFill>
               </a:rPr>
-              <a:t>Full screen</a:t>
+              <a:t>Undo</a:t>
             </a:r>
           </a:p>
           <a:p>
@@ -13706,14 +13657,14 @@
                   <a:srgbClr val="555B6B"/>
                 </a:solidFill>
               </a:rPr>
-              <a:t>Hides the browser bars where allowed.</a:t>
+              <a:t>Takes back the last change on this slide (⌘Z).</a:t>
             </a:r>
           </a:p>
         </p:txBody>
       </p:sp>
       <p:pic>
         <p:nvPicPr>
-          <p:cNvPr id="18" name="Picture 17" descr="split.png"/>
+          <p:cNvPr id="17" name="Picture 16" descr="clear.png"/>
           <p:cNvPicPr>
             <a:picLocks noChangeAspect="1"/>
           </p:cNvPicPr>
@@ -13727,8 +13678,8 @@
         </p:blipFill>
         <p:spPr>
           <a:xfrm>
-            <a:off x="6096792" y="3146016"/>
-            <a:ext cx="600000" cy="600000"/>
+            <a:off x="6096792" y="1039956"/>
+            <a:ext cx="520000" cy="520000"/>
           </a:xfrm>
           <a:prstGeom prst="rect">
             <a:avLst/>
@@ -13737,14 +13688,14 @@
       </p:pic>
       <p:sp>
         <p:nvSpPr>
-          <p:cNvPr id="19" name="TextBox 18"/>
+          <p:cNvPr id="18" name="TextBox 17"/>
           <p:cNvSpPr txBox="1"/>
           <p:nvPr/>
         </p:nvSpPr>
         <p:spPr>
           <a:xfrm>
-            <a:off x="7666792" y="3126016"/>
-            <a:ext cx="4055331" cy="600000"/>
+            <a:off x="7506792" y="1019956"/>
+            <a:ext cx="4215331" cy="520000"/>
           </a:xfrm>
           <a:prstGeom prst="rect">
             <a:avLst/>
@@ -13764,7 +13715,7 @@
                   <a:srgbClr val="111111"/>
                 </a:solidFill>
               </a:rPr>
-              <a:t>Same or separate views</a:t>
+              <a:t>Clear</a:t>
             </a:r>
           </a:p>
           <a:p>
@@ -13779,14 +13730,14 @@
                   <a:srgbClr val="555B6B"/>
                 </a:solidFill>
               </a:rPr>
-              <a:t>Mirror one screen, or projector plus lecturer view.</a:t>
+              <a:t>Removes all ink on this slide.</a:t>
             </a:r>
           </a:p>
         </p:txBody>
       </p:sp>
       <p:pic>
         <p:nvPicPr>
-          <p:cNvPr id="20" name="Picture 19" descr="settings.png"/>
+          <p:cNvPr id="19" name="Picture 18" descr="save.png"/>
           <p:cNvPicPr>
             <a:picLocks noChangeAspect="1"/>
           </p:cNvPicPr>
@@ -13800,8 +13751,8 @@
         </p:blipFill>
         <p:spPr>
           <a:xfrm>
-            <a:off x="6096792" y="4176125"/>
-            <a:ext cx="600000" cy="600000"/>
+            <a:off x="6096792" y="1898380"/>
+            <a:ext cx="520000" cy="520000"/>
           </a:xfrm>
           <a:prstGeom prst="rect">
             <a:avLst/>
@@ -13810,14 +13761,14 @@
       </p:pic>
       <p:sp>
         <p:nvSpPr>
-          <p:cNvPr id="21" name="TextBox 20"/>
+          <p:cNvPr id="20" name="TextBox 19"/>
           <p:cNvSpPr txBox="1"/>
           <p:nvPr/>
         </p:nvSpPr>
         <p:spPr>
           <a:xfrm>
-            <a:off x="7666792" y="4156125"/>
-            <a:ext cx="4055331" cy="600000"/>
+            <a:off x="7506792" y="1878380"/>
+            <a:ext cx="4215331" cy="520000"/>
           </a:xfrm>
           <a:prstGeom prst="rect">
             <a:avLst/>
@@ -13837,7 +13788,7 @@
                   <a:srgbClr val="111111"/>
                 </a:solidFill>
               </a:rPr>
-              <a:t>Settings</a:t>
+              <a:t>Save</a:t>
             </a:r>
           </a:p>
           <a:p>
@@ -13852,14 +13803,14 @@
                   <a:srgbClr val="555B6B"/>
                 </a:solidFill>
               </a:rPr>
-              <a:t>Colours, slide strip speed and glide.</a:t>
+              <a:t>Writes your ink into a new PDF (⌘S).</a:t>
             </a:r>
           </a:p>
         </p:txBody>
       </p:sp>
       <p:pic>
         <p:nvPicPr>
-          <p:cNvPr id="22" name="Picture 21" descr="hide.png"/>
+          <p:cNvPr id="21" name="Picture 20" descr="fs.png"/>
           <p:cNvPicPr>
             <a:picLocks noChangeAspect="1"/>
           </p:cNvPicPr>
@@ -13873,8 +13824,8 @@
         </p:blipFill>
         <p:spPr>
           <a:xfrm>
-            <a:off x="6096792" y="5206234"/>
-            <a:ext cx="600000" cy="600000"/>
+            <a:off x="6096792" y="2756804"/>
+            <a:ext cx="520000" cy="520000"/>
           </a:xfrm>
           <a:prstGeom prst="rect">
             <a:avLst/>
@@ -13883,14 +13834,233 @@
       </p:pic>
       <p:sp>
         <p:nvSpPr>
-          <p:cNvPr id="23" name="TextBox 22"/>
+          <p:cNvPr id="22" name="TextBox 21"/>
           <p:cNvSpPr txBox="1"/>
           <p:nvPr/>
         </p:nvSpPr>
         <p:spPr>
           <a:xfrm>
-            <a:off x="7666792" y="5186234"/>
-            <a:ext cx="4055331" cy="600000"/>
+            <a:off x="7506792" y="2736804"/>
+            <a:ext cx="4215331" cy="520000"/>
+          </a:xfrm>
+          <a:prstGeom prst="rect">
+            <a:avLst/>
+          </a:prstGeom>
+          <a:noFill/>
+        </p:spPr>
+        <p:txBody>
+          <a:bodyPr wrap="square" anchor="ctr" lIns="0" rIns="0" tIns="0" bIns="0">
+            <a:spAutoFit/>
+          </a:bodyPr>
+          <a:lstStyle/>
+          <a:p>
+            <a:pPr algn="l"/>
+            <a:r>
+              <a:rPr sz="2200" b="1">
+                <a:solidFill>
+                  <a:srgbClr val="111111"/>
+                </a:solidFill>
+              </a:rPr>
+              <a:t>Full screen</a:t>
+            </a:r>
+          </a:p>
+          <a:p>
+            <a:pPr algn="l">
+              <a:spcBef>
+                <a:spcPts val="600"/>
+              </a:spcBef>
+            </a:pPr>
+            <a:r>
+              <a:rPr sz="1700" b="0">
+                <a:solidFill>
+                  <a:srgbClr val="555B6B"/>
+                </a:solidFill>
+              </a:rPr>
+              <a:t>Hides the browser bars where allowed.</a:t>
+            </a:r>
+          </a:p>
+        </p:txBody>
+      </p:sp>
+      <p:pic>
+        <p:nvPicPr>
+          <p:cNvPr id="23" name="Picture 22" descr="split.png"/>
+          <p:cNvPicPr>
+            <a:picLocks noChangeAspect="1"/>
+          </p:cNvPicPr>
+          <p:nvPr/>
+        </p:nvPicPr>
+        <p:blipFill>
+          <a:blip r:embed="rId13"/>
+          <a:stretch>
+            <a:fillRect/>
+          </a:stretch>
+        </p:blipFill>
+        <p:spPr>
+          <a:xfrm>
+            <a:off x="6096792" y="3615228"/>
+            <a:ext cx="520000" cy="520000"/>
+          </a:xfrm>
+          <a:prstGeom prst="rect">
+            <a:avLst/>
+          </a:prstGeom>
+        </p:spPr>
+      </p:pic>
+      <p:sp>
+        <p:nvSpPr>
+          <p:cNvPr id="24" name="TextBox 23"/>
+          <p:cNvSpPr txBox="1"/>
+          <p:nvPr/>
+        </p:nvSpPr>
+        <p:spPr>
+          <a:xfrm>
+            <a:off x="7506792" y="3595228"/>
+            <a:ext cx="4215331" cy="520000"/>
+          </a:xfrm>
+          <a:prstGeom prst="rect">
+            <a:avLst/>
+          </a:prstGeom>
+          <a:noFill/>
+        </p:spPr>
+        <p:txBody>
+          <a:bodyPr wrap="square" anchor="ctr" lIns="0" rIns="0" tIns="0" bIns="0">
+            <a:spAutoFit/>
+          </a:bodyPr>
+          <a:lstStyle/>
+          <a:p>
+            <a:pPr algn="l"/>
+            <a:r>
+              <a:rPr sz="2200" b="1">
+                <a:solidFill>
+                  <a:srgbClr val="111111"/>
+                </a:solidFill>
+              </a:rPr>
+              <a:t>Same or separate views</a:t>
+            </a:r>
+          </a:p>
+          <a:p>
+            <a:pPr algn="l">
+              <a:spcBef>
+                <a:spcPts val="600"/>
+              </a:spcBef>
+            </a:pPr>
+            <a:r>
+              <a:rPr sz="1700" b="0">
+                <a:solidFill>
+                  <a:srgbClr val="555B6B"/>
+                </a:solidFill>
+              </a:rPr>
+              <a:t>One mirrored screen, or projector and lecturer.</a:t>
+            </a:r>
+          </a:p>
+        </p:txBody>
+      </p:sp>
+      <p:pic>
+        <p:nvPicPr>
+          <p:cNvPr id="25" name="Picture 24" descr="settings.png"/>
+          <p:cNvPicPr>
+            <a:picLocks noChangeAspect="1"/>
+          </p:cNvPicPr>
+          <p:nvPr/>
+        </p:nvPicPr>
+        <p:blipFill>
+          <a:blip r:embed="rId14"/>
+          <a:stretch>
+            <a:fillRect/>
+          </a:stretch>
+        </p:blipFill>
+        <p:spPr>
+          <a:xfrm>
+            <a:off x="6096792" y="4473652"/>
+            <a:ext cx="520000" cy="520000"/>
+          </a:xfrm>
+          <a:prstGeom prst="rect">
+            <a:avLst/>
+          </a:prstGeom>
+        </p:spPr>
+      </p:pic>
+      <p:sp>
+        <p:nvSpPr>
+          <p:cNvPr id="26" name="TextBox 25"/>
+          <p:cNvSpPr txBox="1"/>
+          <p:nvPr/>
+        </p:nvSpPr>
+        <p:spPr>
+          <a:xfrm>
+            <a:off x="7506792" y="4453652"/>
+            <a:ext cx="4215331" cy="520000"/>
+          </a:xfrm>
+          <a:prstGeom prst="rect">
+            <a:avLst/>
+          </a:prstGeom>
+          <a:noFill/>
+        </p:spPr>
+        <p:txBody>
+          <a:bodyPr wrap="square" anchor="ctr" lIns="0" rIns="0" tIns="0" bIns="0">
+            <a:spAutoFit/>
+          </a:bodyPr>
+          <a:lstStyle/>
+          <a:p>
+            <a:pPr algn="l"/>
+            <a:r>
+              <a:rPr sz="2200" b="1">
+                <a:solidFill>
+                  <a:srgbClr val="111111"/>
+                </a:solidFill>
+              </a:rPr>
+              <a:t>Settings</a:t>
+            </a:r>
+          </a:p>
+          <a:p>
+            <a:pPr algn="l">
+              <a:spcBef>
+                <a:spcPts val="600"/>
+              </a:spcBef>
+            </a:pPr>
+            <a:r>
+              <a:rPr sz="1700" b="0">
+                <a:solidFill>
+                  <a:srgbClr val="555B6B"/>
+                </a:solidFill>
+              </a:rPr>
+              <a:t>Colours, slide strip speed and glide.</a:t>
+            </a:r>
+          </a:p>
+        </p:txBody>
+      </p:sp>
+      <p:pic>
+        <p:nvPicPr>
+          <p:cNvPr id="27" name="Picture 26" descr="hide.png"/>
+          <p:cNvPicPr>
+            <a:picLocks noChangeAspect="1"/>
+          </p:cNvPicPr>
+          <p:nvPr/>
+        </p:nvPicPr>
+        <p:blipFill>
+          <a:blip r:embed="rId15"/>
+          <a:stretch>
+            <a:fillRect/>
+          </a:stretch>
+        </p:blipFill>
+        <p:spPr>
+          <a:xfrm>
+            <a:off x="6096792" y="5332076"/>
+            <a:ext cx="520000" cy="520000"/>
+          </a:xfrm>
+          <a:prstGeom prst="rect">
+            <a:avLst/>
+          </a:prstGeom>
+        </p:spPr>
+      </p:pic>
+      <p:sp>
+        <p:nvSpPr>
+          <p:cNvPr id="28" name="TextBox 27"/>
+          <p:cNvSpPr txBox="1"/>
+          <p:nvPr/>
+        </p:nvSpPr>
+        <p:spPr>
+          <a:xfrm>
+            <a:off x="7506792" y="5312076"/>
+            <a:ext cx="4215331" cy="520000"/>
           </a:xfrm>
           <a:prstGeom prst="rect">
             <a:avLst/>

</xml_diff>